<commit_message>
détaille dashboard et logo
</commit_message>
<xml_diff>
--- a/preprod dashboard.pptx
+++ b/preprod dashboard.pptx
@@ -6,11 +6,12 @@
   </p:sldMasterIdLst>
   <p:sldIdLst>
     <p:sldId id="256" r:id="rId2"/>
-    <p:sldId id="257" r:id="rId3"/>
-    <p:sldId id="258" r:id="rId4"/>
-    <p:sldId id="260" r:id="rId5"/>
-    <p:sldId id="261" r:id="rId6"/>
-    <p:sldId id="259" r:id="rId7"/>
+    <p:sldId id="262" r:id="rId3"/>
+    <p:sldId id="257" r:id="rId4"/>
+    <p:sldId id="258" r:id="rId5"/>
+    <p:sldId id="260" r:id="rId6"/>
+    <p:sldId id="261" r:id="rId7"/>
+    <p:sldId id="259" r:id="rId8"/>
   </p:sldIdLst>
   <p:sldSz cx="12192000" cy="6858000"/>
   <p:notesSz cx="6858000" cy="9144000"/>
@@ -115,6 +116,59 @@
     </p:ext>
   </p:extLst>
 </p:presentation>
+</file>
+
+<file path=ppt/revisionInfo.xml><?xml version="1.0" encoding="utf-8"?>
+<p1510:revInfo xmlns:a="http://schemas.openxmlformats.org/drawingml/2006/main" xmlns:r="http://schemas.openxmlformats.org/officeDocument/2006/relationships" xmlns:p1510="http://schemas.microsoft.com/office/powerpoint/2015/10/main">
+  <p1510:revLst>
+    <p1510:client id="{38990B09-FD06-43AD-8158-50DEDAC6381F}" v="3" dt="2026-09-24T13:14:36.450"/>
+  </p1510:revLst>
+</p1510:revInfo>
+</file>
+
+<file path=ppt/changesInfos/changesInfo1.xml><?xml version="1.0" encoding="utf-8"?>
+<pc:chgInfo xmlns:a="http://schemas.openxmlformats.org/drawingml/2006/main" xmlns:r="http://schemas.openxmlformats.org/officeDocument/2006/relationships" xmlns:ac="http://schemas.microsoft.com/office/drawing/2013/main/command" xmlns:pc="http://schemas.microsoft.com/office/powerpoint/2013/main/command">
+  <pc:docChgLst>
+    <pc:chgData name="Clément  Blanchard" userId="bd1f2afb-49ba-4555-ba39-f89e4473a535" providerId="ADAL" clId="{AF93E1EF-7D80-4C6F-BC21-7CFB1D2CEA6B}"/>
+    <pc:docChg chg="modSld">
+      <pc:chgData name="Clément  Blanchard" userId="bd1f2afb-49ba-4555-ba39-f89e4473a535" providerId="ADAL" clId="{AF93E1EF-7D80-4C6F-BC21-7CFB1D2CEA6B}" dt="2026-09-24T13:14:36.450" v="2" actId="767"/>
+      <pc:docMkLst>
+        <pc:docMk/>
+      </pc:docMkLst>
+      <pc:sldChg chg="addSp modSp">
+        <pc:chgData name="Clément  Blanchard" userId="bd1f2afb-49ba-4555-ba39-f89e4473a535" providerId="ADAL" clId="{AF93E1EF-7D80-4C6F-BC21-7CFB1D2CEA6B}" dt="2026-09-24T13:14:36.450" v="2" actId="767"/>
+        <pc:sldMkLst>
+          <pc:docMk/>
+          <pc:sldMk cId="2069241052" sldId="262"/>
+        </pc:sldMkLst>
+        <pc:spChg chg="add mod">
+          <ac:chgData name="Clément  Blanchard" userId="bd1f2afb-49ba-4555-ba39-f89e4473a535" providerId="ADAL" clId="{AF93E1EF-7D80-4C6F-BC21-7CFB1D2CEA6B}" dt="2026-09-24T13:13:56.573" v="1" actId="767"/>
+          <ac:spMkLst>
+            <pc:docMk/>
+            <pc:sldMk cId="2069241052" sldId="262"/>
+            <ac:spMk id="35" creationId="{92C8D36C-5193-88C5-CB4C-097AD79046A6}"/>
+          </ac:spMkLst>
+        </pc:spChg>
+        <pc:spChg chg="add mod">
+          <ac:chgData name="Clément  Blanchard" userId="bd1f2afb-49ba-4555-ba39-f89e4473a535" providerId="ADAL" clId="{AF93E1EF-7D80-4C6F-BC21-7CFB1D2CEA6B}" dt="2026-09-24T13:14:36.450" v="2" actId="767"/>
+          <ac:spMkLst>
+            <pc:docMk/>
+            <pc:sldMk cId="2069241052" sldId="262"/>
+            <ac:spMk id="36" creationId="{622A576C-D6D4-86DB-7C37-BF1BF6422B81}"/>
+          </ac:spMkLst>
+        </pc:spChg>
+        <pc:cxnChg chg="add mod">
+          <ac:chgData name="Clément  Blanchard" userId="bd1f2afb-49ba-4555-ba39-f89e4473a535" providerId="ADAL" clId="{AF93E1EF-7D80-4C6F-BC21-7CFB1D2CEA6B}" dt="2026-09-24T13:09:17.577" v="0"/>
+          <ac:cxnSpMkLst>
+            <pc:docMk/>
+            <pc:sldMk cId="2069241052" sldId="262"/>
+            <ac:cxnSpMk id="16" creationId="{3BA1234C-E05B-5F48-1A20-C8BE2B64F768}"/>
+          </ac:cxnSpMkLst>
+        </pc:cxnChg>
+      </pc:sldChg>
+    </pc:docChg>
+  </pc:docChgLst>
+</pc:chgInfo>
 </file>
 
 <file path=ppt/slideLayouts/slideLayout1.xml><?xml version="1.0" encoding="utf-8"?>
@@ -3907,7 +3961,7 @@
           <p:cNvPr id="2" name="Titre 1">
             <a:extLst>
               <a:ext uri="{FF2B5EF4-FFF2-40B4-BE49-F238E27FC236}">
-                <a16:creationId xmlns:a16="http://schemas.microsoft.com/office/drawing/2014/main" id="{D5E8CEF5-6E23-4004-9FE2-A86A1917E8E8}"/>
+                <a16:creationId xmlns:a16="http://schemas.microsoft.com/office/drawing/2014/main" id="{F751857D-F159-78B5-0D57-56902ED015CC}"/>
               </a:ext>
             </a:extLst>
           </p:cNvPr>
@@ -3923,81 +3977,1779 @@
           <a:bodyPr/>
           <a:lstStyle/>
           <a:p>
-            <a:r>
-              <a:rPr lang="fr-FR" dirty="0"/>
-              <a:t>Rajouter les </a:t>
-            </a:r>
-            <a:r>
-              <a:rPr lang="fr-FR" dirty="0" err="1"/>
-              <a:t>les</a:t>
-            </a:r>
-            <a:r>
-              <a:rPr lang="fr-FR" dirty="0"/>
-              <a:t> position de </a:t>
-            </a:r>
-            <a:r>
-              <a:rPr lang="fr-FR" dirty="0" err="1"/>
-              <a:t>novawatt</a:t>
-            </a:r>
             <a:endParaRPr lang="fr-FR" dirty="0"/>
           </a:p>
         </p:txBody>
       </p:sp>
-      <p:sp>
-        <p:nvSpPr>
-          <p:cNvPr id="3" name="Espace réservé du contenu 2">
-            <a:extLst>
-              <a:ext uri="{FF2B5EF4-FFF2-40B4-BE49-F238E27FC236}">
-                <a16:creationId xmlns:a16="http://schemas.microsoft.com/office/drawing/2014/main" id="{C1174697-3B19-B6A5-D5F8-1081D2EE0CFB}"/>
-              </a:ext>
-            </a:extLst>
-          </p:cNvPr>
-          <p:cNvSpPr>
-            <a:spLocks noGrp="1"/>
-          </p:cNvSpPr>
+      <p:pic>
+        <p:nvPicPr>
+          <p:cNvPr id="9" name="Espace réservé du contenu 8">
+            <a:extLst>
+              <a:ext uri="{FF2B5EF4-FFF2-40B4-BE49-F238E27FC236}">
+                <a16:creationId xmlns:a16="http://schemas.microsoft.com/office/drawing/2014/main" id="{666B687C-00A8-2D91-F281-BF5EEF9A47F1}"/>
+              </a:ext>
+            </a:extLst>
+          </p:cNvPr>
+          <p:cNvPicPr>
+            <a:picLocks noGrp="1" noChangeAspect="1"/>
+          </p:cNvPicPr>
           <p:nvPr>
             <p:ph idx="1"/>
           </p:nvPr>
-        </p:nvSpPr>
-        <p:spPr/>
-        <p:txBody>
-          <a:bodyPr/>
-          <a:lstStyle/>
-          <a:p>
+        </p:nvPicPr>
+        <p:blipFill>
+          <a:blip r:embed="rId2"/>
+          <a:srcRect t="10361"/>
+          <a:stretch>
+            <a:fillRect/>
+          </a:stretch>
+        </p:blipFill>
+        <p:spPr>
+          <a:xfrm>
+            <a:off x="-79788" y="488051"/>
+            <a:ext cx="12351575" cy="5881897"/>
+          </a:xfrm>
+          <a:prstGeom prst="rect">
+            <a:avLst/>
+          </a:prstGeom>
+          <a:ln>
+            <a:solidFill>
+              <a:srgbClr val="FF0000"/>
+            </a:solidFill>
+          </a:ln>
+        </p:spPr>
+      </p:pic>
+      <p:sp>
+        <p:nvSpPr>
+          <p:cNvPr id="10" name="Rectangle 9">
+            <a:extLst>
+              <a:ext uri="{FF2B5EF4-FFF2-40B4-BE49-F238E27FC236}">
+                <a16:creationId xmlns:a16="http://schemas.microsoft.com/office/drawing/2014/main" id="{2D86FA70-8B6B-3E1F-A01B-52BAB2536515}"/>
+              </a:ext>
+            </a:extLst>
+          </p:cNvPr>
+          <p:cNvSpPr/>
+          <p:nvPr/>
+        </p:nvSpPr>
+        <p:spPr>
+          <a:xfrm>
+            <a:off x="10210800" y="365125"/>
+            <a:ext cx="1905000" cy="720725"/>
+          </a:xfrm>
+          <a:prstGeom prst="rect">
+            <a:avLst/>
+          </a:prstGeom>
+        </p:spPr>
+        <p:style>
+          <a:lnRef idx="2">
+            <a:schemeClr val="accent1">
+              <a:shade val="15000"/>
+            </a:schemeClr>
+          </a:lnRef>
+          <a:fillRef idx="1">
+            <a:schemeClr val="accent1"/>
+          </a:fillRef>
+          <a:effectRef idx="0">
+            <a:schemeClr val="accent1"/>
+          </a:effectRef>
+          <a:fontRef idx="minor">
+            <a:schemeClr val="lt1"/>
+          </a:fontRef>
+        </p:style>
+        <p:txBody>
+          <a:bodyPr rtlCol="0" anchor="ctr"/>
+          <a:lstStyle/>
+          <a:p>
+            <a:pPr algn="ctr"/>
+            <a:r>
+              <a:rPr lang="fr-FR" dirty="0"/>
+              <a:t>Mettre ici le logo de </a:t>
+            </a:r>
             <a:r>
               <a:rPr lang="fr-FR" dirty="0" err="1"/>
-              <a:t>Carouselle</a:t>
-            </a:r>
-            <a:r>
-              <a:rPr lang="fr-FR" dirty="0"/>
-              <a:t> sur la </a:t>
-            </a:r>
+              <a:t>novawatt</a:t>
+            </a:r>
+            <a:endParaRPr lang="fr-FR" dirty="0"/>
+          </a:p>
+        </p:txBody>
+      </p:sp>
+      <p:sp>
+        <p:nvSpPr>
+          <p:cNvPr id="11" name="Rectangle 10">
+            <a:extLst>
+              <a:ext uri="{FF2B5EF4-FFF2-40B4-BE49-F238E27FC236}">
+                <a16:creationId xmlns:a16="http://schemas.microsoft.com/office/drawing/2014/main" id="{12C7354E-4FFC-9552-C22B-B02519BD3171}"/>
+              </a:ext>
+            </a:extLst>
+          </p:cNvPr>
+          <p:cNvSpPr/>
+          <p:nvPr/>
+        </p:nvSpPr>
+        <p:spPr>
+          <a:xfrm>
+            <a:off x="1234440" y="1143476"/>
+            <a:ext cx="3886200" cy="364808"/>
+          </a:xfrm>
+          <a:prstGeom prst="rect">
+            <a:avLst/>
+          </a:prstGeom>
+        </p:spPr>
+        <p:style>
+          <a:lnRef idx="2">
+            <a:schemeClr val="accent1">
+              <a:shade val="15000"/>
+            </a:schemeClr>
+          </a:lnRef>
+          <a:fillRef idx="1">
+            <a:schemeClr val="accent1"/>
+          </a:fillRef>
+          <a:effectRef idx="0">
+            <a:schemeClr val="accent1"/>
+          </a:effectRef>
+          <a:fontRef idx="minor">
+            <a:schemeClr val="lt1"/>
+          </a:fontRef>
+        </p:style>
+        <p:txBody>
+          <a:bodyPr rtlCol="0" anchor="ctr"/>
+          <a:lstStyle/>
+          <a:p>
+            <a:pPr algn="ctr"/>
             <a:r>
               <a:rPr lang="fr-FR" dirty="0" err="1"/>
-              <a:t>téle</a:t>
-            </a:r>
-            <a:endParaRPr lang="fr-FR" dirty="0"/>
-          </a:p>
-          <a:p>
-            <a:endParaRPr lang="fr-FR" dirty="0"/>
-          </a:p>
-          <a:p>
-            <a:r>
-              <a:rPr lang="fr-FR" dirty="0"/>
-              <a:t>Disponibilité du nucléaire et </a:t>
+              <a:t>Metre</a:t>
+            </a:r>
+            <a:r>
+              <a:rPr lang="fr-FR" dirty="0"/>
+              <a:t> la date et l’heure en </a:t>
             </a:r>
             <a:r>
               <a:rPr lang="fr-FR" dirty="0" err="1"/>
-              <a:t>ccg</a:t>
-            </a:r>
-            <a:endParaRPr lang="fr-FR" dirty="0"/>
+              <a:t>gand</a:t>
+            </a:r>
+            <a:r>
+              <a:rPr lang="fr-FR" dirty="0"/>
+              <a:t> ici</a:t>
+            </a:r>
+          </a:p>
+        </p:txBody>
+      </p:sp>
+      <p:sp>
+        <p:nvSpPr>
+          <p:cNvPr id="12" name="Rectangle 11">
+            <a:extLst>
+              <a:ext uri="{FF2B5EF4-FFF2-40B4-BE49-F238E27FC236}">
+                <a16:creationId xmlns:a16="http://schemas.microsoft.com/office/drawing/2014/main" id="{2906C00E-56CB-356E-1268-0AB458BCB26C}"/>
+              </a:ext>
+            </a:extLst>
+          </p:cNvPr>
+          <p:cNvSpPr/>
+          <p:nvPr/>
+        </p:nvSpPr>
+        <p:spPr>
+          <a:xfrm>
+            <a:off x="73152" y="488051"/>
+            <a:ext cx="5605272" cy="364808"/>
+          </a:xfrm>
+          <a:prstGeom prst="rect">
+            <a:avLst/>
+          </a:prstGeom>
+        </p:spPr>
+        <p:style>
+          <a:lnRef idx="2">
+            <a:schemeClr val="accent1">
+              <a:shade val="15000"/>
+            </a:schemeClr>
+          </a:lnRef>
+          <a:fillRef idx="1">
+            <a:schemeClr val="accent1"/>
+          </a:fillRef>
+          <a:effectRef idx="0">
+            <a:schemeClr val="accent1"/>
+          </a:effectRef>
+          <a:fontRef idx="minor">
+            <a:schemeClr val="lt1"/>
+          </a:fontRef>
+        </p:style>
+        <p:txBody>
+          <a:bodyPr rtlCol="0" anchor="ctr"/>
+          <a:lstStyle/>
+          <a:p>
+            <a:pPr algn="ctr"/>
+            <a:r>
+              <a:rPr lang="fr-FR" dirty="0"/>
+              <a:t>Nouveau titre: « Dashboard BESS</a:t>
+            </a:r>
+          </a:p>
+        </p:txBody>
+      </p:sp>
+      <p:sp>
+        <p:nvSpPr>
+          <p:cNvPr id="13" name="Rectangle 12">
+            <a:extLst>
+              <a:ext uri="{FF2B5EF4-FFF2-40B4-BE49-F238E27FC236}">
+                <a16:creationId xmlns:a16="http://schemas.microsoft.com/office/drawing/2014/main" id="{70903A63-B85F-3DFB-256F-2159D84DB1A0}"/>
+              </a:ext>
+            </a:extLst>
+          </p:cNvPr>
+          <p:cNvSpPr/>
+          <p:nvPr/>
+        </p:nvSpPr>
+        <p:spPr>
+          <a:xfrm>
+            <a:off x="10844784" y="1686783"/>
+            <a:ext cx="1562100" cy="612648"/>
+          </a:xfrm>
+          <a:prstGeom prst="rect">
+            <a:avLst/>
+          </a:prstGeom>
+        </p:spPr>
+        <p:style>
+          <a:lnRef idx="2">
+            <a:schemeClr val="accent1">
+              <a:shade val="15000"/>
+            </a:schemeClr>
+          </a:lnRef>
+          <a:fillRef idx="1">
+            <a:schemeClr val="accent1"/>
+          </a:fillRef>
+          <a:effectRef idx="0">
+            <a:schemeClr val="accent1"/>
+          </a:effectRef>
+          <a:fontRef idx="minor">
+            <a:schemeClr val="lt1"/>
+          </a:fontRef>
+        </p:style>
+        <p:txBody>
+          <a:bodyPr rtlCol="0" anchor="ctr"/>
+          <a:lstStyle/>
+          <a:p>
+            <a:pPr algn="ctr"/>
+            <a:r>
+              <a:rPr lang="fr-FR" dirty="0"/>
+              <a:t>Plus visible</a:t>
+            </a:r>
+          </a:p>
+        </p:txBody>
+      </p:sp>
+      <p:cxnSp>
+        <p:nvCxnSpPr>
+          <p:cNvPr id="15" name="Connecteur droit avec flèche 14">
+            <a:extLst>
+              <a:ext uri="{FF2B5EF4-FFF2-40B4-BE49-F238E27FC236}">
+                <a16:creationId xmlns:a16="http://schemas.microsoft.com/office/drawing/2014/main" id="{BFD5DE1E-8DF8-39C8-ADDE-C1CAF97A5F35}"/>
+              </a:ext>
+            </a:extLst>
+          </p:cNvPr>
+          <p:cNvCxnSpPr/>
+          <p:nvPr/>
+        </p:nvCxnSpPr>
+        <p:spPr>
+          <a:xfrm flipH="1" flipV="1">
+            <a:off x="9564624" y="1353312"/>
+            <a:ext cx="1252728" cy="337376"/>
+          </a:xfrm>
+          <a:prstGeom prst="straightConnector1">
+            <a:avLst/>
+          </a:prstGeom>
+          <a:ln>
+            <a:tailEnd type="triangle"/>
+          </a:ln>
+        </p:spPr>
+        <p:style>
+          <a:lnRef idx="2">
+            <a:schemeClr val="accent5"/>
+          </a:lnRef>
+          <a:fillRef idx="0">
+            <a:schemeClr val="accent5"/>
+          </a:fillRef>
+          <a:effectRef idx="1">
+            <a:schemeClr val="accent5"/>
+          </a:effectRef>
+          <a:fontRef idx="minor">
+            <a:schemeClr val="tx1"/>
+          </a:fontRef>
+        </p:style>
+      </p:cxnSp>
+      <p:cxnSp>
+        <p:nvCxnSpPr>
+          <p:cNvPr id="16" name="Connecteur droit avec flèche 15">
+            <a:extLst>
+              <a:ext uri="{FF2B5EF4-FFF2-40B4-BE49-F238E27FC236}">
+                <a16:creationId xmlns:a16="http://schemas.microsoft.com/office/drawing/2014/main" id="{3BA1234C-E05B-5F48-1A20-C8BE2B64F768}"/>
+              </a:ext>
+            </a:extLst>
+          </p:cNvPr>
+          <p:cNvCxnSpPr>
+            <a:cxnSpLocks/>
+          </p:cNvCxnSpPr>
+          <p:nvPr/>
+        </p:nvCxnSpPr>
+        <p:spPr>
+          <a:xfrm flipH="1">
+            <a:off x="9921240" y="2275143"/>
+            <a:ext cx="915924" cy="102297"/>
+          </a:xfrm>
+          <a:prstGeom prst="straightConnector1">
+            <a:avLst/>
+          </a:prstGeom>
+          <a:ln>
+            <a:tailEnd type="triangle"/>
+          </a:ln>
+        </p:spPr>
+        <p:style>
+          <a:lnRef idx="2">
+            <a:schemeClr val="accent5"/>
+          </a:lnRef>
+          <a:fillRef idx="0">
+            <a:schemeClr val="accent5"/>
+          </a:fillRef>
+          <a:effectRef idx="1">
+            <a:schemeClr val="accent5"/>
+          </a:effectRef>
+          <a:fontRef idx="minor">
+            <a:schemeClr val="tx1"/>
+          </a:fontRef>
+        </p:style>
+      </p:cxnSp>
+      <p:sp>
+        <p:nvSpPr>
+          <p:cNvPr id="18" name="Forme libre : forme 17">
+            <a:extLst>
+              <a:ext uri="{FF2B5EF4-FFF2-40B4-BE49-F238E27FC236}">
+                <a16:creationId xmlns:a16="http://schemas.microsoft.com/office/drawing/2014/main" id="{BDEF2358-1D10-9D4C-7A59-3C7B3EB8D737}"/>
+              </a:ext>
+            </a:extLst>
+          </p:cNvPr>
+          <p:cNvSpPr/>
+          <p:nvPr/>
+        </p:nvSpPr>
+        <p:spPr>
+          <a:xfrm>
+            <a:off x="9180576" y="3182112"/>
+            <a:ext cx="859536" cy="36650"/>
+          </a:xfrm>
+          <a:custGeom>
+            <a:avLst/>
+            <a:gdLst>
+              <a:gd name="csX0" fmla="*/ 0 w 859536"/>
+              <a:gd name="csY0" fmla="*/ 27432 h 36650"/>
+              <a:gd name="csX1" fmla="*/ 539496 w 859536"/>
+              <a:gd name="csY1" fmla="*/ 18288 h 36650"/>
+              <a:gd name="csX2" fmla="*/ 658368 w 859536"/>
+              <a:gd name="csY2" fmla="*/ 0 h 36650"/>
+              <a:gd name="csX3" fmla="*/ 749808 w 859536"/>
+              <a:gd name="csY3" fmla="*/ 9144 h 36650"/>
+              <a:gd name="csX4" fmla="*/ 859536 w 859536"/>
+              <a:gd name="csY4" fmla="*/ 36576 h 36650"/>
+            </a:gdLst>
+            <a:ahLst/>
+            <a:cxnLst>
+              <a:cxn ang="0">
+                <a:pos x="csX0" y="csY0"/>
+              </a:cxn>
+              <a:cxn ang="0">
+                <a:pos x="csX1" y="csY1"/>
+              </a:cxn>
+              <a:cxn ang="0">
+                <a:pos x="csX2" y="csY2"/>
+              </a:cxn>
+              <a:cxn ang="0">
+                <a:pos x="csX3" y="csY3"/>
+              </a:cxn>
+              <a:cxn ang="0">
+                <a:pos x="csX4" y="csY4"/>
+              </a:cxn>
+            </a:cxnLst>
+            <a:rect l="l" t="t" r="r" b="b"/>
+            <a:pathLst>
+              <a:path w="859536" h="36650">
+                <a:moveTo>
+                  <a:pt x="0" y="27432"/>
+                </a:moveTo>
+                <a:lnTo>
+                  <a:pt x="539496" y="18288"/>
+                </a:lnTo>
+                <a:cubicBezTo>
+                  <a:pt x="553877" y="17852"/>
+                  <a:pt x="640724" y="2941"/>
+                  <a:pt x="658368" y="0"/>
+                </a:cubicBezTo>
+                <a:cubicBezTo>
+                  <a:pt x="688848" y="3048"/>
+                  <a:pt x="719833" y="2833"/>
+                  <a:pt x="749808" y="9144"/>
+                </a:cubicBezTo>
+                <a:cubicBezTo>
+                  <a:pt x="893845" y="39468"/>
+                  <a:pt x="786407" y="36576"/>
+                  <a:pt x="859536" y="36576"/>
+                </a:cubicBezTo>
+              </a:path>
+            </a:pathLst>
+          </a:custGeom>
+          <a:noFill/>
+          <a:ln>
+            <a:solidFill>
+              <a:srgbClr val="FF0000"/>
+            </a:solidFill>
+          </a:ln>
+        </p:spPr>
+        <p:style>
+          <a:lnRef idx="2">
+            <a:schemeClr val="accent1">
+              <a:shade val="15000"/>
+            </a:schemeClr>
+          </a:lnRef>
+          <a:fillRef idx="1">
+            <a:schemeClr val="accent1"/>
+          </a:fillRef>
+          <a:effectRef idx="0">
+            <a:schemeClr val="accent1"/>
+          </a:effectRef>
+          <a:fontRef idx="minor">
+            <a:schemeClr val="lt1"/>
+          </a:fontRef>
+        </p:style>
+        <p:txBody>
+          <a:bodyPr rtlCol="0" anchor="ctr"/>
+          <a:lstStyle/>
+          <a:p>
+            <a:pPr algn="ctr"/>
+            <a:endParaRPr lang="fr-FR"/>
+          </a:p>
+        </p:txBody>
+      </p:sp>
+      <p:sp>
+        <p:nvSpPr>
+          <p:cNvPr id="19" name="Forme libre : forme 18">
+            <a:extLst>
+              <a:ext uri="{FF2B5EF4-FFF2-40B4-BE49-F238E27FC236}">
+                <a16:creationId xmlns:a16="http://schemas.microsoft.com/office/drawing/2014/main" id="{36354F5E-3F07-FB9F-CB1F-347D4635408E}"/>
+              </a:ext>
+            </a:extLst>
+          </p:cNvPr>
+          <p:cNvSpPr/>
+          <p:nvPr/>
+        </p:nvSpPr>
+        <p:spPr>
+          <a:xfrm>
+            <a:off x="8951976" y="3346353"/>
+            <a:ext cx="475488" cy="55215"/>
+          </a:xfrm>
+          <a:custGeom>
+            <a:avLst/>
+            <a:gdLst>
+              <a:gd name="csX0" fmla="*/ 0 w 475488"/>
+              <a:gd name="csY0" fmla="*/ 55215 h 55215"/>
+              <a:gd name="csX1" fmla="*/ 429768 w 475488"/>
+              <a:gd name="csY1" fmla="*/ 9495 h 55215"/>
+              <a:gd name="csX2" fmla="*/ 475488 w 475488"/>
+              <a:gd name="csY2" fmla="*/ 27783 h 55215"/>
+            </a:gdLst>
+            <a:ahLst/>
+            <a:cxnLst>
+              <a:cxn ang="0">
+                <a:pos x="csX0" y="csY0"/>
+              </a:cxn>
+              <a:cxn ang="0">
+                <a:pos x="csX1" y="csY1"/>
+              </a:cxn>
+              <a:cxn ang="0">
+                <a:pos x="csX2" y="csY2"/>
+              </a:cxn>
+            </a:cxnLst>
+            <a:rect l="l" t="t" r="r" b="b"/>
+            <a:pathLst>
+              <a:path w="475488" h="55215">
+                <a:moveTo>
+                  <a:pt x="0" y="55215"/>
+                </a:moveTo>
+                <a:cubicBezTo>
+                  <a:pt x="203953" y="18133"/>
+                  <a:pt x="258317" y="-17576"/>
+                  <a:pt x="429768" y="9495"/>
+                </a:cubicBezTo>
+                <a:cubicBezTo>
+                  <a:pt x="445981" y="12055"/>
+                  <a:pt x="460248" y="21687"/>
+                  <a:pt x="475488" y="27783"/>
+                </a:cubicBezTo>
+              </a:path>
+            </a:pathLst>
+          </a:custGeom>
+          <a:noFill/>
+          <a:ln>
+            <a:solidFill>
+              <a:srgbClr val="FF0000"/>
+            </a:solidFill>
+          </a:ln>
+        </p:spPr>
+        <p:style>
+          <a:lnRef idx="2">
+            <a:schemeClr val="accent1">
+              <a:shade val="15000"/>
+            </a:schemeClr>
+          </a:lnRef>
+          <a:fillRef idx="1">
+            <a:schemeClr val="accent1"/>
+          </a:fillRef>
+          <a:effectRef idx="0">
+            <a:schemeClr val="accent1"/>
+          </a:effectRef>
+          <a:fontRef idx="minor">
+            <a:schemeClr val="lt1"/>
+          </a:fontRef>
+        </p:style>
+        <p:txBody>
+          <a:bodyPr rtlCol="0" anchor="ctr"/>
+          <a:lstStyle/>
+          <a:p>
+            <a:pPr algn="ctr"/>
+            <a:endParaRPr lang="fr-FR"/>
+          </a:p>
+        </p:txBody>
+      </p:sp>
+      <p:sp>
+        <p:nvSpPr>
+          <p:cNvPr id="20" name="Forme libre : forme 19">
+            <a:extLst>
+              <a:ext uri="{FF2B5EF4-FFF2-40B4-BE49-F238E27FC236}">
+                <a16:creationId xmlns:a16="http://schemas.microsoft.com/office/drawing/2014/main" id="{3C19720F-D588-0B5F-233B-701CE3564B0F}"/>
+              </a:ext>
+            </a:extLst>
+          </p:cNvPr>
+          <p:cNvSpPr/>
+          <p:nvPr/>
+        </p:nvSpPr>
+        <p:spPr>
+          <a:xfrm>
+            <a:off x="228600" y="5413248"/>
+            <a:ext cx="2717175" cy="320147"/>
+          </a:xfrm>
+          <a:custGeom>
+            <a:avLst/>
+            <a:gdLst>
+              <a:gd name="csX0" fmla="*/ 0 w 2717175"/>
+              <a:gd name="csY0" fmla="*/ 109728 h 320147"/>
+              <a:gd name="csX1" fmla="*/ 301752 w 2717175"/>
+              <a:gd name="csY1" fmla="*/ 100584 h 320147"/>
+              <a:gd name="csX2" fmla="*/ 429768 w 2717175"/>
+              <a:gd name="csY2" fmla="*/ 73152 h 320147"/>
+              <a:gd name="csX3" fmla="*/ 557784 w 2717175"/>
+              <a:gd name="csY3" fmla="*/ 64008 h 320147"/>
+              <a:gd name="csX4" fmla="*/ 1115568 w 2717175"/>
+              <a:gd name="csY4" fmla="*/ 82296 h 320147"/>
+              <a:gd name="csX5" fmla="*/ 1463040 w 2717175"/>
+              <a:gd name="csY5" fmla="*/ 137160 h 320147"/>
+              <a:gd name="csX6" fmla="*/ 1682496 w 2717175"/>
+              <a:gd name="csY6" fmla="*/ 164592 h 320147"/>
+              <a:gd name="csX7" fmla="*/ 1956816 w 2717175"/>
+              <a:gd name="csY7" fmla="*/ 201168 h 320147"/>
+              <a:gd name="csX8" fmla="*/ 2386584 w 2717175"/>
+              <a:gd name="csY8" fmla="*/ 173736 h 320147"/>
+              <a:gd name="csX9" fmla="*/ 2642616 w 2717175"/>
+              <a:gd name="csY9" fmla="*/ 118872 h 320147"/>
+              <a:gd name="csX10" fmla="*/ 2688336 w 2717175"/>
+              <a:gd name="csY10" fmla="*/ 82296 h 320147"/>
+              <a:gd name="csX11" fmla="*/ 2697480 w 2717175"/>
+              <a:gd name="csY11" fmla="*/ 27432 h 320147"/>
+              <a:gd name="csX12" fmla="*/ 2606040 w 2717175"/>
+              <a:gd name="csY12" fmla="*/ 0 h 320147"/>
+              <a:gd name="csX13" fmla="*/ 2240280 w 2717175"/>
+              <a:gd name="csY13" fmla="*/ 9144 h 320147"/>
+              <a:gd name="csX14" fmla="*/ 1563624 w 2717175"/>
+              <a:gd name="csY14" fmla="*/ 27432 h 320147"/>
+              <a:gd name="csX15" fmla="*/ 1463040 w 2717175"/>
+              <a:gd name="csY15" fmla="*/ 45720 h 320147"/>
+              <a:gd name="csX16" fmla="*/ 1289304 w 2717175"/>
+              <a:gd name="csY16" fmla="*/ 91440 h 320147"/>
+              <a:gd name="csX17" fmla="*/ 1179576 w 2717175"/>
+              <a:gd name="csY17" fmla="*/ 109728 h 320147"/>
+              <a:gd name="csX18" fmla="*/ 1042416 w 2717175"/>
+              <a:gd name="csY18" fmla="*/ 155448 h 320147"/>
+              <a:gd name="csX19" fmla="*/ 868680 w 2717175"/>
+              <a:gd name="csY19" fmla="*/ 192024 h 320147"/>
+              <a:gd name="csX20" fmla="*/ 786384 w 2717175"/>
+              <a:gd name="csY20" fmla="*/ 210312 h 320147"/>
+              <a:gd name="csX21" fmla="*/ 429768 w 2717175"/>
+              <a:gd name="csY21" fmla="*/ 192024 h 320147"/>
+              <a:gd name="csX22" fmla="*/ 265176 w 2717175"/>
+              <a:gd name="csY22" fmla="*/ 164592 h 320147"/>
+              <a:gd name="csX23" fmla="*/ 45720 w 2717175"/>
+              <a:gd name="csY23" fmla="*/ 146304 h 320147"/>
+              <a:gd name="csX24" fmla="*/ 36576 w 2717175"/>
+              <a:gd name="csY24" fmla="*/ 109728 h 320147"/>
+              <a:gd name="csX25" fmla="*/ 173736 w 2717175"/>
+              <a:gd name="csY25" fmla="*/ 73152 h 320147"/>
+              <a:gd name="csX26" fmla="*/ 347472 w 2717175"/>
+              <a:gd name="csY26" fmla="*/ 91440 h 320147"/>
+              <a:gd name="csX27" fmla="*/ 630936 w 2717175"/>
+              <a:gd name="csY27" fmla="*/ 192024 h 320147"/>
+              <a:gd name="csX28" fmla="*/ 914400 w 2717175"/>
+              <a:gd name="csY28" fmla="*/ 256032 h 320147"/>
+              <a:gd name="csX29" fmla="*/ 1124712 w 2717175"/>
+              <a:gd name="csY29" fmla="*/ 320040 h 320147"/>
+              <a:gd name="csX30" fmla="*/ 1280160 w 2717175"/>
+              <a:gd name="csY30" fmla="*/ 283464 h 320147"/>
+              <a:gd name="csX31" fmla="*/ 1344168 w 2717175"/>
+              <a:gd name="csY31" fmla="*/ 237744 h 320147"/>
+              <a:gd name="csX32" fmla="*/ 1417320 w 2717175"/>
+              <a:gd name="csY32" fmla="*/ 192024 h 320147"/>
+              <a:gd name="csX33" fmla="*/ 1581912 w 2717175"/>
+              <a:gd name="csY33" fmla="*/ 91440 h 320147"/>
+              <a:gd name="csX34" fmla="*/ 1655064 w 2717175"/>
+              <a:gd name="csY34" fmla="*/ 82296 h 320147"/>
+              <a:gd name="csX35" fmla="*/ 1691640 w 2717175"/>
+              <a:gd name="csY35" fmla="*/ 128016 h 320147"/>
+              <a:gd name="csX36" fmla="*/ 1901952 w 2717175"/>
+              <a:gd name="csY36" fmla="*/ 164592 h 320147"/>
+              <a:gd name="csX37" fmla="*/ 2231136 w 2717175"/>
+              <a:gd name="csY37" fmla="*/ 82296 h 320147"/>
+              <a:gd name="csX38" fmla="*/ 2459736 w 2717175"/>
+              <a:gd name="csY38" fmla="*/ 64008 h 320147"/>
+              <a:gd name="csX39" fmla="*/ 2496312 w 2717175"/>
+              <a:gd name="csY39" fmla="*/ 100584 h 320147"/>
+              <a:gd name="csX40" fmla="*/ 2514600 w 2717175"/>
+              <a:gd name="csY40" fmla="*/ 155448 h 320147"/>
+            </a:gdLst>
+            <a:ahLst/>
+            <a:cxnLst>
+              <a:cxn ang="0">
+                <a:pos x="csX0" y="csY0"/>
+              </a:cxn>
+              <a:cxn ang="0">
+                <a:pos x="csX1" y="csY1"/>
+              </a:cxn>
+              <a:cxn ang="0">
+                <a:pos x="csX2" y="csY2"/>
+              </a:cxn>
+              <a:cxn ang="0">
+                <a:pos x="csX3" y="csY3"/>
+              </a:cxn>
+              <a:cxn ang="0">
+                <a:pos x="csX4" y="csY4"/>
+              </a:cxn>
+              <a:cxn ang="0">
+                <a:pos x="csX5" y="csY5"/>
+              </a:cxn>
+              <a:cxn ang="0">
+                <a:pos x="csX6" y="csY6"/>
+              </a:cxn>
+              <a:cxn ang="0">
+                <a:pos x="csX7" y="csY7"/>
+              </a:cxn>
+              <a:cxn ang="0">
+                <a:pos x="csX8" y="csY8"/>
+              </a:cxn>
+              <a:cxn ang="0">
+                <a:pos x="csX9" y="csY9"/>
+              </a:cxn>
+              <a:cxn ang="0">
+                <a:pos x="csX10" y="csY10"/>
+              </a:cxn>
+              <a:cxn ang="0">
+                <a:pos x="csX11" y="csY11"/>
+              </a:cxn>
+              <a:cxn ang="0">
+                <a:pos x="csX12" y="csY12"/>
+              </a:cxn>
+              <a:cxn ang="0">
+                <a:pos x="csX13" y="csY13"/>
+              </a:cxn>
+              <a:cxn ang="0">
+                <a:pos x="csX14" y="csY14"/>
+              </a:cxn>
+              <a:cxn ang="0">
+                <a:pos x="csX15" y="csY15"/>
+              </a:cxn>
+              <a:cxn ang="0">
+                <a:pos x="csX16" y="csY16"/>
+              </a:cxn>
+              <a:cxn ang="0">
+                <a:pos x="csX17" y="csY17"/>
+              </a:cxn>
+              <a:cxn ang="0">
+                <a:pos x="csX18" y="csY18"/>
+              </a:cxn>
+              <a:cxn ang="0">
+                <a:pos x="csX19" y="csY19"/>
+              </a:cxn>
+              <a:cxn ang="0">
+                <a:pos x="csX20" y="csY20"/>
+              </a:cxn>
+              <a:cxn ang="0">
+                <a:pos x="csX21" y="csY21"/>
+              </a:cxn>
+              <a:cxn ang="0">
+                <a:pos x="csX22" y="csY22"/>
+              </a:cxn>
+              <a:cxn ang="0">
+                <a:pos x="csX23" y="csY23"/>
+              </a:cxn>
+              <a:cxn ang="0">
+                <a:pos x="csX24" y="csY24"/>
+              </a:cxn>
+              <a:cxn ang="0">
+                <a:pos x="csX25" y="csY25"/>
+              </a:cxn>
+              <a:cxn ang="0">
+                <a:pos x="csX26" y="csY26"/>
+              </a:cxn>
+              <a:cxn ang="0">
+                <a:pos x="csX27" y="csY27"/>
+              </a:cxn>
+              <a:cxn ang="0">
+                <a:pos x="csX28" y="csY28"/>
+              </a:cxn>
+              <a:cxn ang="0">
+                <a:pos x="csX29" y="csY29"/>
+              </a:cxn>
+              <a:cxn ang="0">
+                <a:pos x="csX30" y="csY30"/>
+              </a:cxn>
+              <a:cxn ang="0">
+                <a:pos x="csX31" y="csY31"/>
+              </a:cxn>
+              <a:cxn ang="0">
+                <a:pos x="csX32" y="csY32"/>
+              </a:cxn>
+              <a:cxn ang="0">
+                <a:pos x="csX33" y="csY33"/>
+              </a:cxn>
+              <a:cxn ang="0">
+                <a:pos x="csX34" y="csY34"/>
+              </a:cxn>
+              <a:cxn ang="0">
+                <a:pos x="csX35" y="csY35"/>
+              </a:cxn>
+              <a:cxn ang="0">
+                <a:pos x="csX36" y="csY36"/>
+              </a:cxn>
+              <a:cxn ang="0">
+                <a:pos x="csX37" y="csY37"/>
+              </a:cxn>
+              <a:cxn ang="0">
+                <a:pos x="csX38" y="csY38"/>
+              </a:cxn>
+              <a:cxn ang="0">
+                <a:pos x="csX39" y="csY39"/>
+              </a:cxn>
+              <a:cxn ang="0">
+                <a:pos x="csX40" y="csY40"/>
+              </a:cxn>
+            </a:cxnLst>
+            <a:rect l="l" t="t" r="r" b="b"/>
+            <a:pathLst>
+              <a:path w="2717175" h="320147">
+                <a:moveTo>
+                  <a:pt x="0" y="109728"/>
+                </a:moveTo>
+                <a:cubicBezTo>
+                  <a:pt x="100584" y="106680"/>
+                  <a:pt x="201484" y="109117"/>
+                  <a:pt x="301752" y="100584"/>
+                </a:cubicBezTo>
+                <a:cubicBezTo>
+                  <a:pt x="345236" y="96883"/>
+                  <a:pt x="386566" y="79324"/>
+                  <a:pt x="429768" y="73152"/>
+                </a:cubicBezTo>
+                <a:cubicBezTo>
+                  <a:pt x="472119" y="67102"/>
+                  <a:pt x="515112" y="67056"/>
+                  <a:pt x="557784" y="64008"/>
+                </a:cubicBezTo>
+                <a:cubicBezTo>
+                  <a:pt x="743712" y="70104"/>
+                  <a:pt x="930145" y="67312"/>
+                  <a:pt x="1115568" y="82296"/>
+                </a:cubicBezTo>
+                <a:cubicBezTo>
+                  <a:pt x="1232446" y="91741"/>
+                  <a:pt x="1346997" y="120315"/>
+                  <a:pt x="1463040" y="137160"/>
+                </a:cubicBezTo>
+                <a:cubicBezTo>
+                  <a:pt x="1535997" y="147750"/>
+                  <a:pt x="1609516" y="154166"/>
+                  <a:pt x="1682496" y="164592"/>
+                </a:cubicBezTo>
+                <a:cubicBezTo>
+                  <a:pt x="1963610" y="204751"/>
+                  <a:pt x="1738659" y="182988"/>
+                  <a:pt x="1956816" y="201168"/>
+                </a:cubicBezTo>
+                <a:cubicBezTo>
+                  <a:pt x="2100072" y="192024"/>
+                  <a:pt x="2243791" y="188435"/>
+                  <a:pt x="2386584" y="173736"/>
+                </a:cubicBezTo>
+                <a:cubicBezTo>
+                  <a:pt x="2498001" y="162267"/>
+                  <a:pt x="2550830" y="145097"/>
+                  <a:pt x="2642616" y="118872"/>
+                </a:cubicBezTo>
+                <a:cubicBezTo>
+                  <a:pt x="2657856" y="106680"/>
+                  <a:pt x="2673648" y="95148"/>
+                  <a:pt x="2688336" y="82296"/>
+                </a:cubicBezTo>
+                <a:cubicBezTo>
+                  <a:pt x="2704950" y="67759"/>
+                  <a:pt x="2738739" y="48061"/>
+                  <a:pt x="2697480" y="27432"/>
+                </a:cubicBezTo>
+                <a:cubicBezTo>
+                  <a:pt x="2669017" y="13201"/>
+                  <a:pt x="2636520" y="9144"/>
+                  <a:pt x="2606040" y="0"/>
+                </a:cubicBezTo>
+                <a:lnTo>
+                  <a:pt x="2240280" y="9144"/>
+                </a:lnTo>
+                <a:cubicBezTo>
+                  <a:pt x="1640289" y="22187"/>
+                  <a:pt x="1947455" y="9985"/>
+                  <a:pt x="1563624" y="27432"/>
+                </a:cubicBezTo>
+                <a:cubicBezTo>
+                  <a:pt x="1530096" y="33528"/>
+                  <a:pt x="1496226" y="37977"/>
+                  <a:pt x="1463040" y="45720"/>
+                </a:cubicBezTo>
+                <a:cubicBezTo>
+                  <a:pt x="1404723" y="59327"/>
+                  <a:pt x="1348373" y="81595"/>
+                  <a:pt x="1289304" y="91440"/>
+                </a:cubicBezTo>
+                <a:cubicBezTo>
+                  <a:pt x="1252728" y="97536"/>
+                  <a:pt x="1215861" y="102089"/>
+                  <a:pt x="1179576" y="109728"/>
+                </a:cubicBezTo>
+                <a:cubicBezTo>
+                  <a:pt x="1037835" y="139568"/>
+                  <a:pt x="1198186" y="115063"/>
+                  <a:pt x="1042416" y="155448"/>
+                </a:cubicBezTo>
+                <a:cubicBezTo>
+                  <a:pt x="985129" y="170300"/>
+                  <a:pt x="926452" y="179186"/>
+                  <a:pt x="868680" y="192024"/>
+                </a:cubicBezTo>
+                <a:lnTo>
+                  <a:pt x="786384" y="210312"/>
+                </a:lnTo>
+                <a:lnTo>
+                  <a:pt x="429768" y="192024"/>
+                </a:lnTo>
+                <a:cubicBezTo>
+                  <a:pt x="352515" y="187093"/>
+                  <a:pt x="346885" y="177493"/>
+                  <a:pt x="265176" y="164592"/>
+                </a:cubicBezTo>
+                <a:cubicBezTo>
+                  <a:pt x="202896" y="154758"/>
+                  <a:pt x="101584" y="150028"/>
+                  <a:pt x="45720" y="146304"/>
+                </a:cubicBezTo>
+                <a:cubicBezTo>
+                  <a:pt x="42672" y="134112"/>
+                  <a:pt x="29271" y="119954"/>
+                  <a:pt x="36576" y="109728"/>
+                </a:cubicBezTo>
+                <a:cubicBezTo>
+                  <a:pt x="60578" y="76125"/>
+                  <a:pt x="146103" y="76222"/>
+                  <a:pt x="173736" y="73152"/>
+                </a:cubicBezTo>
+                <a:cubicBezTo>
+                  <a:pt x="231648" y="79248"/>
+                  <a:pt x="290311" y="80325"/>
+                  <a:pt x="347472" y="91440"/>
+                </a:cubicBezTo>
+                <a:cubicBezTo>
+                  <a:pt x="490414" y="119234"/>
+                  <a:pt x="502310" y="142553"/>
+                  <a:pt x="630936" y="192024"/>
+                </a:cubicBezTo>
+                <a:cubicBezTo>
+                  <a:pt x="758884" y="241235"/>
+                  <a:pt x="759456" y="231567"/>
+                  <a:pt x="914400" y="256032"/>
+                </a:cubicBezTo>
+                <a:cubicBezTo>
+                  <a:pt x="928275" y="260987"/>
+                  <a:pt x="1085383" y="323065"/>
+                  <a:pt x="1124712" y="320040"/>
+                </a:cubicBezTo>
+                <a:cubicBezTo>
+                  <a:pt x="1177786" y="315957"/>
+                  <a:pt x="1228344" y="295656"/>
+                  <a:pt x="1280160" y="283464"/>
+                </a:cubicBezTo>
+                <a:cubicBezTo>
+                  <a:pt x="1301496" y="268224"/>
+                  <a:pt x="1322352" y="252288"/>
+                  <a:pt x="1344168" y="237744"/>
+                </a:cubicBezTo>
+                <a:cubicBezTo>
+                  <a:pt x="1368093" y="221794"/>
+                  <a:pt x="1393828" y="208606"/>
+                  <a:pt x="1417320" y="192024"/>
+                </a:cubicBezTo>
+                <a:cubicBezTo>
+                  <a:pt x="1493615" y="138169"/>
+                  <a:pt x="1493511" y="117440"/>
+                  <a:pt x="1581912" y="91440"/>
+                </a:cubicBezTo>
+                <a:cubicBezTo>
+                  <a:pt x="1605487" y="84506"/>
+                  <a:pt x="1630680" y="85344"/>
+                  <a:pt x="1655064" y="82296"/>
+                </a:cubicBezTo>
+                <a:cubicBezTo>
+                  <a:pt x="1667256" y="97536"/>
+                  <a:pt x="1682912" y="110560"/>
+                  <a:pt x="1691640" y="128016"/>
+                </a:cubicBezTo>
+                <a:cubicBezTo>
+                  <a:pt x="1746667" y="238070"/>
+                  <a:pt x="1543945" y="180865"/>
+                  <a:pt x="1901952" y="164592"/>
+                </a:cubicBezTo>
+                <a:cubicBezTo>
+                  <a:pt x="2011680" y="137160"/>
+                  <a:pt x="2122306" y="113097"/>
+                  <a:pt x="2231136" y="82296"/>
+                </a:cubicBezTo>
+                <a:cubicBezTo>
+                  <a:pt x="2382369" y="39494"/>
+                  <a:pt x="2352282" y="-7628"/>
+                  <a:pt x="2459736" y="64008"/>
+                </a:cubicBezTo>
+                <a:cubicBezTo>
+                  <a:pt x="2474082" y="73572"/>
+                  <a:pt x="2484120" y="88392"/>
+                  <a:pt x="2496312" y="100584"/>
+                </a:cubicBezTo>
+                <a:cubicBezTo>
+                  <a:pt x="2506301" y="150531"/>
+                  <a:pt x="2494466" y="135314"/>
+                  <a:pt x="2514600" y="155448"/>
+                </a:cubicBezTo>
+              </a:path>
+            </a:pathLst>
+          </a:custGeom>
+          <a:noFill/>
+          <a:ln>
+            <a:solidFill>
+              <a:srgbClr val="FF0000"/>
+            </a:solidFill>
+          </a:ln>
+        </p:spPr>
+        <p:style>
+          <a:lnRef idx="2">
+            <a:schemeClr val="accent1">
+              <a:shade val="15000"/>
+            </a:schemeClr>
+          </a:lnRef>
+          <a:fillRef idx="1">
+            <a:schemeClr val="accent1"/>
+          </a:fillRef>
+          <a:effectRef idx="0">
+            <a:schemeClr val="accent1"/>
+          </a:effectRef>
+          <a:fontRef idx="minor">
+            <a:schemeClr val="lt1"/>
+          </a:fontRef>
+        </p:style>
+        <p:txBody>
+          <a:bodyPr rtlCol="0" anchor="ctr"/>
+          <a:lstStyle/>
+          <a:p>
+            <a:pPr algn="ctr"/>
+            <a:endParaRPr lang="fr-FR"/>
+          </a:p>
+        </p:txBody>
+      </p:sp>
+      <p:sp>
+        <p:nvSpPr>
+          <p:cNvPr id="23" name="Rectangle 22">
+            <a:extLst>
+              <a:ext uri="{FF2B5EF4-FFF2-40B4-BE49-F238E27FC236}">
+                <a16:creationId xmlns:a16="http://schemas.microsoft.com/office/drawing/2014/main" id="{C2FA0176-84E3-F5DD-A977-3FE78B0A1D71}"/>
+              </a:ext>
+            </a:extLst>
+          </p:cNvPr>
+          <p:cNvSpPr/>
+          <p:nvPr/>
+        </p:nvSpPr>
+        <p:spPr>
+          <a:xfrm>
+            <a:off x="356616" y="3858768"/>
+            <a:ext cx="4014216" cy="364808"/>
+          </a:xfrm>
+          <a:prstGeom prst="rect">
+            <a:avLst/>
+          </a:prstGeom>
+        </p:spPr>
+        <p:style>
+          <a:lnRef idx="2">
+            <a:schemeClr val="accent1">
+              <a:shade val="15000"/>
+            </a:schemeClr>
+          </a:lnRef>
+          <a:fillRef idx="1">
+            <a:schemeClr val="accent1"/>
+          </a:fillRef>
+          <a:effectRef idx="0">
+            <a:schemeClr val="accent1"/>
+          </a:effectRef>
+          <a:fontRef idx="minor">
+            <a:schemeClr val="lt1"/>
+          </a:fontRef>
+        </p:style>
+        <p:txBody>
+          <a:bodyPr rtlCol="0" anchor="ctr"/>
+          <a:lstStyle/>
+          <a:p>
+            <a:pPr algn="ctr"/>
+            <a:r>
+              <a:rPr lang="fr-FR" dirty="0"/>
+              <a:t>Ajouter min journée</a:t>
+            </a:r>
+          </a:p>
+        </p:txBody>
+      </p:sp>
+      <p:sp>
+        <p:nvSpPr>
+          <p:cNvPr id="25" name="Rectangle 24">
+            <a:extLst>
+              <a:ext uri="{FF2B5EF4-FFF2-40B4-BE49-F238E27FC236}">
+                <a16:creationId xmlns:a16="http://schemas.microsoft.com/office/drawing/2014/main" id="{76ED6296-E4BC-7234-65A0-C7E0B4DC5756}"/>
+              </a:ext>
+            </a:extLst>
+          </p:cNvPr>
+          <p:cNvSpPr/>
+          <p:nvPr/>
+        </p:nvSpPr>
+        <p:spPr>
+          <a:xfrm>
+            <a:off x="4608845" y="3847914"/>
+            <a:ext cx="4014216" cy="364808"/>
+          </a:xfrm>
+          <a:prstGeom prst="rect">
+            <a:avLst/>
+          </a:prstGeom>
+        </p:spPr>
+        <p:style>
+          <a:lnRef idx="2">
+            <a:schemeClr val="accent1">
+              <a:shade val="15000"/>
+            </a:schemeClr>
+          </a:lnRef>
+          <a:fillRef idx="1">
+            <a:schemeClr val="accent1"/>
+          </a:fillRef>
+          <a:effectRef idx="0">
+            <a:schemeClr val="accent1"/>
+          </a:effectRef>
+          <a:fontRef idx="minor">
+            <a:schemeClr val="lt1"/>
+          </a:fontRef>
+        </p:style>
+        <p:txBody>
+          <a:bodyPr rtlCol="0" anchor="ctr"/>
+          <a:lstStyle/>
+          <a:p>
+            <a:pPr algn="ctr"/>
+            <a:r>
+              <a:rPr lang="fr-FR" dirty="0"/>
+              <a:t>Ajouter max journée</a:t>
+            </a:r>
+          </a:p>
+        </p:txBody>
+      </p:sp>
+      <p:sp>
+        <p:nvSpPr>
+          <p:cNvPr id="26" name="Forme libre : forme 25">
+            <a:extLst>
+              <a:ext uri="{FF2B5EF4-FFF2-40B4-BE49-F238E27FC236}">
+                <a16:creationId xmlns:a16="http://schemas.microsoft.com/office/drawing/2014/main" id="{1E208B8F-7436-88AC-BE1E-BA1E7AB9DC23}"/>
+              </a:ext>
+            </a:extLst>
+          </p:cNvPr>
+          <p:cNvSpPr/>
+          <p:nvPr/>
+        </p:nvSpPr>
+        <p:spPr>
+          <a:xfrm>
+            <a:off x="6775699" y="4169664"/>
+            <a:ext cx="1884273" cy="2029968"/>
+          </a:xfrm>
+          <a:custGeom>
+            <a:avLst/>
+            <a:gdLst>
+              <a:gd name="csX0" fmla="*/ 64013 w 1884273"/>
+              <a:gd name="csY0" fmla="*/ 201168 h 2029968"/>
+              <a:gd name="csX1" fmla="*/ 91445 w 1884273"/>
+              <a:gd name="csY1" fmla="*/ 146304 h 2029968"/>
+              <a:gd name="csX2" fmla="*/ 155453 w 1884273"/>
+              <a:gd name="csY2" fmla="*/ 45720 h 2029968"/>
+              <a:gd name="csX3" fmla="*/ 192029 w 1884273"/>
+              <a:gd name="csY3" fmla="*/ 27432 h 2029968"/>
+              <a:gd name="csX4" fmla="*/ 265181 w 1884273"/>
+              <a:gd name="csY4" fmla="*/ 0 h 2029968"/>
+              <a:gd name="csX5" fmla="*/ 1234445 w 1884273"/>
+              <a:gd name="csY5" fmla="*/ 45720 h 2029968"/>
+              <a:gd name="csX6" fmla="*/ 1499621 w 1884273"/>
+              <a:gd name="csY6" fmla="*/ 109728 h 2029968"/>
+              <a:gd name="csX7" fmla="*/ 1581917 w 1884273"/>
+              <a:gd name="csY7" fmla="*/ 182880 h 2029968"/>
+              <a:gd name="csX8" fmla="*/ 1636781 w 1884273"/>
+              <a:gd name="csY8" fmla="*/ 338328 h 2029968"/>
+              <a:gd name="csX9" fmla="*/ 1691645 w 1884273"/>
+              <a:gd name="csY9" fmla="*/ 457200 h 2029968"/>
+              <a:gd name="csX10" fmla="*/ 1773941 w 1884273"/>
+              <a:gd name="csY10" fmla="*/ 612648 h 2029968"/>
+              <a:gd name="csX11" fmla="*/ 1865381 w 1884273"/>
+              <a:gd name="csY11" fmla="*/ 1024128 h 2029968"/>
+              <a:gd name="csX12" fmla="*/ 1874525 w 1884273"/>
+              <a:gd name="csY12" fmla="*/ 1188720 h 2029968"/>
+              <a:gd name="csX13" fmla="*/ 1883669 w 1884273"/>
+              <a:gd name="csY13" fmla="*/ 1335024 h 2029968"/>
+              <a:gd name="csX14" fmla="*/ 1837949 w 1884273"/>
+              <a:gd name="csY14" fmla="*/ 1773936 h 2029968"/>
+              <a:gd name="csX15" fmla="*/ 1755653 w 1884273"/>
+              <a:gd name="csY15" fmla="*/ 1883664 h 2029968"/>
+              <a:gd name="csX16" fmla="*/ 1536197 w 1884273"/>
+              <a:gd name="csY16" fmla="*/ 1956816 h 2029968"/>
+              <a:gd name="csX17" fmla="*/ 1161293 w 1884273"/>
+              <a:gd name="csY17" fmla="*/ 2029968 h 2029968"/>
+              <a:gd name="csX18" fmla="*/ 594365 w 1884273"/>
+              <a:gd name="csY18" fmla="*/ 2011680 h 2029968"/>
+              <a:gd name="csX19" fmla="*/ 384053 w 1884273"/>
+              <a:gd name="csY19" fmla="*/ 1865376 h 2029968"/>
+              <a:gd name="csX20" fmla="*/ 201173 w 1884273"/>
+              <a:gd name="csY20" fmla="*/ 1618488 h 2029968"/>
+              <a:gd name="csX21" fmla="*/ 128021 w 1884273"/>
+              <a:gd name="csY21" fmla="*/ 1508760 h 2029968"/>
+              <a:gd name="csX22" fmla="*/ 45725 w 1884273"/>
+              <a:gd name="csY22" fmla="*/ 1380744 h 2029968"/>
+              <a:gd name="csX23" fmla="*/ 18293 w 1884273"/>
+              <a:gd name="csY23" fmla="*/ 1289304 h 2029968"/>
+              <a:gd name="csX24" fmla="*/ 5 w 1884273"/>
+              <a:gd name="csY24" fmla="*/ 1143000 h 2029968"/>
+              <a:gd name="csX25" fmla="*/ 18293 w 1884273"/>
+              <a:gd name="csY25" fmla="*/ 640080 h 2029968"/>
+              <a:gd name="csX26" fmla="*/ 36581 w 1884273"/>
+              <a:gd name="csY26" fmla="*/ 576072 h 2029968"/>
+              <a:gd name="csX27" fmla="*/ 45725 w 1884273"/>
+              <a:gd name="csY27" fmla="*/ 512064 h 2029968"/>
+              <a:gd name="csX28" fmla="*/ 82301 w 1884273"/>
+              <a:gd name="csY28" fmla="*/ 411480 h 2029968"/>
+              <a:gd name="csX29" fmla="*/ 100589 w 1884273"/>
+              <a:gd name="csY29" fmla="*/ 320040 h 2029968"/>
+              <a:gd name="csX30" fmla="*/ 128021 w 1884273"/>
+              <a:gd name="csY30" fmla="*/ 91440 h 2029968"/>
+            </a:gdLst>
+            <a:ahLst/>
+            <a:cxnLst>
+              <a:cxn ang="0">
+                <a:pos x="csX0" y="csY0"/>
+              </a:cxn>
+              <a:cxn ang="0">
+                <a:pos x="csX1" y="csY1"/>
+              </a:cxn>
+              <a:cxn ang="0">
+                <a:pos x="csX2" y="csY2"/>
+              </a:cxn>
+              <a:cxn ang="0">
+                <a:pos x="csX3" y="csY3"/>
+              </a:cxn>
+              <a:cxn ang="0">
+                <a:pos x="csX4" y="csY4"/>
+              </a:cxn>
+              <a:cxn ang="0">
+                <a:pos x="csX5" y="csY5"/>
+              </a:cxn>
+              <a:cxn ang="0">
+                <a:pos x="csX6" y="csY6"/>
+              </a:cxn>
+              <a:cxn ang="0">
+                <a:pos x="csX7" y="csY7"/>
+              </a:cxn>
+              <a:cxn ang="0">
+                <a:pos x="csX8" y="csY8"/>
+              </a:cxn>
+              <a:cxn ang="0">
+                <a:pos x="csX9" y="csY9"/>
+              </a:cxn>
+              <a:cxn ang="0">
+                <a:pos x="csX10" y="csY10"/>
+              </a:cxn>
+              <a:cxn ang="0">
+                <a:pos x="csX11" y="csY11"/>
+              </a:cxn>
+              <a:cxn ang="0">
+                <a:pos x="csX12" y="csY12"/>
+              </a:cxn>
+              <a:cxn ang="0">
+                <a:pos x="csX13" y="csY13"/>
+              </a:cxn>
+              <a:cxn ang="0">
+                <a:pos x="csX14" y="csY14"/>
+              </a:cxn>
+              <a:cxn ang="0">
+                <a:pos x="csX15" y="csY15"/>
+              </a:cxn>
+              <a:cxn ang="0">
+                <a:pos x="csX16" y="csY16"/>
+              </a:cxn>
+              <a:cxn ang="0">
+                <a:pos x="csX17" y="csY17"/>
+              </a:cxn>
+              <a:cxn ang="0">
+                <a:pos x="csX18" y="csY18"/>
+              </a:cxn>
+              <a:cxn ang="0">
+                <a:pos x="csX19" y="csY19"/>
+              </a:cxn>
+              <a:cxn ang="0">
+                <a:pos x="csX20" y="csY20"/>
+              </a:cxn>
+              <a:cxn ang="0">
+                <a:pos x="csX21" y="csY21"/>
+              </a:cxn>
+              <a:cxn ang="0">
+                <a:pos x="csX22" y="csY22"/>
+              </a:cxn>
+              <a:cxn ang="0">
+                <a:pos x="csX23" y="csY23"/>
+              </a:cxn>
+              <a:cxn ang="0">
+                <a:pos x="csX24" y="csY24"/>
+              </a:cxn>
+              <a:cxn ang="0">
+                <a:pos x="csX25" y="csY25"/>
+              </a:cxn>
+              <a:cxn ang="0">
+                <a:pos x="csX26" y="csY26"/>
+              </a:cxn>
+              <a:cxn ang="0">
+                <a:pos x="csX27" y="csY27"/>
+              </a:cxn>
+              <a:cxn ang="0">
+                <a:pos x="csX28" y="csY28"/>
+              </a:cxn>
+              <a:cxn ang="0">
+                <a:pos x="csX29" y="csY29"/>
+              </a:cxn>
+              <a:cxn ang="0">
+                <a:pos x="csX30" y="csY30"/>
+              </a:cxn>
+            </a:cxnLst>
+            <a:rect l="l" t="t" r="r" b="b"/>
+            <a:pathLst>
+              <a:path w="1884273" h="2029968">
+                <a:moveTo>
+                  <a:pt x="64013" y="201168"/>
+                </a:moveTo>
+                <a:cubicBezTo>
+                  <a:pt x="73157" y="182880"/>
+                  <a:pt x="82984" y="164918"/>
+                  <a:pt x="91445" y="146304"/>
+                </a:cubicBezTo>
+                <a:cubicBezTo>
+                  <a:pt x="115582" y="93202"/>
+                  <a:pt x="103564" y="91843"/>
+                  <a:pt x="155453" y="45720"/>
+                </a:cubicBezTo>
+                <a:cubicBezTo>
+                  <a:pt x="165641" y="36664"/>
+                  <a:pt x="179573" y="32968"/>
+                  <a:pt x="192029" y="27432"/>
+                </a:cubicBezTo>
+                <a:cubicBezTo>
+                  <a:pt x="224831" y="12854"/>
+                  <a:pt x="235018" y="10054"/>
+                  <a:pt x="265181" y="0"/>
+                </a:cubicBezTo>
+                <a:cubicBezTo>
+                  <a:pt x="588269" y="15240"/>
+                  <a:pt x="912268" y="17082"/>
+                  <a:pt x="1234445" y="45720"/>
+                </a:cubicBezTo>
+                <a:cubicBezTo>
+                  <a:pt x="1325018" y="53771"/>
+                  <a:pt x="1499621" y="109728"/>
+                  <a:pt x="1499621" y="109728"/>
+                </a:cubicBezTo>
+                <a:cubicBezTo>
+                  <a:pt x="1514256" y="121436"/>
+                  <a:pt x="1570897" y="163989"/>
+                  <a:pt x="1581917" y="182880"/>
+                </a:cubicBezTo>
+                <a:cubicBezTo>
+                  <a:pt x="1594919" y="205169"/>
+                  <a:pt x="1628409" y="317864"/>
+                  <a:pt x="1636781" y="338328"/>
+                </a:cubicBezTo>
+                <a:cubicBezTo>
+                  <a:pt x="1653305" y="378720"/>
+                  <a:pt x="1672128" y="418167"/>
+                  <a:pt x="1691645" y="457200"/>
+                </a:cubicBezTo>
+                <a:cubicBezTo>
+                  <a:pt x="1717865" y="509640"/>
+                  <a:pt x="1753905" y="557548"/>
+                  <a:pt x="1773941" y="612648"/>
+                </a:cubicBezTo>
+                <a:cubicBezTo>
+                  <a:pt x="1825348" y="754016"/>
+                  <a:pt x="1841349" y="879935"/>
+                  <a:pt x="1865381" y="1024128"/>
+                </a:cubicBezTo>
+                <a:cubicBezTo>
+                  <a:pt x="1868429" y="1078992"/>
+                  <a:pt x="1871298" y="1133866"/>
+                  <a:pt x="1874525" y="1188720"/>
+                </a:cubicBezTo>
+                <a:cubicBezTo>
+                  <a:pt x="1877394" y="1237499"/>
+                  <a:pt x="1886717" y="1286256"/>
+                  <a:pt x="1883669" y="1335024"/>
+                </a:cubicBezTo>
+                <a:cubicBezTo>
+                  <a:pt x="1874493" y="1481833"/>
+                  <a:pt x="1871373" y="1630688"/>
+                  <a:pt x="1837949" y="1773936"/>
+                </a:cubicBezTo>
+                <a:cubicBezTo>
+                  <a:pt x="1827560" y="1818460"/>
+                  <a:pt x="1794753" y="1859967"/>
+                  <a:pt x="1755653" y="1883664"/>
+                </a:cubicBezTo>
+                <a:cubicBezTo>
+                  <a:pt x="1689710" y="1923630"/>
+                  <a:pt x="1609825" y="1933910"/>
+                  <a:pt x="1536197" y="1956816"/>
+                </a:cubicBezTo>
+                <a:cubicBezTo>
+                  <a:pt x="1315453" y="2025492"/>
+                  <a:pt x="1382631" y="2007834"/>
+                  <a:pt x="1161293" y="2029968"/>
+                </a:cubicBezTo>
+                <a:cubicBezTo>
+                  <a:pt x="972317" y="2023872"/>
+                  <a:pt x="782314" y="2032277"/>
+                  <a:pt x="594365" y="2011680"/>
+                </a:cubicBezTo>
+                <a:cubicBezTo>
+                  <a:pt x="545692" y="2006346"/>
+                  <a:pt x="406298" y="1891097"/>
+                  <a:pt x="384053" y="1865376"/>
+                </a:cubicBezTo>
+                <a:cubicBezTo>
+                  <a:pt x="317058" y="1787913"/>
+                  <a:pt x="260902" y="1701682"/>
+                  <a:pt x="201173" y="1618488"/>
+                </a:cubicBezTo>
+                <a:cubicBezTo>
+                  <a:pt x="175536" y="1582779"/>
+                  <a:pt x="152844" y="1545040"/>
+                  <a:pt x="128021" y="1508760"/>
+                </a:cubicBezTo>
+                <a:cubicBezTo>
+                  <a:pt x="101324" y="1469741"/>
+                  <a:pt x="64095" y="1425356"/>
+                  <a:pt x="45725" y="1380744"/>
+                </a:cubicBezTo>
+                <a:cubicBezTo>
+                  <a:pt x="33609" y="1351319"/>
+                  <a:pt x="27437" y="1319784"/>
+                  <a:pt x="18293" y="1289304"/>
+                </a:cubicBezTo>
+                <a:cubicBezTo>
+                  <a:pt x="14498" y="1262739"/>
+                  <a:pt x="-320" y="1163776"/>
+                  <a:pt x="5" y="1143000"/>
+                </a:cubicBezTo>
+                <a:cubicBezTo>
+                  <a:pt x="2626" y="975270"/>
+                  <a:pt x="7493" y="807483"/>
+                  <a:pt x="18293" y="640080"/>
+                </a:cubicBezTo>
+                <a:cubicBezTo>
+                  <a:pt x="19722" y="617936"/>
+                  <a:pt x="31932" y="597769"/>
+                  <a:pt x="36581" y="576072"/>
+                </a:cubicBezTo>
+                <a:cubicBezTo>
+                  <a:pt x="41097" y="554998"/>
+                  <a:pt x="40879" y="533065"/>
+                  <a:pt x="45725" y="512064"/>
+                </a:cubicBezTo>
+                <a:cubicBezTo>
+                  <a:pt x="79581" y="365356"/>
+                  <a:pt x="48018" y="540042"/>
+                  <a:pt x="82301" y="411480"/>
+                </a:cubicBezTo>
+                <a:cubicBezTo>
+                  <a:pt x="90310" y="381446"/>
+                  <a:pt x="96734" y="350884"/>
+                  <a:pt x="100589" y="320040"/>
+                </a:cubicBezTo>
+                <a:cubicBezTo>
+                  <a:pt x="128399" y="97560"/>
+                  <a:pt x="128021" y="174305"/>
+                  <a:pt x="128021" y="91440"/>
+                </a:cubicBezTo>
+              </a:path>
+            </a:pathLst>
+          </a:custGeom>
+          <a:noFill/>
+          <a:ln>
+            <a:solidFill>
+              <a:srgbClr val="FF0000"/>
+            </a:solidFill>
+          </a:ln>
+        </p:spPr>
+        <p:style>
+          <a:lnRef idx="2">
+            <a:schemeClr val="accent1">
+              <a:shade val="15000"/>
+            </a:schemeClr>
+          </a:lnRef>
+          <a:fillRef idx="1">
+            <a:schemeClr val="accent1"/>
+          </a:fillRef>
+          <a:effectRef idx="0">
+            <a:schemeClr val="accent1"/>
+          </a:effectRef>
+          <a:fontRef idx="minor">
+            <a:schemeClr val="lt1"/>
+          </a:fontRef>
+        </p:style>
+        <p:txBody>
+          <a:bodyPr rtlCol="0" anchor="ctr"/>
+          <a:lstStyle/>
+          <a:p>
+            <a:pPr algn="ctr"/>
+            <a:endParaRPr lang="fr-FR"/>
+          </a:p>
+        </p:txBody>
+      </p:sp>
+      <p:cxnSp>
+        <p:nvCxnSpPr>
+          <p:cNvPr id="28" name="Connecteur droit avec flèche 27">
+            <a:extLst>
+              <a:ext uri="{FF2B5EF4-FFF2-40B4-BE49-F238E27FC236}">
+                <a16:creationId xmlns:a16="http://schemas.microsoft.com/office/drawing/2014/main" id="{CFFBAC36-BCC9-CAE0-AFFF-7DD781B32CE5}"/>
+              </a:ext>
+            </a:extLst>
+          </p:cNvPr>
+          <p:cNvCxnSpPr>
+            <a:stCxn id="26" idx="18"/>
+          </p:cNvCxnSpPr>
+          <p:nvPr/>
+        </p:nvCxnSpPr>
+        <p:spPr>
+          <a:xfrm flipH="1">
+            <a:off x="6327648" y="6181344"/>
+            <a:ext cx="1042416" cy="188604"/>
+          </a:xfrm>
+          <a:prstGeom prst="straightConnector1">
+            <a:avLst/>
+          </a:prstGeom>
+          <a:ln>
+            <a:solidFill>
+              <a:srgbClr val="FF0000"/>
+            </a:solidFill>
+            <a:tailEnd type="triangle"/>
+          </a:ln>
+        </p:spPr>
+        <p:style>
+          <a:lnRef idx="2">
+            <a:schemeClr val="accent1"/>
+          </a:lnRef>
+          <a:fillRef idx="0">
+            <a:schemeClr val="accent1"/>
+          </a:fillRef>
+          <a:effectRef idx="1">
+            <a:schemeClr val="accent1"/>
+          </a:effectRef>
+          <a:fontRef idx="minor">
+            <a:schemeClr val="tx1"/>
+          </a:fontRef>
+        </p:style>
+      </p:cxnSp>
+      <p:sp>
+        <p:nvSpPr>
+          <p:cNvPr id="29" name="Rectangle 28">
+            <a:extLst>
+              <a:ext uri="{FF2B5EF4-FFF2-40B4-BE49-F238E27FC236}">
+                <a16:creationId xmlns:a16="http://schemas.microsoft.com/office/drawing/2014/main" id="{ED53F903-A08C-5959-DF0E-0EE488078F94}"/>
+              </a:ext>
+            </a:extLst>
+          </p:cNvPr>
+          <p:cNvSpPr/>
+          <p:nvPr/>
+        </p:nvSpPr>
+        <p:spPr>
+          <a:xfrm>
+            <a:off x="3648456" y="6263640"/>
+            <a:ext cx="2642616" cy="396925"/>
+          </a:xfrm>
+          <a:prstGeom prst="rect">
+            <a:avLst/>
+          </a:prstGeom>
+        </p:spPr>
+        <p:style>
+          <a:lnRef idx="2">
+            <a:schemeClr val="accent1">
+              <a:shade val="15000"/>
+            </a:schemeClr>
+          </a:lnRef>
+          <a:fillRef idx="1">
+            <a:schemeClr val="accent1"/>
+          </a:fillRef>
+          <a:effectRef idx="0">
+            <a:schemeClr val="accent1"/>
+          </a:effectRef>
+          <a:fontRef idx="minor">
+            <a:schemeClr val="lt1"/>
+          </a:fontRef>
+        </p:style>
+        <p:txBody>
+          <a:bodyPr rtlCol="0" anchor="ctr"/>
+          <a:lstStyle/>
+          <a:p>
+            <a:pPr algn="ctr"/>
+            <a:r>
+              <a:rPr lang="fr-FR" dirty="0"/>
+              <a:t>Prix d’activation</a:t>
+            </a:r>
+          </a:p>
+        </p:txBody>
+      </p:sp>
+      <p:sp>
+        <p:nvSpPr>
+          <p:cNvPr id="30" name="Rectangle 29">
+            <a:extLst>
+              <a:ext uri="{FF2B5EF4-FFF2-40B4-BE49-F238E27FC236}">
+                <a16:creationId xmlns:a16="http://schemas.microsoft.com/office/drawing/2014/main" id="{180B10C1-5DDE-A201-BF21-ED55F890E3CD}"/>
+              </a:ext>
+            </a:extLst>
+          </p:cNvPr>
+          <p:cNvSpPr/>
+          <p:nvPr/>
+        </p:nvSpPr>
+        <p:spPr>
+          <a:xfrm>
+            <a:off x="8778240" y="3255161"/>
+            <a:ext cx="915924" cy="182806"/>
+          </a:xfrm>
+          <a:prstGeom prst="rect">
+            <a:avLst/>
+          </a:prstGeom>
+        </p:spPr>
+        <p:style>
+          <a:lnRef idx="2">
+            <a:schemeClr val="accent1">
+              <a:shade val="15000"/>
+            </a:schemeClr>
+          </a:lnRef>
+          <a:fillRef idx="1">
+            <a:schemeClr val="accent1"/>
+          </a:fillRef>
+          <a:effectRef idx="0">
+            <a:schemeClr val="accent1"/>
+          </a:effectRef>
+          <a:fontRef idx="minor">
+            <a:schemeClr val="lt1"/>
+          </a:fontRef>
+        </p:style>
+        <p:txBody>
+          <a:bodyPr rtlCol="0" anchor="ctr"/>
+          <a:lstStyle/>
+          <a:p>
+            <a:pPr algn="ctr"/>
+            <a:r>
+              <a:rPr lang="fr-FR" dirty="0"/>
+              <a:t>TB2</a:t>
+            </a:r>
+          </a:p>
+        </p:txBody>
+      </p:sp>
+      <p:sp>
+        <p:nvSpPr>
+          <p:cNvPr id="32" name="Rectangle 31">
+            <a:extLst>
+              <a:ext uri="{FF2B5EF4-FFF2-40B4-BE49-F238E27FC236}">
+                <a16:creationId xmlns:a16="http://schemas.microsoft.com/office/drawing/2014/main" id="{702254D7-E089-F0E0-F6AA-86905F3608E1}"/>
+              </a:ext>
+            </a:extLst>
+          </p:cNvPr>
+          <p:cNvSpPr/>
+          <p:nvPr/>
+        </p:nvSpPr>
+        <p:spPr>
+          <a:xfrm>
+            <a:off x="10386822" y="3191154"/>
+            <a:ext cx="915924" cy="182806"/>
+          </a:xfrm>
+          <a:prstGeom prst="rect">
+            <a:avLst/>
+          </a:prstGeom>
+        </p:spPr>
+        <p:style>
+          <a:lnRef idx="2">
+            <a:schemeClr val="accent1">
+              <a:shade val="15000"/>
+            </a:schemeClr>
+          </a:lnRef>
+          <a:fillRef idx="1">
+            <a:schemeClr val="accent1"/>
+          </a:fillRef>
+          <a:effectRef idx="0">
+            <a:schemeClr val="accent1"/>
+          </a:effectRef>
+          <a:fontRef idx="minor">
+            <a:schemeClr val="lt1"/>
+          </a:fontRef>
+        </p:style>
+        <p:txBody>
+          <a:bodyPr rtlCol="0" anchor="ctr"/>
+          <a:lstStyle/>
+          <a:p>
+            <a:pPr algn="ctr"/>
+            <a:r>
+              <a:rPr lang="fr-FR" dirty="0"/>
+              <a:t>TB4</a:t>
+            </a:r>
+          </a:p>
+        </p:txBody>
+      </p:sp>
+      <p:cxnSp>
+        <p:nvCxnSpPr>
+          <p:cNvPr id="34" name="Connecteur droit avec flèche 33">
+            <a:extLst>
+              <a:ext uri="{FF2B5EF4-FFF2-40B4-BE49-F238E27FC236}">
+                <a16:creationId xmlns:a16="http://schemas.microsoft.com/office/drawing/2014/main" id="{29BA4DC2-F1C3-609D-5998-5B7A450C3036}"/>
+              </a:ext>
+            </a:extLst>
+          </p:cNvPr>
+          <p:cNvCxnSpPr/>
+          <p:nvPr/>
+        </p:nvCxnSpPr>
+        <p:spPr>
+          <a:xfrm>
+            <a:off x="8107052" y="3101419"/>
+            <a:ext cx="150828" cy="480767"/>
+          </a:xfrm>
+          <a:prstGeom prst="straightConnector1">
+            <a:avLst/>
+          </a:prstGeom>
+          <a:ln>
+            <a:solidFill>
+              <a:srgbClr val="FF0000"/>
+            </a:solidFill>
+            <a:tailEnd type="triangle"/>
+          </a:ln>
+        </p:spPr>
+        <p:style>
+          <a:lnRef idx="2">
+            <a:schemeClr val="accent1"/>
+          </a:lnRef>
+          <a:fillRef idx="0">
+            <a:schemeClr val="accent1"/>
+          </a:fillRef>
+          <a:effectRef idx="1">
+            <a:schemeClr val="accent1"/>
+          </a:effectRef>
+          <a:fontRef idx="minor">
+            <a:schemeClr val="tx1"/>
+          </a:fontRef>
+        </p:style>
+      </p:cxnSp>
+      <p:sp>
+        <p:nvSpPr>
+          <p:cNvPr id="35" name="ZoneTexte 34">
+            <a:extLst>
+              <a:ext uri="{FF2B5EF4-FFF2-40B4-BE49-F238E27FC236}">
+                <a16:creationId xmlns:a16="http://schemas.microsoft.com/office/drawing/2014/main" id="{92C8D36C-5193-88C5-CB4C-097AD79046A6}"/>
+              </a:ext>
+            </a:extLst>
+          </p:cNvPr>
+          <p:cNvSpPr txBox="1"/>
+          <p:nvPr/>
+        </p:nvSpPr>
+        <p:spPr>
+          <a:xfrm>
+            <a:off x="6775699" y="2686491"/>
+            <a:ext cx="2225161" cy="369332"/>
+          </a:xfrm>
+          <a:prstGeom prst="rect">
+            <a:avLst/>
+          </a:prstGeom>
+          <a:noFill/>
+        </p:spPr>
+        <p:txBody>
+          <a:bodyPr wrap="none" rtlCol="0">
+            <a:spAutoFit/>
+          </a:bodyPr>
+          <a:lstStyle/>
+          <a:p>
+            <a:r>
+              <a:rPr lang="fr-FR" dirty="0">
+                <a:solidFill>
+                  <a:srgbClr val="FF0000"/>
+                </a:solidFill>
+              </a:rPr>
+              <a:t>Variation sur la veille</a:t>
+            </a:r>
+          </a:p>
+        </p:txBody>
+      </p:sp>
+      <p:sp>
+        <p:nvSpPr>
+          <p:cNvPr id="36" name="ZoneTexte 35">
+            <a:extLst>
+              <a:ext uri="{FF2B5EF4-FFF2-40B4-BE49-F238E27FC236}">
+                <a16:creationId xmlns:a16="http://schemas.microsoft.com/office/drawing/2014/main" id="{622A576C-D6D4-86DB-7C37-BF1BF6422B81}"/>
+              </a:ext>
+            </a:extLst>
+          </p:cNvPr>
+          <p:cNvSpPr txBox="1"/>
+          <p:nvPr/>
+        </p:nvSpPr>
+        <p:spPr>
+          <a:xfrm>
+            <a:off x="-179109" y="103695"/>
+            <a:ext cx="184731" cy="369332"/>
+          </a:xfrm>
+          <a:prstGeom prst="rect">
+            <a:avLst/>
+          </a:prstGeom>
+          <a:noFill/>
+        </p:spPr>
+        <p:txBody>
+          <a:bodyPr wrap="none" rtlCol="0">
+            <a:spAutoFit/>
+          </a:bodyPr>
+          <a:lstStyle/>
+          <a:p>
+            <a:endParaRPr lang="fr-FR"/>
           </a:p>
         </p:txBody>
       </p:sp>
     </p:spTree>
     <p:extLst>
       <p:ext uri="{BB962C8B-B14F-4D97-AF65-F5344CB8AC3E}">
-        <p14:creationId xmlns:p14="http://schemas.microsoft.com/office/powerpoint/2010/main" val="2021926209"/>
+        <p14:creationId xmlns:p14="http://schemas.microsoft.com/office/powerpoint/2010/main" val="2069241052"/>
       </p:ext>
     </p:extLst>
   </p:cSld>
@@ -4029,7 +5781,7 @@
           <p:cNvPr id="2" name="Titre 1">
             <a:extLst>
               <a:ext uri="{FF2B5EF4-FFF2-40B4-BE49-F238E27FC236}">
-                <a16:creationId xmlns:a16="http://schemas.microsoft.com/office/drawing/2014/main" id="{24167CB6-DF6E-AEAB-B0AD-6BDC6FB984BE}"/>
+                <a16:creationId xmlns:a16="http://schemas.microsoft.com/office/drawing/2014/main" id="{D5E8CEF5-6E23-4004-9FE2-A86A1917E8E8}"/>
               </a:ext>
             </a:extLst>
           </p:cNvPr>
@@ -4045,379 +5797,32 @@
           <a:bodyPr/>
           <a:lstStyle/>
           <a:p>
+            <a:r>
+              <a:rPr lang="fr-FR" dirty="0"/>
+              <a:t>Rajouter les </a:t>
+            </a:r>
+            <a:r>
+              <a:rPr lang="fr-FR" dirty="0" err="1"/>
+              <a:t>les</a:t>
+            </a:r>
+            <a:r>
+              <a:rPr lang="fr-FR" dirty="0"/>
+              <a:t> position de </a:t>
+            </a:r>
+            <a:r>
+              <a:rPr lang="fr-FR" dirty="0" err="1"/>
+              <a:t>novawatt</a:t>
+            </a:r>
             <a:endParaRPr lang="fr-FR" dirty="0"/>
           </a:p>
         </p:txBody>
       </p:sp>
       <p:sp>
         <p:nvSpPr>
-          <p:cNvPr id="4" name="Rectangle 3">
-            <a:extLst>
-              <a:ext uri="{FF2B5EF4-FFF2-40B4-BE49-F238E27FC236}">
-                <a16:creationId xmlns:a16="http://schemas.microsoft.com/office/drawing/2014/main" id="{1B0C0160-F03D-7BB6-9B60-68BD48B0762C}"/>
-              </a:ext>
-            </a:extLst>
-          </p:cNvPr>
-          <p:cNvSpPr/>
-          <p:nvPr/>
-        </p:nvSpPr>
-        <p:spPr>
-          <a:xfrm>
-            <a:off x="8189406" y="365126"/>
-            <a:ext cx="2803491" cy="629662"/>
-          </a:xfrm>
-          <a:prstGeom prst="rect">
-            <a:avLst/>
-          </a:prstGeom>
-        </p:spPr>
-        <p:style>
-          <a:lnRef idx="2">
-            <a:schemeClr val="accent1">
-              <a:shade val="15000"/>
-            </a:schemeClr>
-          </a:lnRef>
-          <a:fillRef idx="1">
-            <a:schemeClr val="accent1"/>
-          </a:fillRef>
-          <a:effectRef idx="0">
-            <a:schemeClr val="accent1"/>
-          </a:effectRef>
-          <a:fontRef idx="minor">
-            <a:schemeClr val="lt1"/>
-          </a:fontRef>
-        </p:style>
-        <p:txBody>
-          <a:bodyPr rtlCol="0" anchor="ctr"/>
-          <a:lstStyle/>
-          <a:p>
-            <a:pPr algn="ctr"/>
-            <a:r>
-              <a:rPr lang="fr-FR" dirty="0"/>
-              <a:t>Spark-spread </a:t>
-            </a:r>
-          </a:p>
-        </p:txBody>
-      </p:sp>
-      <p:sp>
-        <p:nvSpPr>
-          <p:cNvPr id="6" name="Rectangle 5">
-            <a:extLst>
-              <a:ext uri="{FF2B5EF4-FFF2-40B4-BE49-F238E27FC236}">
-                <a16:creationId xmlns:a16="http://schemas.microsoft.com/office/drawing/2014/main" id="{6FDA8550-54D3-BCFE-061C-90769C5311AE}"/>
-              </a:ext>
-            </a:extLst>
-          </p:cNvPr>
-          <p:cNvSpPr/>
-          <p:nvPr/>
-        </p:nvSpPr>
-        <p:spPr>
-          <a:xfrm>
-            <a:off x="8189406" y="2173575"/>
-            <a:ext cx="2803491" cy="920175"/>
-          </a:xfrm>
-          <a:prstGeom prst="rect">
-            <a:avLst/>
-          </a:prstGeom>
-        </p:spPr>
-        <p:style>
-          <a:lnRef idx="2">
-            <a:schemeClr val="accent1">
-              <a:shade val="15000"/>
-            </a:schemeClr>
-          </a:lnRef>
-          <a:fillRef idx="1">
-            <a:schemeClr val="accent1"/>
-          </a:fillRef>
-          <a:effectRef idx="0">
-            <a:schemeClr val="accent1"/>
-          </a:effectRef>
-          <a:fontRef idx="minor">
-            <a:schemeClr val="lt1"/>
-          </a:fontRef>
-        </p:style>
-        <p:txBody>
-          <a:bodyPr rtlCol="0" anchor="ctr"/>
-          <a:lstStyle/>
-          <a:p>
-            <a:pPr algn="ctr"/>
-            <a:endParaRPr lang="fr-FR" dirty="0"/>
-          </a:p>
-        </p:txBody>
-      </p:sp>
-      <p:sp>
-        <p:nvSpPr>
-          <p:cNvPr id="8" name="Rectangle 7">
-            <a:extLst>
-              <a:ext uri="{FF2B5EF4-FFF2-40B4-BE49-F238E27FC236}">
-                <a16:creationId xmlns:a16="http://schemas.microsoft.com/office/drawing/2014/main" id="{C5D7E445-750A-A988-EADB-36671FDD7FA5}"/>
-              </a:ext>
-            </a:extLst>
-          </p:cNvPr>
-          <p:cNvSpPr/>
-          <p:nvPr/>
-        </p:nvSpPr>
-        <p:spPr>
-          <a:xfrm>
-            <a:off x="157425" y="4467486"/>
-            <a:ext cx="2803491" cy="920176"/>
-          </a:xfrm>
-          <a:prstGeom prst="rect">
-            <a:avLst/>
-          </a:prstGeom>
-        </p:spPr>
-        <p:style>
-          <a:lnRef idx="2">
-            <a:schemeClr val="accent1">
-              <a:shade val="15000"/>
-            </a:schemeClr>
-          </a:lnRef>
-          <a:fillRef idx="1">
-            <a:schemeClr val="accent1"/>
-          </a:fillRef>
-          <a:effectRef idx="0">
-            <a:schemeClr val="accent1"/>
-          </a:effectRef>
-          <a:fontRef idx="minor">
-            <a:schemeClr val="lt1"/>
-          </a:fontRef>
-        </p:style>
-        <p:txBody>
-          <a:bodyPr rtlCol="0" anchor="ctr"/>
-          <a:lstStyle/>
-          <a:p>
-            <a:pPr algn="ctr"/>
-            <a:r>
-              <a:rPr lang="fr-FR" dirty="0"/>
-              <a:t>NB de jours PP/22</a:t>
-            </a:r>
-          </a:p>
-        </p:txBody>
-      </p:sp>
-      <p:sp>
-        <p:nvSpPr>
-          <p:cNvPr id="10" name="Rectangle 9">
-            <a:extLst>
-              <a:ext uri="{FF2B5EF4-FFF2-40B4-BE49-F238E27FC236}">
-                <a16:creationId xmlns:a16="http://schemas.microsoft.com/office/drawing/2014/main" id="{06AF5FCC-81CF-9BF9-D7C5-DF187F1BAA8C}"/>
-              </a:ext>
-            </a:extLst>
-          </p:cNvPr>
-          <p:cNvSpPr/>
-          <p:nvPr/>
-        </p:nvSpPr>
-        <p:spPr>
-          <a:xfrm>
-            <a:off x="157424" y="365124"/>
-            <a:ext cx="5938576" cy="3960228"/>
-          </a:xfrm>
-          <a:prstGeom prst="rect">
-            <a:avLst/>
-          </a:prstGeom>
-        </p:spPr>
-        <p:style>
-          <a:lnRef idx="2">
-            <a:schemeClr val="accent1">
-              <a:shade val="15000"/>
-            </a:schemeClr>
-          </a:lnRef>
-          <a:fillRef idx="1">
-            <a:schemeClr val="accent1"/>
-          </a:fillRef>
-          <a:effectRef idx="0">
-            <a:schemeClr val="accent1"/>
-          </a:effectRef>
-          <a:fontRef idx="minor">
-            <a:schemeClr val="lt1"/>
-          </a:fontRef>
-        </p:style>
-        <p:txBody>
-          <a:bodyPr rtlCol="0" anchor="ctr"/>
-          <a:lstStyle/>
-          <a:p>
-            <a:pPr algn="ctr"/>
-            <a:r>
-              <a:rPr lang="fr-FR" dirty="0"/>
-              <a:t>Courbe </a:t>
-            </a:r>
-            <a:r>
-              <a:rPr lang="fr-FR" dirty="0" err="1"/>
-              <a:t>spark</a:t>
-            </a:r>
-            <a:r>
-              <a:rPr lang="fr-FR" dirty="0"/>
-              <a:t> spread *3 rendements</a:t>
-            </a:r>
-          </a:p>
-          <a:p>
-            <a:pPr algn="ctr"/>
-            <a:r>
-              <a:rPr lang="fr-FR" dirty="0"/>
-              <a:t>1,8</a:t>
-            </a:r>
-          </a:p>
-          <a:p>
-            <a:pPr algn="ctr"/>
-            <a:r>
-              <a:rPr lang="fr-FR" dirty="0"/>
-              <a:t>2,2</a:t>
-            </a:r>
-          </a:p>
-          <a:p>
-            <a:pPr algn="ctr"/>
-            <a:r>
-              <a:rPr lang="fr-FR" dirty="0"/>
-              <a:t>3,2</a:t>
-            </a:r>
-          </a:p>
-        </p:txBody>
-      </p:sp>
-      <p:sp>
-        <p:nvSpPr>
-          <p:cNvPr id="12" name="Rectangle 11">
-            <a:extLst>
-              <a:ext uri="{FF2B5EF4-FFF2-40B4-BE49-F238E27FC236}">
-                <a16:creationId xmlns:a16="http://schemas.microsoft.com/office/drawing/2014/main" id="{8786F3C1-0787-E66A-848E-955B90C792F9}"/>
-              </a:ext>
-            </a:extLst>
-          </p:cNvPr>
-          <p:cNvSpPr/>
-          <p:nvPr/>
-        </p:nvSpPr>
-        <p:spPr>
-          <a:xfrm>
-            <a:off x="6297807" y="365124"/>
-            <a:ext cx="5938576" cy="3960228"/>
-          </a:xfrm>
-          <a:prstGeom prst="rect">
-            <a:avLst/>
-          </a:prstGeom>
-        </p:spPr>
-        <p:style>
-          <a:lnRef idx="2">
-            <a:schemeClr val="accent1">
-              <a:shade val="15000"/>
-            </a:schemeClr>
-          </a:lnRef>
-          <a:fillRef idx="1">
-            <a:schemeClr val="accent1"/>
-          </a:fillRef>
-          <a:effectRef idx="0">
-            <a:schemeClr val="accent1"/>
-          </a:effectRef>
-          <a:fontRef idx="minor">
-            <a:schemeClr val="lt1"/>
-          </a:fontRef>
-        </p:style>
-        <p:txBody>
-          <a:bodyPr rtlCol="0" anchor="ctr"/>
-          <a:lstStyle/>
-          <a:p>
-            <a:pPr algn="ctr"/>
-            <a:r>
-              <a:rPr lang="fr-FR" dirty="0"/>
-              <a:t>Courbe Clean </a:t>
-            </a:r>
-            <a:r>
-              <a:rPr lang="fr-FR" dirty="0" err="1"/>
-              <a:t>spark</a:t>
-            </a:r>
-            <a:r>
-              <a:rPr lang="fr-FR" dirty="0"/>
-              <a:t> spread *3 rendements</a:t>
-            </a:r>
-          </a:p>
-          <a:p>
-            <a:pPr algn="ctr"/>
-            <a:r>
-              <a:rPr lang="fr-FR" dirty="0"/>
-              <a:t>1,8</a:t>
-            </a:r>
-          </a:p>
-          <a:p>
-            <a:pPr algn="ctr"/>
-            <a:r>
-              <a:rPr lang="fr-FR" dirty="0"/>
-              <a:t>2,2</a:t>
-            </a:r>
-          </a:p>
-          <a:p>
-            <a:pPr algn="ctr"/>
-            <a:r>
-              <a:rPr lang="fr-FR" dirty="0"/>
-              <a:t>3,2</a:t>
-            </a:r>
-          </a:p>
-          <a:p>
-            <a:pPr algn="ctr"/>
-            <a:endParaRPr lang="fr-FR" dirty="0"/>
-          </a:p>
-          <a:p>
-            <a:pPr algn="ctr"/>
-            <a:r>
-              <a:rPr lang="fr-FR" dirty="0"/>
-              <a:t>+0,185*co2</a:t>
-            </a:r>
-          </a:p>
-        </p:txBody>
-      </p:sp>
-      <p:sp>
-        <p:nvSpPr>
-          <p:cNvPr id="14" name="Rectangle 13">
-            <a:extLst>
-              <a:ext uri="{FF2B5EF4-FFF2-40B4-BE49-F238E27FC236}">
-                <a16:creationId xmlns:a16="http://schemas.microsoft.com/office/drawing/2014/main" id="{816291A1-7B8E-9638-9B09-43AD346292A9}"/>
-              </a:ext>
-            </a:extLst>
-          </p:cNvPr>
-          <p:cNvSpPr/>
-          <p:nvPr/>
-        </p:nvSpPr>
-        <p:spPr>
-          <a:xfrm>
-            <a:off x="157424" y="5398921"/>
-            <a:ext cx="2803491" cy="920176"/>
-          </a:xfrm>
-          <a:prstGeom prst="rect">
-            <a:avLst/>
-          </a:prstGeom>
-          <a:solidFill>
-            <a:schemeClr val="accent2"/>
-          </a:solidFill>
-        </p:spPr>
-        <p:style>
-          <a:lnRef idx="2">
-            <a:schemeClr val="accent1">
-              <a:shade val="15000"/>
-            </a:schemeClr>
-          </a:lnRef>
-          <a:fillRef idx="1">
-            <a:schemeClr val="accent1"/>
-          </a:fillRef>
-          <a:effectRef idx="0">
-            <a:schemeClr val="accent1"/>
-          </a:effectRef>
-          <a:fontRef idx="minor">
-            <a:schemeClr val="lt1"/>
-          </a:fontRef>
-        </p:style>
-        <p:txBody>
-          <a:bodyPr rtlCol="0" anchor="ctr"/>
-          <a:lstStyle/>
-          <a:p>
-            <a:pPr algn="ctr"/>
-            <a:r>
-              <a:rPr lang="fr-FR" dirty="0"/>
-              <a:t>On est en PP</a:t>
-            </a:r>
-          </a:p>
-        </p:txBody>
-      </p:sp>
-      <p:sp>
-        <p:nvSpPr>
-          <p:cNvPr id="16" name="Espace réservé du contenu 15">
-            <a:extLst>
-              <a:ext uri="{FF2B5EF4-FFF2-40B4-BE49-F238E27FC236}">
-                <a16:creationId xmlns:a16="http://schemas.microsoft.com/office/drawing/2014/main" id="{A5CA299F-B19F-30AF-6A78-A1D1B6BFB50D}"/>
+          <p:cNvPr id="3" name="Espace réservé du contenu 2">
+            <a:extLst>
+              <a:ext uri="{FF2B5EF4-FFF2-40B4-BE49-F238E27FC236}">
+                <a16:creationId xmlns:a16="http://schemas.microsoft.com/office/drawing/2014/main" id="{C1174697-3B19-B6A5-D5F8-1081D2EE0CFB}"/>
               </a:ext>
             </a:extLst>
           </p:cNvPr>
@@ -4428,485 +5833,45 @@
             <p:ph idx="1"/>
           </p:nvPr>
         </p:nvSpPr>
-        <p:spPr>
-          <a:xfrm>
-            <a:off x="3228169" y="4496809"/>
-            <a:ext cx="3309791" cy="1822287"/>
-          </a:xfrm>
-          <a:prstGeom prst="rect">
-            <a:avLst/>
-          </a:prstGeom>
-        </p:spPr>
-        <p:style>
-          <a:lnRef idx="2">
-            <a:schemeClr val="accent1">
-              <a:shade val="15000"/>
-            </a:schemeClr>
-          </a:lnRef>
-          <a:fillRef idx="1">
-            <a:schemeClr val="accent1"/>
-          </a:fillRef>
-          <a:effectRef idx="0">
-            <a:schemeClr val="accent1"/>
-          </a:effectRef>
-          <a:fontRef idx="minor">
-            <a:schemeClr val="lt1"/>
-          </a:fontRef>
-        </p:style>
-        <p:txBody>
-          <a:bodyPr rtlCol="0" anchor="ctr">
-            <a:normAutofit/>
-          </a:bodyPr>
-          <a:lstStyle/>
-          <a:p>
-            <a:pPr algn="ctr"/>
-            <a:r>
-              <a:rPr lang="fr-FR" dirty="0"/>
-              <a:t>MFRR hausse +baisse</a:t>
-            </a:r>
-          </a:p>
-          <a:p>
-            <a:pPr marL="0" indent="0" algn="ctr">
-              <a:buNone/>
-            </a:pPr>
-            <a:r>
-              <a:rPr lang="fr-FR" dirty="0"/>
-              <a:t>(vs la saison précédente)</a:t>
-            </a:r>
-          </a:p>
-        </p:txBody>
-      </p:sp>
-      <p:sp>
-        <p:nvSpPr>
-          <p:cNvPr id="17" name="Rectangle 16">
-            <a:extLst>
-              <a:ext uri="{FF2B5EF4-FFF2-40B4-BE49-F238E27FC236}">
-                <a16:creationId xmlns:a16="http://schemas.microsoft.com/office/drawing/2014/main" id="{95649D35-BCF5-72FD-6D49-A3333C4ADF6F}"/>
-              </a:ext>
-            </a:extLst>
-          </p:cNvPr>
-          <p:cNvSpPr/>
-          <p:nvPr/>
-        </p:nvSpPr>
-        <p:spPr>
-          <a:xfrm>
-            <a:off x="6748172" y="4446030"/>
-            <a:ext cx="1981197" cy="631547"/>
-          </a:xfrm>
-          <a:prstGeom prst="rect">
-            <a:avLst/>
-          </a:prstGeom>
-        </p:spPr>
-        <p:style>
-          <a:lnRef idx="2">
-            <a:schemeClr val="accent1">
-              <a:shade val="15000"/>
-            </a:schemeClr>
-          </a:lnRef>
-          <a:fillRef idx="1">
-            <a:schemeClr val="accent1"/>
-          </a:fillRef>
-          <a:effectRef idx="0">
-            <a:schemeClr val="accent1"/>
-          </a:effectRef>
-          <a:fontRef idx="minor">
-            <a:schemeClr val="lt1"/>
-          </a:fontRef>
-        </p:style>
-        <p:txBody>
-          <a:bodyPr rtlCol="0" anchor="ctr"/>
-          <a:lstStyle/>
-          <a:p>
-            <a:pPr algn="ctr"/>
-            <a:r>
-              <a:rPr lang="fr-FR" dirty="0"/>
-              <a:t>Peg du jour</a:t>
-            </a:r>
-          </a:p>
-          <a:p>
-            <a:pPr algn="ctr"/>
-            <a:r>
-              <a:rPr lang="fr-FR" dirty="0"/>
-              <a:t>Vs 7dernires jours</a:t>
-            </a:r>
-          </a:p>
-        </p:txBody>
-      </p:sp>
-      <p:sp>
-        <p:nvSpPr>
-          <p:cNvPr id="19" name="Rectangle 18">
-            <a:extLst>
-              <a:ext uri="{FF2B5EF4-FFF2-40B4-BE49-F238E27FC236}">
-                <a16:creationId xmlns:a16="http://schemas.microsoft.com/office/drawing/2014/main" id="{F4C3C6F4-59AA-372C-6EE9-AF9BAFB53123}"/>
-              </a:ext>
-            </a:extLst>
-          </p:cNvPr>
-          <p:cNvSpPr/>
-          <p:nvPr/>
-        </p:nvSpPr>
-        <p:spPr>
-          <a:xfrm>
-            <a:off x="9550026" y="4446030"/>
-            <a:ext cx="2315459" cy="631547"/>
-          </a:xfrm>
-          <a:prstGeom prst="rect">
-            <a:avLst/>
-          </a:prstGeom>
-        </p:spPr>
-        <p:style>
-          <a:lnRef idx="2">
-            <a:schemeClr val="accent1">
-              <a:shade val="15000"/>
-            </a:schemeClr>
-          </a:lnRef>
-          <a:fillRef idx="1">
-            <a:schemeClr val="accent1"/>
-          </a:fillRef>
-          <a:effectRef idx="0">
-            <a:schemeClr val="accent1"/>
-          </a:effectRef>
-          <a:fontRef idx="minor">
-            <a:schemeClr val="lt1"/>
-          </a:fontRef>
-        </p:style>
-        <p:txBody>
-          <a:bodyPr rtlCol="0" anchor="ctr"/>
-          <a:lstStyle/>
-          <a:p>
-            <a:pPr algn="ctr"/>
-            <a:r>
-              <a:rPr lang="fr-FR" dirty="0"/>
-              <a:t>CO2</a:t>
-            </a:r>
-          </a:p>
-          <a:p>
-            <a:pPr algn="ctr"/>
-            <a:r>
-              <a:rPr lang="fr-FR" dirty="0"/>
-              <a:t>Vs 7 derniers jours</a:t>
-            </a:r>
-          </a:p>
-        </p:txBody>
-      </p:sp>
-      <p:sp>
-        <p:nvSpPr>
-          <p:cNvPr id="20" name="Rectangle 19">
-            <a:extLst>
-              <a:ext uri="{FF2B5EF4-FFF2-40B4-BE49-F238E27FC236}">
-                <a16:creationId xmlns:a16="http://schemas.microsoft.com/office/drawing/2014/main" id="{DCD43213-6E2E-3F18-F644-103974EB4502}"/>
-              </a:ext>
-            </a:extLst>
-          </p:cNvPr>
-          <p:cNvSpPr/>
-          <p:nvPr/>
-        </p:nvSpPr>
-        <p:spPr>
-          <a:xfrm>
-            <a:off x="5453323" y="658167"/>
-            <a:ext cx="1406769" cy="1321149"/>
-          </a:xfrm>
-          <a:prstGeom prst="rect">
-            <a:avLst/>
-          </a:prstGeom>
-        </p:spPr>
-        <p:style>
-          <a:lnRef idx="2">
-            <a:schemeClr val="accent1">
-              <a:shade val="15000"/>
-            </a:schemeClr>
-          </a:lnRef>
-          <a:fillRef idx="1">
-            <a:schemeClr val="accent1"/>
-          </a:fillRef>
-          <a:effectRef idx="0">
-            <a:schemeClr val="accent1"/>
-          </a:effectRef>
-          <a:fontRef idx="minor">
-            <a:schemeClr val="lt1"/>
-          </a:fontRef>
-        </p:style>
-        <p:txBody>
-          <a:bodyPr rtlCol="0" anchor="ctr"/>
-          <a:lstStyle/>
-          <a:p>
-            <a:pPr algn="ctr"/>
+        <p:spPr/>
+        <p:txBody>
+          <a:bodyPr/>
+          <a:lstStyle/>
+          <a:p>
             <a:r>
               <a:rPr lang="fr-FR" dirty="0" err="1"/>
-              <a:t>Cogé</a:t>
-            </a:r>
-            <a:r>
-              <a:rPr lang="fr-FR" dirty="0"/>
-              <a:t> serre</a:t>
-            </a:r>
-          </a:p>
-          <a:p>
-            <a:pPr algn="ctr"/>
-            <a:r>
-              <a:rPr lang="fr-FR" dirty="0"/>
-              <a:t>Base</a:t>
-            </a:r>
-          </a:p>
-          <a:p>
-            <a:pPr algn="ctr"/>
-            <a:r>
-              <a:rPr lang="fr-FR" dirty="0"/>
-              <a:t>Peak</a:t>
-            </a:r>
-          </a:p>
-          <a:p>
-            <a:pPr algn="ctr"/>
-            <a:r>
-              <a:rPr lang="fr-FR" dirty="0"/>
-              <a:t>1,8 </a:t>
-            </a:r>
-          </a:p>
-        </p:txBody>
-      </p:sp>
-      <p:sp>
-        <p:nvSpPr>
-          <p:cNvPr id="21" name="Rectangle 20">
-            <a:extLst>
-              <a:ext uri="{FF2B5EF4-FFF2-40B4-BE49-F238E27FC236}">
-                <a16:creationId xmlns:a16="http://schemas.microsoft.com/office/drawing/2014/main" id="{ED0F5393-ABA6-5D46-298B-C8EC403AD580}"/>
-              </a:ext>
-            </a:extLst>
-          </p:cNvPr>
-          <p:cNvSpPr/>
-          <p:nvPr/>
-        </p:nvSpPr>
-        <p:spPr>
-          <a:xfrm>
-            <a:off x="296425" y="222990"/>
-            <a:ext cx="2069960" cy="703385"/>
-          </a:xfrm>
-          <a:prstGeom prst="rect">
-            <a:avLst/>
-          </a:prstGeom>
-        </p:spPr>
-        <p:style>
-          <a:lnRef idx="2">
-            <a:schemeClr val="accent1">
-              <a:shade val="15000"/>
-            </a:schemeClr>
-          </a:lnRef>
-          <a:fillRef idx="1">
-            <a:schemeClr val="accent1"/>
-          </a:fillRef>
-          <a:effectRef idx="0">
-            <a:schemeClr val="accent1"/>
-          </a:effectRef>
-          <a:fontRef idx="minor">
-            <a:schemeClr val="lt1"/>
-          </a:fontRef>
-        </p:style>
-        <p:txBody>
-          <a:bodyPr rtlCol="0" anchor="ctr"/>
-          <a:lstStyle/>
-          <a:p>
-            <a:pPr algn="ctr"/>
-            <a:r>
-              <a:rPr lang="fr-FR" dirty="0"/>
-              <a:t>Choisir les rendements?</a:t>
-            </a:r>
-          </a:p>
-          <a:p>
-            <a:pPr algn="ctr"/>
+              <a:t>Carouselle</a:t>
+            </a:r>
+            <a:r>
+              <a:rPr lang="fr-FR" dirty="0"/>
+              <a:t> sur la </a:t>
+            </a:r>
+            <a:r>
+              <a:rPr lang="fr-FR" dirty="0" err="1"/>
+              <a:t>téle</a:t>
+            </a:r>
             <a:endParaRPr lang="fr-FR" dirty="0"/>
           </a:p>
-        </p:txBody>
-      </p:sp>
-      <p:sp>
-        <p:nvSpPr>
-          <p:cNvPr id="23" name="Rectangle 22">
-            <a:extLst>
-              <a:ext uri="{FF2B5EF4-FFF2-40B4-BE49-F238E27FC236}">
-                <a16:creationId xmlns:a16="http://schemas.microsoft.com/office/drawing/2014/main" id="{6AA87551-7BE9-EDDA-0CA3-09610BF807C9}"/>
-              </a:ext>
-            </a:extLst>
-          </p:cNvPr>
-          <p:cNvSpPr/>
-          <p:nvPr/>
-        </p:nvSpPr>
-        <p:spPr>
-          <a:xfrm>
-            <a:off x="5453323" y="2262359"/>
-            <a:ext cx="1406769" cy="1166641"/>
-          </a:xfrm>
-          <a:prstGeom prst="rect">
-            <a:avLst/>
-          </a:prstGeom>
-        </p:spPr>
-        <p:style>
-          <a:lnRef idx="2">
-            <a:schemeClr val="accent1">
-              <a:shade val="15000"/>
-            </a:schemeClr>
-          </a:lnRef>
-          <a:fillRef idx="1">
-            <a:schemeClr val="accent1"/>
-          </a:fillRef>
-          <a:effectRef idx="0">
-            <a:schemeClr val="accent1"/>
-          </a:effectRef>
-          <a:fontRef idx="minor">
-            <a:schemeClr val="lt1"/>
-          </a:fontRef>
-        </p:style>
-        <p:txBody>
-          <a:bodyPr rtlCol="0" anchor="ctr"/>
-          <a:lstStyle/>
-          <a:p>
-            <a:pPr algn="ctr"/>
+          <a:p>
+            <a:endParaRPr lang="fr-FR" dirty="0"/>
+          </a:p>
+          <a:p>
+            <a:r>
+              <a:rPr lang="fr-FR" dirty="0"/>
+              <a:t>Disponibilité du nucléaire et </a:t>
+            </a:r>
             <a:r>
               <a:rPr lang="fr-FR" dirty="0" err="1"/>
-              <a:t>Cogé</a:t>
-            </a:r>
-            <a:r>
-              <a:rPr lang="fr-FR" dirty="0"/>
-              <a:t> indus</a:t>
-            </a:r>
-          </a:p>
-          <a:p>
-            <a:pPr algn="ctr"/>
-            <a:r>
-              <a:rPr lang="fr-FR" dirty="0"/>
-              <a:t>Base</a:t>
-            </a:r>
-          </a:p>
-          <a:p>
-            <a:pPr algn="ctr"/>
-            <a:r>
-              <a:rPr lang="fr-FR" dirty="0"/>
-              <a:t>Peak </a:t>
-            </a:r>
-          </a:p>
-          <a:p>
-            <a:pPr algn="ctr"/>
-            <a:r>
-              <a:rPr lang="fr-FR" dirty="0"/>
-              <a:t>2,2</a:t>
-            </a:r>
-          </a:p>
-        </p:txBody>
-      </p:sp>
-      <p:sp>
-        <p:nvSpPr>
-          <p:cNvPr id="24" name="Rectangle 23">
-            <a:extLst>
-              <a:ext uri="{FF2B5EF4-FFF2-40B4-BE49-F238E27FC236}">
-                <a16:creationId xmlns:a16="http://schemas.microsoft.com/office/drawing/2014/main" id="{2AE4F717-A388-4800-26AD-405D6E5025B4}"/>
-              </a:ext>
-            </a:extLst>
-          </p:cNvPr>
-          <p:cNvSpPr/>
-          <p:nvPr/>
-        </p:nvSpPr>
-        <p:spPr>
-          <a:xfrm>
-            <a:off x="6748172" y="5198257"/>
-            <a:ext cx="5117313" cy="699624"/>
-          </a:xfrm>
-          <a:prstGeom prst="rect">
-            <a:avLst/>
-          </a:prstGeom>
-        </p:spPr>
-        <p:style>
-          <a:lnRef idx="2">
-            <a:schemeClr val="accent1">
-              <a:shade val="15000"/>
-            </a:schemeClr>
-          </a:lnRef>
-          <a:fillRef idx="1">
-            <a:schemeClr val="accent1"/>
-          </a:fillRef>
-          <a:effectRef idx="0">
-            <a:schemeClr val="accent1"/>
-          </a:effectRef>
-          <a:fontRef idx="minor">
-            <a:schemeClr val="lt1"/>
-          </a:fontRef>
-        </p:style>
-        <p:txBody>
-          <a:bodyPr rtlCol="0" anchor="ctr"/>
-          <a:lstStyle/>
-          <a:p>
-            <a:pPr algn="ctr"/>
-            <a:r>
-              <a:rPr lang="fr-FR" dirty="0"/>
-              <a:t>Base </a:t>
-            </a:r>
-            <a:r>
-              <a:rPr lang="fr-FR" dirty="0" err="1"/>
-              <a:t>peak</a:t>
-            </a:r>
-            <a:r>
-              <a:rPr lang="fr-FR" dirty="0"/>
-              <a:t> M+1 M+2 Q+1 serre</a:t>
-            </a:r>
-          </a:p>
-        </p:txBody>
-      </p:sp>
-      <p:sp>
-        <p:nvSpPr>
-          <p:cNvPr id="26" name="Rectangle 25">
-            <a:extLst>
-              <a:ext uri="{FF2B5EF4-FFF2-40B4-BE49-F238E27FC236}">
-                <a16:creationId xmlns:a16="http://schemas.microsoft.com/office/drawing/2014/main" id="{D9FEA2F4-9AF2-0D71-DD0A-AAECC0EF8922}"/>
-              </a:ext>
-            </a:extLst>
-          </p:cNvPr>
-          <p:cNvSpPr/>
-          <p:nvPr/>
-        </p:nvSpPr>
-        <p:spPr>
-          <a:xfrm>
-            <a:off x="6748172" y="5950483"/>
-            <a:ext cx="5117313" cy="699624"/>
-          </a:xfrm>
-          <a:prstGeom prst="rect">
-            <a:avLst/>
-          </a:prstGeom>
-        </p:spPr>
-        <p:style>
-          <a:lnRef idx="2">
-            <a:schemeClr val="accent1">
-              <a:shade val="15000"/>
-            </a:schemeClr>
-          </a:lnRef>
-          <a:fillRef idx="1">
-            <a:schemeClr val="accent1"/>
-          </a:fillRef>
-          <a:effectRef idx="0">
-            <a:schemeClr val="accent1"/>
-          </a:effectRef>
-          <a:fontRef idx="minor">
-            <a:schemeClr val="lt1"/>
-          </a:fontRef>
-        </p:style>
-        <p:txBody>
-          <a:bodyPr rtlCol="0" anchor="ctr"/>
-          <a:lstStyle/>
-          <a:p>
-            <a:pPr algn="ctr"/>
-            <a:r>
-              <a:rPr lang="fr-FR" dirty="0"/>
-              <a:t>Base </a:t>
-            </a:r>
-            <a:r>
-              <a:rPr lang="fr-FR" dirty="0" err="1"/>
-              <a:t>peak</a:t>
-            </a:r>
-            <a:r>
-              <a:rPr lang="fr-FR" dirty="0"/>
-              <a:t> M+1 M+2 Q+1 indus</a:t>
-            </a:r>
+              <a:t>ccg</a:t>
+            </a:r>
+            <a:endParaRPr lang="fr-FR" dirty="0"/>
           </a:p>
         </p:txBody>
       </p:sp>
     </p:spTree>
     <p:extLst>
       <p:ext uri="{BB962C8B-B14F-4D97-AF65-F5344CB8AC3E}">
-        <p14:creationId xmlns:p14="http://schemas.microsoft.com/office/powerpoint/2010/main" val="3235114641"/>
+        <p14:creationId xmlns:p14="http://schemas.microsoft.com/office/powerpoint/2010/main" val="2021926209"/>
       </p:ext>
     </p:extLst>
   </p:cSld>
@@ -4938,6 +5903,915 @@
           <p:cNvPr id="2" name="Titre 1">
             <a:extLst>
               <a:ext uri="{FF2B5EF4-FFF2-40B4-BE49-F238E27FC236}">
+                <a16:creationId xmlns:a16="http://schemas.microsoft.com/office/drawing/2014/main" id="{24167CB6-DF6E-AEAB-B0AD-6BDC6FB984BE}"/>
+              </a:ext>
+            </a:extLst>
+          </p:cNvPr>
+          <p:cNvSpPr>
+            <a:spLocks noGrp="1"/>
+          </p:cNvSpPr>
+          <p:nvPr>
+            <p:ph type="title"/>
+          </p:nvPr>
+        </p:nvSpPr>
+        <p:spPr/>
+        <p:txBody>
+          <a:bodyPr/>
+          <a:lstStyle/>
+          <a:p>
+            <a:endParaRPr lang="fr-FR" dirty="0"/>
+          </a:p>
+        </p:txBody>
+      </p:sp>
+      <p:sp>
+        <p:nvSpPr>
+          <p:cNvPr id="4" name="Rectangle 3">
+            <a:extLst>
+              <a:ext uri="{FF2B5EF4-FFF2-40B4-BE49-F238E27FC236}">
+                <a16:creationId xmlns:a16="http://schemas.microsoft.com/office/drawing/2014/main" id="{1B0C0160-F03D-7BB6-9B60-68BD48B0762C}"/>
+              </a:ext>
+            </a:extLst>
+          </p:cNvPr>
+          <p:cNvSpPr/>
+          <p:nvPr/>
+        </p:nvSpPr>
+        <p:spPr>
+          <a:xfrm>
+            <a:off x="8189406" y="365126"/>
+            <a:ext cx="2803491" cy="629662"/>
+          </a:xfrm>
+          <a:prstGeom prst="rect">
+            <a:avLst/>
+          </a:prstGeom>
+        </p:spPr>
+        <p:style>
+          <a:lnRef idx="2">
+            <a:schemeClr val="accent1">
+              <a:shade val="15000"/>
+            </a:schemeClr>
+          </a:lnRef>
+          <a:fillRef idx="1">
+            <a:schemeClr val="accent1"/>
+          </a:fillRef>
+          <a:effectRef idx="0">
+            <a:schemeClr val="accent1"/>
+          </a:effectRef>
+          <a:fontRef idx="minor">
+            <a:schemeClr val="lt1"/>
+          </a:fontRef>
+        </p:style>
+        <p:txBody>
+          <a:bodyPr rtlCol="0" anchor="ctr"/>
+          <a:lstStyle/>
+          <a:p>
+            <a:pPr algn="ctr"/>
+            <a:r>
+              <a:rPr lang="fr-FR" dirty="0"/>
+              <a:t>Spark-spread </a:t>
+            </a:r>
+          </a:p>
+        </p:txBody>
+      </p:sp>
+      <p:sp>
+        <p:nvSpPr>
+          <p:cNvPr id="6" name="Rectangle 5">
+            <a:extLst>
+              <a:ext uri="{FF2B5EF4-FFF2-40B4-BE49-F238E27FC236}">
+                <a16:creationId xmlns:a16="http://schemas.microsoft.com/office/drawing/2014/main" id="{6FDA8550-54D3-BCFE-061C-90769C5311AE}"/>
+              </a:ext>
+            </a:extLst>
+          </p:cNvPr>
+          <p:cNvSpPr/>
+          <p:nvPr/>
+        </p:nvSpPr>
+        <p:spPr>
+          <a:xfrm>
+            <a:off x="8189406" y="2173575"/>
+            <a:ext cx="2803491" cy="920175"/>
+          </a:xfrm>
+          <a:prstGeom prst="rect">
+            <a:avLst/>
+          </a:prstGeom>
+        </p:spPr>
+        <p:style>
+          <a:lnRef idx="2">
+            <a:schemeClr val="accent1">
+              <a:shade val="15000"/>
+            </a:schemeClr>
+          </a:lnRef>
+          <a:fillRef idx="1">
+            <a:schemeClr val="accent1"/>
+          </a:fillRef>
+          <a:effectRef idx="0">
+            <a:schemeClr val="accent1"/>
+          </a:effectRef>
+          <a:fontRef idx="minor">
+            <a:schemeClr val="lt1"/>
+          </a:fontRef>
+        </p:style>
+        <p:txBody>
+          <a:bodyPr rtlCol="0" anchor="ctr"/>
+          <a:lstStyle/>
+          <a:p>
+            <a:pPr algn="ctr"/>
+            <a:endParaRPr lang="fr-FR" dirty="0"/>
+          </a:p>
+        </p:txBody>
+      </p:sp>
+      <p:sp>
+        <p:nvSpPr>
+          <p:cNvPr id="8" name="Rectangle 7">
+            <a:extLst>
+              <a:ext uri="{FF2B5EF4-FFF2-40B4-BE49-F238E27FC236}">
+                <a16:creationId xmlns:a16="http://schemas.microsoft.com/office/drawing/2014/main" id="{C5D7E445-750A-A988-EADB-36671FDD7FA5}"/>
+              </a:ext>
+            </a:extLst>
+          </p:cNvPr>
+          <p:cNvSpPr/>
+          <p:nvPr/>
+        </p:nvSpPr>
+        <p:spPr>
+          <a:xfrm>
+            <a:off x="157425" y="4467486"/>
+            <a:ext cx="2803491" cy="920176"/>
+          </a:xfrm>
+          <a:prstGeom prst="rect">
+            <a:avLst/>
+          </a:prstGeom>
+        </p:spPr>
+        <p:style>
+          <a:lnRef idx="2">
+            <a:schemeClr val="accent1">
+              <a:shade val="15000"/>
+            </a:schemeClr>
+          </a:lnRef>
+          <a:fillRef idx="1">
+            <a:schemeClr val="accent1"/>
+          </a:fillRef>
+          <a:effectRef idx="0">
+            <a:schemeClr val="accent1"/>
+          </a:effectRef>
+          <a:fontRef idx="minor">
+            <a:schemeClr val="lt1"/>
+          </a:fontRef>
+        </p:style>
+        <p:txBody>
+          <a:bodyPr rtlCol="0" anchor="ctr"/>
+          <a:lstStyle/>
+          <a:p>
+            <a:pPr algn="ctr"/>
+            <a:r>
+              <a:rPr lang="fr-FR" dirty="0"/>
+              <a:t>NB de jours PP/22</a:t>
+            </a:r>
+          </a:p>
+        </p:txBody>
+      </p:sp>
+      <p:sp>
+        <p:nvSpPr>
+          <p:cNvPr id="10" name="Rectangle 9">
+            <a:extLst>
+              <a:ext uri="{FF2B5EF4-FFF2-40B4-BE49-F238E27FC236}">
+                <a16:creationId xmlns:a16="http://schemas.microsoft.com/office/drawing/2014/main" id="{06AF5FCC-81CF-9BF9-D7C5-DF187F1BAA8C}"/>
+              </a:ext>
+            </a:extLst>
+          </p:cNvPr>
+          <p:cNvSpPr/>
+          <p:nvPr/>
+        </p:nvSpPr>
+        <p:spPr>
+          <a:xfrm>
+            <a:off x="157424" y="365124"/>
+            <a:ext cx="5938576" cy="3960228"/>
+          </a:xfrm>
+          <a:prstGeom prst="rect">
+            <a:avLst/>
+          </a:prstGeom>
+        </p:spPr>
+        <p:style>
+          <a:lnRef idx="2">
+            <a:schemeClr val="accent1">
+              <a:shade val="15000"/>
+            </a:schemeClr>
+          </a:lnRef>
+          <a:fillRef idx="1">
+            <a:schemeClr val="accent1"/>
+          </a:fillRef>
+          <a:effectRef idx="0">
+            <a:schemeClr val="accent1"/>
+          </a:effectRef>
+          <a:fontRef idx="minor">
+            <a:schemeClr val="lt1"/>
+          </a:fontRef>
+        </p:style>
+        <p:txBody>
+          <a:bodyPr rtlCol="0" anchor="ctr"/>
+          <a:lstStyle/>
+          <a:p>
+            <a:pPr algn="ctr"/>
+            <a:r>
+              <a:rPr lang="fr-FR" dirty="0"/>
+              <a:t>Courbe </a:t>
+            </a:r>
+            <a:r>
+              <a:rPr lang="fr-FR" dirty="0" err="1"/>
+              <a:t>spark</a:t>
+            </a:r>
+            <a:r>
+              <a:rPr lang="fr-FR" dirty="0"/>
+              <a:t> spread *3 rendements</a:t>
+            </a:r>
+          </a:p>
+          <a:p>
+            <a:pPr algn="ctr"/>
+            <a:r>
+              <a:rPr lang="fr-FR" dirty="0"/>
+              <a:t>1,8</a:t>
+            </a:r>
+          </a:p>
+          <a:p>
+            <a:pPr algn="ctr"/>
+            <a:r>
+              <a:rPr lang="fr-FR" dirty="0"/>
+              <a:t>2,2</a:t>
+            </a:r>
+          </a:p>
+          <a:p>
+            <a:pPr algn="ctr"/>
+            <a:r>
+              <a:rPr lang="fr-FR" dirty="0"/>
+              <a:t>3,2</a:t>
+            </a:r>
+          </a:p>
+        </p:txBody>
+      </p:sp>
+      <p:sp>
+        <p:nvSpPr>
+          <p:cNvPr id="12" name="Rectangle 11">
+            <a:extLst>
+              <a:ext uri="{FF2B5EF4-FFF2-40B4-BE49-F238E27FC236}">
+                <a16:creationId xmlns:a16="http://schemas.microsoft.com/office/drawing/2014/main" id="{8786F3C1-0787-E66A-848E-955B90C792F9}"/>
+              </a:ext>
+            </a:extLst>
+          </p:cNvPr>
+          <p:cNvSpPr/>
+          <p:nvPr/>
+        </p:nvSpPr>
+        <p:spPr>
+          <a:xfrm>
+            <a:off x="6297807" y="365124"/>
+            <a:ext cx="5938576" cy="3960228"/>
+          </a:xfrm>
+          <a:prstGeom prst="rect">
+            <a:avLst/>
+          </a:prstGeom>
+        </p:spPr>
+        <p:style>
+          <a:lnRef idx="2">
+            <a:schemeClr val="accent1">
+              <a:shade val="15000"/>
+            </a:schemeClr>
+          </a:lnRef>
+          <a:fillRef idx="1">
+            <a:schemeClr val="accent1"/>
+          </a:fillRef>
+          <a:effectRef idx="0">
+            <a:schemeClr val="accent1"/>
+          </a:effectRef>
+          <a:fontRef idx="minor">
+            <a:schemeClr val="lt1"/>
+          </a:fontRef>
+        </p:style>
+        <p:txBody>
+          <a:bodyPr rtlCol="0" anchor="ctr"/>
+          <a:lstStyle/>
+          <a:p>
+            <a:pPr algn="ctr"/>
+            <a:r>
+              <a:rPr lang="fr-FR" dirty="0"/>
+              <a:t>Courbe Clean </a:t>
+            </a:r>
+            <a:r>
+              <a:rPr lang="fr-FR" dirty="0" err="1"/>
+              <a:t>spark</a:t>
+            </a:r>
+            <a:r>
+              <a:rPr lang="fr-FR" dirty="0"/>
+              <a:t> spread *3 rendements</a:t>
+            </a:r>
+          </a:p>
+          <a:p>
+            <a:pPr algn="ctr"/>
+            <a:r>
+              <a:rPr lang="fr-FR" dirty="0"/>
+              <a:t>1,8</a:t>
+            </a:r>
+          </a:p>
+          <a:p>
+            <a:pPr algn="ctr"/>
+            <a:r>
+              <a:rPr lang="fr-FR" dirty="0"/>
+              <a:t>2,2</a:t>
+            </a:r>
+          </a:p>
+          <a:p>
+            <a:pPr algn="ctr"/>
+            <a:r>
+              <a:rPr lang="fr-FR" dirty="0"/>
+              <a:t>3,2</a:t>
+            </a:r>
+          </a:p>
+          <a:p>
+            <a:pPr algn="ctr"/>
+            <a:endParaRPr lang="fr-FR" dirty="0"/>
+          </a:p>
+          <a:p>
+            <a:pPr algn="ctr"/>
+            <a:r>
+              <a:rPr lang="fr-FR" dirty="0"/>
+              <a:t>+0,185*co2</a:t>
+            </a:r>
+          </a:p>
+        </p:txBody>
+      </p:sp>
+      <p:sp>
+        <p:nvSpPr>
+          <p:cNvPr id="14" name="Rectangle 13">
+            <a:extLst>
+              <a:ext uri="{FF2B5EF4-FFF2-40B4-BE49-F238E27FC236}">
+                <a16:creationId xmlns:a16="http://schemas.microsoft.com/office/drawing/2014/main" id="{816291A1-7B8E-9638-9B09-43AD346292A9}"/>
+              </a:ext>
+            </a:extLst>
+          </p:cNvPr>
+          <p:cNvSpPr/>
+          <p:nvPr/>
+        </p:nvSpPr>
+        <p:spPr>
+          <a:xfrm>
+            <a:off x="157424" y="5398921"/>
+            <a:ext cx="2803491" cy="920176"/>
+          </a:xfrm>
+          <a:prstGeom prst="rect">
+            <a:avLst/>
+          </a:prstGeom>
+          <a:solidFill>
+            <a:schemeClr val="accent2"/>
+          </a:solidFill>
+        </p:spPr>
+        <p:style>
+          <a:lnRef idx="2">
+            <a:schemeClr val="accent1">
+              <a:shade val="15000"/>
+            </a:schemeClr>
+          </a:lnRef>
+          <a:fillRef idx="1">
+            <a:schemeClr val="accent1"/>
+          </a:fillRef>
+          <a:effectRef idx="0">
+            <a:schemeClr val="accent1"/>
+          </a:effectRef>
+          <a:fontRef idx="minor">
+            <a:schemeClr val="lt1"/>
+          </a:fontRef>
+        </p:style>
+        <p:txBody>
+          <a:bodyPr rtlCol="0" anchor="ctr"/>
+          <a:lstStyle/>
+          <a:p>
+            <a:pPr algn="ctr"/>
+            <a:r>
+              <a:rPr lang="fr-FR" dirty="0"/>
+              <a:t>On est en PP</a:t>
+            </a:r>
+          </a:p>
+        </p:txBody>
+      </p:sp>
+      <p:sp>
+        <p:nvSpPr>
+          <p:cNvPr id="16" name="Espace réservé du contenu 15">
+            <a:extLst>
+              <a:ext uri="{FF2B5EF4-FFF2-40B4-BE49-F238E27FC236}">
+                <a16:creationId xmlns:a16="http://schemas.microsoft.com/office/drawing/2014/main" id="{A5CA299F-B19F-30AF-6A78-A1D1B6BFB50D}"/>
+              </a:ext>
+            </a:extLst>
+          </p:cNvPr>
+          <p:cNvSpPr>
+            <a:spLocks noGrp="1"/>
+          </p:cNvSpPr>
+          <p:nvPr>
+            <p:ph idx="1"/>
+          </p:nvPr>
+        </p:nvSpPr>
+        <p:spPr>
+          <a:xfrm>
+            <a:off x="3228169" y="4496809"/>
+            <a:ext cx="3309791" cy="1822287"/>
+          </a:xfrm>
+          <a:prstGeom prst="rect">
+            <a:avLst/>
+          </a:prstGeom>
+        </p:spPr>
+        <p:style>
+          <a:lnRef idx="2">
+            <a:schemeClr val="accent1">
+              <a:shade val="15000"/>
+            </a:schemeClr>
+          </a:lnRef>
+          <a:fillRef idx="1">
+            <a:schemeClr val="accent1"/>
+          </a:fillRef>
+          <a:effectRef idx="0">
+            <a:schemeClr val="accent1"/>
+          </a:effectRef>
+          <a:fontRef idx="minor">
+            <a:schemeClr val="lt1"/>
+          </a:fontRef>
+        </p:style>
+        <p:txBody>
+          <a:bodyPr rtlCol="0" anchor="ctr">
+            <a:normAutofit/>
+          </a:bodyPr>
+          <a:lstStyle/>
+          <a:p>
+            <a:pPr algn="ctr"/>
+            <a:r>
+              <a:rPr lang="fr-FR" dirty="0"/>
+              <a:t>MFRR hausse +baisse</a:t>
+            </a:r>
+          </a:p>
+          <a:p>
+            <a:pPr marL="0" indent="0" algn="ctr">
+              <a:buNone/>
+            </a:pPr>
+            <a:r>
+              <a:rPr lang="fr-FR" dirty="0"/>
+              <a:t>(vs la saison précédente)</a:t>
+            </a:r>
+          </a:p>
+        </p:txBody>
+      </p:sp>
+      <p:sp>
+        <p:nvSpPr>
+          <p:cNvPr id="17" name="Rectangle 16">
+            <a:extLst>
+              <a:ext uri="{FF2B5EF4-FFF2-40B4-BE49-F238E27FC236}">
+                <a16:creationId xmlns:a16="http://schemas.microsoft.com/office/drawing/2014/main" id="{95649D35-BCF5-72FD-6D49-A3333C4ADF6F}"/>
+              </a:ext>
+            </a:extLst>
+          </p:cNvPr>
+          <p:cNvSpPr/>
+          <p:nvPr/>
+        </p:nvSpPr>
+        <p:spPr>
+          <a:xfrm>
+            <a:off x="6748172" y="4446030"/>
+            <a:ext cx="1981197" cy="631547"/>
+          </a:xfrm>
+          <a:prstGeom prst="rect">
+            <a:avLst/>
+          </a:prstGeom>
+        </p:spPr>
+        <p:style>
+          <a:lnRef idx="2">
+            <a:schemeClr val="accent1">
+              <a:shade val="15000"/>
+            </a:schemeClr>
+          </a:lnRef>
+          <a:fillRef idx="1">
+            <a:schemeClr val="accent1"/>
+          </a:fillRef>
+          <a:effectRef idx="0">
+            <a:schemeClr val="accent1"/>
+          </a:effectRef>
+          <a:fontRef idx="minor">
+            <a:schemeClr val="lt1"/>
+          </a:fontRef>
+        </p:style>
+        <p:txBody>
+          <a:bodyPr rtlCol="0" anchor="ctr"/>
+          <a:lstStyle/>
+          <a:p>
+            <a:pPr algn="ctr"/>
+            <a:r>
+              <a:rPr lang="fr-FR" dirty="0"/>
+              <a:t>Peg du jour</a:t>
+            </a:r>
+          </a:p>
+          <a:p>
+            <a:pPr algn="ctr"/>
+            <a:r>
+              <a:rPr lang="fr-FR" dirty="0"/>
+              <a:t>Vs 7dernires jours</a:t>
+            </a:r>
+          </a:p>
+        </p:txBody>
+      </p:sp>
+      <p:sp>
+        <p:nvSpPr>
+          <p:cNvPr id="19" name="Rectangle 18">
+            <a:extLst>
+              <a:ext uri="{FF2B5EF4-FFF2-40B4-BE49-F238E27FC236}">
+                <a16:creationId xmlns:a16="http://schemas.microsoft.com/office/drawing/2014/main" id="{F4C3C6F4-59AA-372C-6EE9-AF9BAFB53123}"/>
+              </a:ext>
+            </a:extLst>
+          </p:cNvPr>
+          <p:cNvSpPr/>
+          <p:nvPr/>
+        </p:nvSpPr>
+        <p:spPr>
+          <a:xfrm>
+            <a:off x="9550026" y="4446030"/>
+            <a:ext cx="2315459" cy="631547"/>
+          </a:xfrm>
+          <a:prstGeom prst="rect">
+            <a:avLst/>
+          </a:prstGeom>
+        </p:spPr>
+        <p:style>
+          <a:lnRef idx="2">
+            <a:schemeClr val="accent1">
+              <a:shade val="15000"/>
+            </a:schemeClr>
+          </a:lnRef>
+          <a:fillRef idx="1">
+            <a:schemeClr val="accent1"/>
+          </a:fillRef>
+          <a:effectRef idx="0">
+            <a:schemeClr val="accent1"/>
+          </a:effectRef>
+          <a:fontRef idx="minor">
+            <a:schemeClr val="lt1"/>
+          </a:fontRef>
+        </p:style>
+        <p:txBody>
+          <a:bodyPr rtlCol="0" anchor="ctr"/>
+          <a:lstStyle/>
+          <a:p>
+            <a:pPr algn="ctr"/>
+            <a:r>
+              <a:rPr lang="fr-FR" dirty="0"/>
+              <a:t>CO2</a:t>
+            </a:r>
+          </a:p>
+          <a:p>
+            <a:pPr algn="ctr"/>
+            <a:r>
+              <a:rPr lang="fr-FR" dirty="0"/>
+              <a:t>Vs 7 derniers jours</a:t>
+            </a:r>
+          </a:p>
+        </p:txBody>
+      </p:sp>
+      <p:sp>
+        <p:nvSpPr>
+          <p:cNvPr id="20" name="Rectangle 19">
+            <a:extLst>
+              <a:ext uri="{FF2B5EF4-FFF2-40B4-BE49-F238E27FC236}">
+                <a16:creationId xmlns:a16="http://schemas.microsoft.com/office/drawing/2014/main" id="{DCD43213-6E2E-3F18-F644-103974EB4502}"/>
+              </a:ext>
+            </a:extLst>
+          </p:cNvPr>
+          <p:cNvSpPr/>
+          <p:nvPr/>
+        </p:nvSpPr>
+        <p:spPr>
+          <a:xfrm>
+            <a:off x="5453323" y="658167"/>
+            <a:ext cx="1406769" cy="1321149"/>
+          </a:xfrm>
+          <a:prstGeom prst="rect">
+            <a:avLst/>
+          </a:prstGeom>
+        </p:spPr>
+        <p:style>
+          <a:lnRef idx="2">
+            <a:schemeClr val="accent1">
+              <a:shade val="15000"/>
+            </a:schemeClr>
+          </a:lnRef>
+          <a:fillRef idx="1">
+            <a:schemeClr val="accent1"/>
+          </a:fillRef>
+          <a:effectRef idx="0">
+            <a:schemeClr val="accent1"/>
+          </a:effectRef>
+          <a:fontRef idx="minor">
+            <a:schemeClr val="lt1"/>
+          </a:fontRef>
+        </p:style>
+        <p:txBody>
+          <a:bodyPr rtlCol="0" anchor="ctr"/>
+          <a:lstStyle/>
+          <a:p>
+            <a:pPr algn="ctr"/>
+            <a:r>
+              <a:rPr lang="fr-FR" dirty="0" err="1"/>
+              <a:t>Cogé</a:t>
+            </a:r>
+            <a:r>
+              <a:rPr lang="fr-FR" dirty="0"/>
+              <a:t> serre</a:t>
+            </a:r>
+          </a:p>
+          <a:p>
+            <a:pPr algn="ctr"/>
+            <a:r>
+              <a:rPr lang="fr-FR" dirty="0"/>
+              <a:t>Base</a:t>
+            </a:r>
+          </a:p>
+          <a:p>
+            <a:pPr algn="ctr"/>
+            <a:r>
+              <a:rPr lang="fr-FR" dirty="0"/>
+              <a:t>Peak</a:t>
+            </a:r>
+          </a:p>
+          <a:p>
+            <a:pPr algn="ctr"/>
+            <a:r>
+              <a:rPr lang="fr-FR" dirty="0"/>
+              <a:t>1,8 </a:t>
+            </a:r>
+          </a:p>
+        </p:txBody>
+      </p:sp>
+      <p:sp>
+        <p:nvSpPr>
+          <p:cNvPr id="21" name="Rectangle 20">
+            <a:extLst>
+              <a:ext uri="{FF2B5EF4-FFF2-40B4-BE49-F238E27FC236}">
+                <a16:creationId xmlns:a16="http://schemas.microsoft.com/office/drawing/2014/main" id="{ED0F5393-ABA6-5D46-298B-C8EC403AD580}"/>
+              </a:ext>
+            </a:extLst>
+          </p:cNvPr>
+          <p:cNvSpPr/>
+          <p:nvPr/>
+        </p:nvSpPr>
+        <p:spPr>
+          <a:xfrm>
+            <a:off x="296425" y="222990"/>
+            <a:ext cx="2069960" cy="703385"/>
+          </a:xfrm>
+          <a:prstGeom prst="rect">
+            <a:avLst/>
+          </a:prstGeom>
+        </p:spPr>
+        <p:style>
+          <a:lnRef idx="2">
+            <a:schemeClr val="accent1">
+              <a:shade val="15000"/>
+            </a:schemeClr>
+          </a:lnRef>
+          <a:fillRef idx="1">
+            <a:schemeClr val="accent1"/>
+          </a:fillRef>
+          <a:effectRef idx="0">
+            <a:schemeClr val="accent1"/>
+          </a:effectRef>
+          <a:fontRef idx="minor">
+            <a:schemeClr val="lt1"/>
+          </a:fontRef>
+        </p:style>
+        <p:txBody>
+          <a:bodyPr rtlCol="0" anchor="ctr"/>
+          <a:lstStyle/>
+          <a:p>
+            <a:pPr algn="ctr"/>
+            <a:r>
+              <a:rPr lang="fr-FR" dirty="0"/>
+              <a:t>Choisir les rendements?</a:t>
+            </a:r>
+          </a:p>
+          <a:p>
+            <a:pPr algn="ctr"/>
+            <a:endParaRPr lang="fr-FR" dirty="0"/>
+          </a:p>
+        </p:txBody>
+      </p:sp>
+      <p:sp>
+        <p:nvSpPr>
+          <p:cNvPr id="23" name="Rectangle 22">
+            <a:extLst>
+              <a:ext uri="{FF2B5EF4-FFF2-40B4-BE49-F238E27FC236}">
+                <a16:creationId xmlns:a16="http://schemas.microsoft.com/office/drawing/2014/main" id="{6AA87551-7BE9-EDDA-0CA3-09610BF807C9}"/>
+              </a:ext>
+            </a:extLst>
+          </p:cNvPr>
+          <p:cNvSpPr/>
+          <p:nvPr/>
+        </p:nvSpPr>
+        <p:spPr>
+          <a:xfrm>
+            <a:off x="5453323" y="2262359"/>
+            <a:ext cx="1406769" cy="1166641"/>
+          </a:xfrm>
+          <a:prstGeom prst="rect">
+            <a:avLst/>
+          </a:prstGeom>
+        </p:spPr>
+        <p:style>
+          <a:lnRef idx="2">
+            <a:schemeClr val="accent1">
+              <a:shade val="15000"/>
+            </a:schemeClr>
+          </a:lnRef>
+          <a:fillRef idx="1">
+            <a:schemeClr val="accent1"/>
+          </a:fillRef>
+          <a:effectRef idx="0">
+            <a:schemeClr val="accent1"/>
+          </a:effectRef>
+          <a:fontRef idx="minor">
+            <a:schemeClr val="lt1"/>
+          </a:fontRef>
+        </p:style>
+        <p:txBody>
+          <a:bodyPr rtlCol="0" anchor="ctr"/>
+          <a:lstStyle/>
+          <a:p>
+            <a:pPr algn="ctr"/>
+            <a:r>
+              <a:rPr lang="fr-FR" dirty="0" err="1"/>
+              <a:t>Cogé</a:t>
+            </a:r>
+            <a:r>
+              <a:rPr lang="fr-FR" dirty="0"/>
+              <a:t> indus</a:t>
+            </a:r>
+          </a:p>
+          <a:p>
+            <a:pPr algn="ctr"/>
+            <a:r>
+              <a:rPr lang="fr-FR" dirty="0"/>
+              <a:t>Base</a:t>
+            </a:r>
+          </a:p>
+          <a:p>
+            <a:pPr algn="ctr"/>
+            <a:r>
+              <a:rPr lang="fr-FR" dirty="0"/>
+              <a:t>Peak </a:t>
+            </a:r>
+          </a:p>
+          <a:p>
+            <a:pPr algn="ctr"/>
+            <a:r>
+              <a:rPr lang="fr-FR" dirty="0"/>
+              <a:t>2,2</a:t>
+            </a:r>
+          </a:p>
+        </p:txBody>
+      </p:sp>
+      <p:sp>
+        <p:nvSpPr>
+          <p:cNvPr id="24" name="Rectangle 23">
+            <a:extLst>
+              <a:ext uri="{FF2B5EF4-FFF2-40B4-BE49-F238E27FC236}">
+                <a16:creationId xmlns:a16="http://schemas.microsoft.com/office/drawing/2014/main" id="{2AE4F717-A388-4800-26AD-405D6E5025B4}"/>
+              </a:ext>
+            </a:extLst>
+          </p:cNvPr>
+          <p:cNvSpPr/>
+          <p:nvPr/>
+        </p:nvSpPr>
+        <p:spPr>
+          <a:xfrm>
+            <a:off x="6748172" y="5198257"/>
+            <a:ext cx="5117313" cy="699624"/>
+          </a:xfrm>
+          <a:prstGeom prst="rect">
+            <a:avLst/>
+          </a:prstGeom>
+        </p:spPr>
+        <p:style>
+          <a:lnRef idx="2">
+            <a:schemeClr val="accent1">
+              <a:shade val="15000"/>
+            </a:schemeClr>
+          </a:lnRef>
+          <a:fillRef idx="1">
+            <a:schemeClr val="accent1"/>
+          </a:fillRef>
+          <a:effectRef idx="0">
+            <a:schemeClr val="accent1"/>
+          </a:effectRef>
+          <a:fontRef idx="minor">
+            <a:schemeClr val="lt1"/>
+          </a:fontRef>
+        </p:style>
+        <p:txBody>
+          <a:bodyPr rtlCol="0" anchor="ctr"/>
+          <a:lstStyle/>
+          <a:p>
+            <a:pPr algn="ctr"/>
+            <a:r>
+              <a:rPr lang="fr-FR" dirty="0"/>
+              <a:t>Base </a:t>
+            </a:r>
+            <a:r>
+              <a:rPr lang="fr-FR" dirty="0" err="1"/>
+              <a:t>peak</a:t>
+            </a:r>
+            <a:r>
+              <a:rPr lang="fr-FR" dirty="0"/>
+              <a:t> M+1 M+2 Q+1 serre</a:t>
+            </a:r>
+          </a:p>
+        </p:txBody>
+      </p:sp>
+      <p:sp>
+        <p:nvSpPr>
+          <p:cNvPr id="26" name="Rectangle 25">
+            <a:extLst>
+              <a:ext uri="{FF2B5EF4-FFF2-40B4-BE49-F238E27FC236}">
+                <a16:creationId xmlns:a16="http://schemas.microsoft.com/office/drawing/2014/main" id="{D9FEA2F4-9AF2-0D71-DD0A-AAECC0EF8922}"/>
+              </a:ext>
+            </a:extLst>
+          </p:cNvPr>
+          <p:cNvSpPr/>
+          <p:nvPr/>
+        </p:nvSpPr>
+        <p:spPr>
+          <a:xfrm>
+            <a:off x="6748172" y="5950483"/>
+            <a:ext cx="5117313" cy="699624"/>
+          </a:xfrm>
+          <a:prstGeom prst="rect">
+            <a:avLst/>
+          </a:prstGeom>
+        </p:spPr>
+        <p:style>
+          <a:lnRef idx="2">
+            <a:schemeClr val="accent1">
+              <a:shade val="15000"/>
+            </a:schemeClr>
+          </a:lnRef>
+          <a:fillRef idx="1">
+            <a:schemeClr val="accent1"/>
+          </a:fillRef>
+          <a:effectRef idx="0">
+            <a:schemeClr val="accent1"/>
+          </a:effectRef>
+          <a:fontRef idx="minor">
+            <a:schemeClr val="lt1"/>
+          </a:fontRef>
+        </p:style>
+        <p:txBody>
+          <a:bodyPr rtlCol="0" anchor="ctr"/>
+          <a:lstStyle/>
+          <a:p>
+            <a:pPr algn="ctr"/>
+            <a:r>
+              <a:rPr lang="fr-FR" dirty="0"/>
+              <a:t>Base </a:t>
+            </a:r>
+            <a:r>
+              <a:rPr lang="fr-FR" dirty="0" err="1"/>
+              <a:t>peak</a:t>
+            </a:r>
+            <a:r>
+              <a:rPr lang="fr-FR" dirty="0"/>
+              <a:t> M+1 M+2 Q+1 indus</a:t>
+            </a:r>
+          </a:p>
+        </p:txBody>
+      </p:sp>
+    </p:spTree>
+    <p:extLst>
+      <p:ext uri="{BB962C8B-B14F-4D97-AF65-F5344CB8AC3E}">
+        <p14:creationId xmlns:p14="http://schemas.microsoft.com/office/powerpoint/2010/main" val="3235114641"/>
+      </p:ext>
+    </p:extLst>
+  </p:cSld>
+  <p:clrMapOvr>
+    <a:masterClrMapping/>
+  </p:clrMapOvr>
+</p:sld>
+</file>
+
+<file path=ppt/slides/slide5.xml><?xml version="1.0" encoding="utf-8"?>
+<p:sld xmlns:a="http://schemas.openxmlformats.org/drawingml/2006/main" xmlns:r="http://schemas.openxmlformats.org/officeDocument/2006/relationships" xmlns:p="http://schemas.openxmlformats.org/presentationml/2006/main">
+  <p:cSld>
+    <p:spTree>
+      <p:nvGrpSpPr>
+        <p:cNvPr id="1" name=""/>
+        <p:cNvGrpSpPr/>
+        <p:nvPr/>
+      </p:nvGrpSpPr>
+      <p:grpSpPr>
+        <a:xfrm>
+          <a:off x="0" y="0"/>
+          <a:ext cx="0" cy="0"/>
+          <a:chOff x="0" y="0"/>
+          <a:chExt cx="0" cy="0"/>
+        </a:xfrm>
+      </p:grpSpPr>
+      <p:sp>
+        <p:nvSpPr>
+          <p:cNvPr id="2" name="Titre 1">
+            <a:extLst>
+              <a:ext uri="{FF2B5EF4-FFF2-40B4-BE49-F238E27FC236}">
                 <a16:creationId xmlns:a16="http://schemas.microsoft.com/office/drawing/2014/main" id="{4CEDA65A-F7D8-95D0-31F3-01098CB458E2}"/>
               </a:ext>
             </a:extLst>
@@ -5361,7 +7235,7 @@
 </p:sld>
 </file>
 
-<file path=ppt/slides/slide5.xml><?xml version="1.0" encoding="utf-8"?>
+<file path=ppt/slides/slide6.xml><?xml version="1.0" encoding="utf-8"?>
 <p:sld xmlns:a="http://schemas.openxmlformats.org/drawingml/2006/main" xmlns:r="http://schemas.openxmlformats.org/officeDocument/2006/relationships" xmlns:p="http://schemas.openxmlformats.org/presentationml/2006/main">
   <p:cSld>
     <p:spTree>
@@ -6489,7 +8363,7 @@
 </p:sld>
 </file>
 
-<file path=ppt/slides/slide6.xml><?xml version="1.0" encoding="utf-8"?>
+<file path=ppt/slides/slide7.xml><?xml version="1.0" encoding="utf-8"?>
 <p:sld xmlns:a="http://schemas.openxmlformats.org/drawingml/2006/main" xmlns:r="http://schemas.openxmlformats.org/officeDocument/2006/relationships" xmlns:p="http://schemas.openxmlformats.org/presentationml/2006/main">
   <p:cSld>
     <p:spTree>

</xml_diff>

<commit_message>
version definitve du dashboard BESS?
</commit_message>
<xml_diff>
--- a/preprod dashboard.pptx
+++ b/preprod dashboard.pptx
@@ -7,11 +7,12 @@
   <p:sldIdLst>
     <p:sldId id="256" r:id="rId2"/>
     <p:sldId id="262" r:id="rId3"/>
-    <p:sldId id="257" r:id="rId4"/>
-    <p:sldId id="258" r:id="rId5"/>
-    <p:sldId id="260" r:id="rId6"/>
-    <p:sldId id="261" r:id="rId7"/>
-    <p:sldId id="259" r:id="rId8"/>
+    <p:sldId id="263" r:id="rId4"/>
+    <p:sldId id="257" r:id="rId5"/>
+    <p:sldId id="258" r:id="rId6"/>
+    <p:sldId id="260" r:id="rId7"/>
+    <p:sldId id="261" r:id="rId8"/>
+    <p:sldId id="259" r:id="rId9"/>
   </p:sldIdLst>
   <p:sldSz cx="12192000" cy="6858000"/>
   <p:notesSz cx="6858000" cy="9144000"/>
@@ -131,12 +132,12 @@
   <pc:docChgLst>
     <pc:chgData name="Clément  Blanchard" userId="bd1f2afb-49ba-4555-ba39-f89e4473a535" providerId="ADAL" clId="{AF93E1EF-7D80-4C6F-BC21-7CFB1D2CEA6B}"/>
     <pc:docChg chg="modSld">
-      <pc:chgData name="Clément  Blanchard" userId="bd1f2afb-49ba-4555-ba39-f89e4473a535" providerId="ADAL" clId="{AF93E1EF-7D80-4C6F-BC21-7CFB1D2CEA6B}" dt="2026-09-24T13:14:36.450" v="2" actId="767"/>
+      <pc:chgData name="Clément  Blanchard" userId="bd1f2afb-49ba-4555-ba39-f89e4473a535" providerId="ADAL" clId="{AF93E1EF-7D80-4C6F-BC21-7CFB1D2CEA6B}" dt="2026-09-24T13:38:02.617" v="3"/>
       <pc:docMkLst>
         <pc:docMk/>
       </pc:docMkLst>
-      <pc:sldChg chg="addSp modSp">
-        <pc:chgData name="Clément  Blanchard" userId="bd1f2afb-49ba-4555-ba39-f89e4473a535" providerId="ADAL" clId="{AF93E1EF-7D80-4C6F-BC21-7CFB1D2CEA6B}" dt="2026-09-24T13:14:36.450" v="2" actId="767"/>
+      <pc:sldChg chg="addSp delSp modSp">
+        <pc:chgData name="Clément  Blanchard" userId="bd1f2afb-49ba-4555-ba39-f89e4473a535" providerId="ADAL" clId="{AF93E1EF-7D80-4C6F-BC21-7CFB1D2CEA6B}" dt="2026-09-24T13:38:02.617" v="3"/>
         <pc:sldMkLst>
           <pc:docMk/>
           <pc:sldMk cId="2069241052" sldId="262"/>
@@ -149,8 +150,8 @@
             <ac:spMk id="35" creationId="{92C8D36C-5193-88C5-CB4C-097AD79046A6}"/>
           </ac:spMkLst>
         </pc:spChg>
-        <pc:spChg chg="add mod">
-          <ac:chgData name="Clément  Blanchard" userId="bd1f2afb-49ba-4555-ba39-f89e4473a535" providerId="ADAL" clId="{AF93E1EF-7D80-4C6F-BC21-7CFB1D2CEA6B}" dt="2026-09-24T13:14:36.450" v="2" actId="767"/>
+        <pc:spChg chg="add del mod">
+          <ac:chgData name="Clément  Blanchard" userId="bd1f2afb-49ba-4555-ba39-f89e4473a535" providerId="ADAL" clId="{AF93E1EF-7D80-4C6F-BC21-7CFB1D2CEA6B}" dt="2026-09-24T13:38:02.617" v="3"/>
           <ac:spMkLst>
             <pc:docMk/>
             <pc:sldMk cId="2069241052" sldId="262"/>
@@ -5714,38 +5715,6 @@
           </a:p>
         </p:txBody>
       </p:sp>
-      <p:sp>
-        <p:nvSpPr>
-          <p:cNvPr id="36" name="ZoneTexte 35">
-            <a:extLst>
-              <a:ext uri="{FF2B5EF4-FFF2-40B4-BE49-F238E27FC236}">
-                <a16:creationId xmlns:a16="http://schemas.microsoft.com/office/drawing/2014/main" id="{622A576C-D6D4-86DB-7C37-BF1BF6422B81}"/>
-              </a:ext>
-            </a:extLst>
-          </p:cNvPr>
-          <p:cNvSpPr txBox="1"/>
-          <p:nvPr/>
-        </p:nvSpPr>
-        <p:spPr>
-          <a:xfrm>
-            <a:off x="-179109" y="103695"/>
-            <a:ext cx="184731" cy="369332"/>
-          </a:xfrm>
-          <a:prstGeom prst="rect">
-            <a:avLst/>
-          </a:prstGeom>
-          <a:noFill/>
-        </p:spPr>
-        <p:txBody>
-          <a:bodyPr wrap="none" rtlCol="0">
-            <a:spAutoFit/>
-          </a:bodyPr>
-          <a:lstStyle/>
-          <a:p>
-            <a:endParaRPr lang="fr-FR"/>
-          </a:p>
-        </p:txBody>
-      </p:sp>
     </p:spTree>
     <p:extLst>
       <p:ext uri="{BB962C8B-B14F-4D97-AF65-F5344CB8AC3E}">
@@ -5781,7 +5750,7 @@
           <p:cNvPr id="2" name="Titre 1">
             <a:extLst>
               <a:ext uri="{FF2B5EF4-FFF2-40B4-BE49-F238E27FC236}">
-                <a16:creationId xmlns:a16="http://schemas.microsoft.com/office/drawing/2014/main" id="{D5E8CEF5-6E23-4004-9FE2-A86A1917E8E8}"/>
+                <a16:creationId xmlns:a16="http://schemas.microsoft.com/office/drawing/2014/main" id="{5E513659-E8AB-87A0-3709-D9B7A6843778}"/>
               </a:ext>
             </a:extLst>
           </p:cNvPr>
@@ -5797,23 +5766,7 @@
           <a:bodyPr/>
           <a:lstStyle/>
           <a:p>
-            <a:r>
-              <a:rPr lang="fr-FR" dirty="0"/>
-              <a:t>Rajouter les </a:t>
-            </a:r>
-            <a:r>
-              <a:rPr lang="fr-FR" dirty="0" err="1"/>
-              <a:t>les</a:t>
-            </a:r>
-            <a:r>
-              <a:rPr lang="fr-FR" dirty="0"/>
-              <a:t> position de </a:t>
-            </a:r>
-            <a:r>
-              <a:rPr lang="fr-FR" dirty="0" err="1"/>
-              <a:t>novawatt</a:t>
-            </a:r>
-            <a:endParaRPr lang="fr-FR" dirty="0"/>
+            <a:endParaRPr lang="fr-FR"/>
           </a:p>
         </p:txBody>
       </p:sp>
@@ -5822,7 +5775,7 @@
           <p:cNvPr id="3" name="Espace réservé du contenu 2">
             <a:extLst>
               <a:ext uri="{FF2B5EF4-FFF2-40B4-BE49-F238E27FC236}">
-                <a16:creationId xmlns:a16="http://schemas.microsoft.com/office/drawing/2014/main" id="{C1174697-3B19-B6A5-D5F8-1081D2EE0CFB}"/>
+                <a16:creationId xmlns:a16="http://schemas.microsoft.com/office/drawing/2014/main" id="{BB9A57CC-0391-EDD0-6107-03CAA7921B5E}"/>
               </a:ext>
             </a:extLst>
           </p:cNvPr>
@@ -5838,40 +5791,90 @@
           <a:bodyPr/>
           <a:lstStyle/>
           <a:p>
-            <a:r>
-              <a:rPr lang="fr-FR" dirty="0" err="1"/>
-              <a:t>Carouselle</a:t>
-            </a:r>
-            <a:r>
-              <a:rPr lang="fr-FR" dirty="0"/>
-              <a:t> sur la </a:t>
-            </a:r>
-            <a:r>
-              <a:rPr lang="fr-FR" dirty="0" err="1"/>
-              <a:t>téle</a:t>
-            </a:r>
-            <a:endParaRPr lang="fr-FR" dirty="0"/>
-          </a:p>
-          <a:p>
-            <a:endParaRPr lang="fr-FR" dirty="0"/>
-          </a:p>
-          <a:p>
-            <a:r>
-              <a:rPr lang="fr-FR" dirty="0"/>
-              <a:t>Disponibilité du nucléaire et </a:t>
-            </a:r>
-            <a:r>
-              <a:rPr lang="fr-FR" dirty="0" err="1"/>
-              <a:t>ccg</a:t>
-            </a:r>
-            <a:endParaRPr lang="fr-FR" dirty="0"/>
+            <a:endParaRPr lang="fr-FR"/>
+          </a:p>
+        </p:txBody>
+      </p:sp>
+      <p:pic>
+        <p:nvPicPr>
+          <p:cNvPr id="5" name="Image 4">
+            <a:extLst>
+              <a:ext uri="{FF2B5EF4-FFF2-40B4-BE49-F238E27FC236}">
+                <a16:creationId xmlns:a16="http://schemas.microsoft.com/office/drawing/2014/main" id="{E4B7728C-8894-DC55-8F33-EB0229DE2F80}"/>
+              </a:ext>
+            </a:extLst>
+          </p:cNvPr>
+          <p:cNvPicPr>
+            <a:picLocks noChangeAspect="1"/>
+          </p:cNvPicPr>
+          <p:nvPr/>
+        </p:nvPicPr>
+        <p:blipFill>
+          <a:blip r:embed="rId2"/>
+          <a:stretch>
+            <a:fillRect/>
+          </a:stretch>
+        </p:blipFill>
+        <p:spPr>
+          <a:xfrm>
+            <a:off x="0" y="0"/>
+            <a:ext cx="12192000" cy="6858000"/>
+          </a:xfrm>
+          <a:prstGeom prst="rect">
+            <a:avLst/>
+          </a:prstGeom>
+        </p:spPr>
+      </p:pic>
+      <p:sp>
+        <p:nvSpPr>
+          <p:cNvPr id="6" name="Rectangle 5">
+            <a:extLst>
+              <a:ext uri="{FF2B5EF4-FFF2-40B4-BE49-F238E27FC236}">
+                <a16:creationId xmlns:a16="http://schemas.microsoft.com/office/drawing/2014/main" id="{42B30F58-DDA4-156C-62E1-0DDF4FC8E0A6}"/>
+              </a:ext>
+            </a:extLst>
+          </p:cNvPr>
+          <p:cNvSpPr/>
+          <p:nvPr/>
+        </p:nvSpPr>
+        <p:spPr>
+          <a:xfrm>
+            <a:off x="11823192" y="1271016"/>
+            <a:ext cx="1344168" cy="1042416"/>
+          </a:xfrm>
+          <a:prstGeom prst="rect">
+            <a:avLst/>
+          </a:prstGeom>
+        </p:spPr>
+        <p:style>
+          <a:lnRef idx="2">
+            <a:schemeClr val="accent1">
+              <a:shade val="15000"/>
+            </a:schemeClr>
+          </a:lnRef>
+          <a:fillRef idx="1">
+            <a:schemeClr val="accent1"/>
+          </a:fillRef>
+          <a:effectRef idx="0">
+            <a:schemeClr val="accent1"/>
+          </a:effectRef>
+          <a:fontRef idx="minor">
+            <a:schemeClr val="lt1"/>
+          </a:fontRef>
+        </p:style>
+        <p:txBody>
+          <a:bodyPr rtlCol="0" anchor="ctr"/>
+          <a:lstStyle/>
+          <a:p>
+            <a:pPr algn="ctr"/>
+            <a:endParaRPr lang="fr-FR"/>
           </a:p>
         </p:txBody>
       </p:sp>
     </p:spTree>
     <p:extLst>
       <p:ext uri="{BB962C8B-B14F-4D97-AF65-F5344CB8AC3E}">
-        <p14:creationId xmlns:p14="http://schemas.microsoft.com/office/powerpoint/2010/main" val="2021926209"/>
+        <p14:creationId xmlns:p14="http://schemas.microsoft.com/office/powerpoint/2010/main" val="2813967424"/>
       </p:ext>
     </p:extLst>
   </p:cSld>
@@ -5903,7 +5906,7 @@
           <p:cNvPr id="2" name="Titre 1">
             <a:extLst>
               <a:ext uri="{FF2B5EF4-FFF2-40B4-BE49-F238E27FC236}">
-                <a16:creationId xmlns:a16="http://schemas.microsoft.com/office/drawing/2014/main" id="{24167CB6-DF6E-AEAB-B0AD-6BDC6FB984BE}"/>
+                <a16:creationId xmlns:a16="http://schemas.microsoft.com/office/drawing/2014/main" id="{D5E8CEF5-6E23-4004-9FE2-A86A1917E8E8}"/>
               </a:ext>
             </a:extLst>
           </p:cNvPr>
@@ -5919,379 +5922,32 @@
           <a:bodyPr/>
           <a:lstStyle/>
           <a:p>
+            <a:r>
+              <a:rPr lang="fr-FR" dirty="0"/>
+              <a:t>Rajouter les </a:t>
+            </a:r>
+            <a:r>
+              <a:rPr lang="fr-FR" dirty="0" err="1"/>
+              <a:t>les</a:t>
+            </a:r>
+            <a:r>
+              <a:rPr lang="fr-FR" dirty="0"/>
+              <a:t> position de </a:t>
+            </a:r>
+            <a:r>
+              <a:rPr lang="fr-FR" dirty="0" err="1"/>
+              <a:t>novawatt</a:t>
+            </a:r>
             <a:endParaRPr lang="fr-FR" dirty="0"/>
           </a:p>
         </p:txBody>
       </p:sp>
       <p:sp>
         <p:nvSpPr>
-          <p:cNvPr id="4" name="Rectangle 3">
-            <a:extLst>
-              <a:ext uri="{FF2B5EF4-FFF2-40B4-BE49-F238E27FC236}">
-                <a16:creationId xmlns:a16="http://schemas.microsoft.com/office/drawing/2014/main" id="{1B0C0160-F03D-7BB6-9B60-68BD48B0762C}"/>
-              </a:ext>
-            </a:extLst>
-          </p:cNvPr>
-          <p:cNvSpPr/>
-          <p:nvPr/>
-        </p:nvSpPr>
-        <p:spPr>
-          <a:xfrm>
-            <a:off x="8189406" y="365126"/>
-            <a:ext cx="2803491" cy="629662"/>
-          </a:xfrm>
-          <a:prstGeom prst="rect">
-            <a:avLst/>
-          </a:prstGeom>
-        </p:spPr>
-        <p:style>
-          <a:lnRef idx="2">
-            <a:schemeClr val="accent1">
-              <a:shade val="15000"/>
-            </a:schemeClr>
-          </a:lnRef>
-          <a:fillRef idx="1">
-            <a:schemeClr val="accent1"/>
-          </a:fillRef>
-          <a:effectRef idx="0">
-            <a:schemeClr val="accent1"/>
-          </a:effectRef>
-          <a:fontRef idx="minor">
-            <a:schemeClr val="lt1"/>
-          </a:fontRef>
-        </p:style>
-        <p:txBody>
-          <a:bodyPr rtlCol="0" anchor="ctr"/>
-          <a:lstStyle/>
-          <a:p>
-            <a:pPr algn="ctr"/>
-            <a:r>
-              <a:rPr lang="fr-FR" dirty="0"/>
-              <a:t>Spark-spread </a:t>
-            </a:r>
-          </a:p>
-        </p:txBody>
-      </p:sp>
-      <p:sp>
-        <p:nvSpPr>
-          <p:cNvPr id="6" name="Rectangle 5">
-            <a:extLst>
-              <a:ext uri="{FF2B5EF4-FFF2-40B4-BE49-F238E27FC236}">
-                <a16:creationId xmlns:a16="http://schemas.microsoft.com/office/drawing/2014/main" id="{6FDA8550-54D3-BCFE-061C-90769C5311AE}"/>
-              </a:ext>
-            </a:extLst>
-          </p:cNvPr>
-          <p:cNvSpPr/>
-          <p:nvPr/>
-        </p:nvSpPr>
-        <p:spPr>
-          <a:xfrm>
-            <a:off x="8189406" y="2173575"/>
-            <a:ext cx="2803491" cy="920175"/>
-          </a:xfrm>
-          <a:prstGeom prst="rect">
-            <a:avLst/>
-          </a:prstGeom>
-        </p:spPr>
-        <p:style>
-          <a:lnRef idx="2">
-            <a:schemeClr val="accent1">
-              <a:shade val="15000"/>
-            </a:schemeClr>
-          </a:lnRef>
-          <a:fillRef idx="1">
-            <a:schemeClr val="accent1"/>
-          </a:fillRef>
-          <a:effectRef idx="0">
-            <a:schemeClr val="accent1"/>
-          </a:effectRef>
-          <a:fontRef idx="minor">
-            <a:schemeClr val="lt1"/>
-          </a:fontRef>
-        </p:style>
-        <p:txBody>
-          <a:bodyPr rtlCol="0" anchor="ctr"/>
-          <a:lstStyle/>
-          <a:p>
-            <a:pPr algn="ctr"/>
-            <a:endParaRPr lang="fr-FR" dirty="0"/>
-          </a:p>
-        </p:txBody>
-      </p:sp>
-      <p:sp>
-        <p:nvSpPr>
-          <p:cNvPr id="8" name="Rectangle 7">
-            <a:extLst>
-              <a:ext uri="{FF2B5EF4-FFF2-40B4-BE49-F238E27FC236}">
-                <a16:creationId xmlns:a16="http://schemas.microsoft.com/office/drawing/2014/main" id="{C5D7E445-750A-A988-EADB-36671FDD7FA5}"/>
-              </a:ext>
-            </a:extLst>
-          </p:cNvPr>
-          <p:cNvSpPr/>
-          <p:nvPr/>
-        </p:nvSpPr>
-        <p:spPr>
-          <a:xfrm>
-            <a:off x="157425" y="4467486"/>
-            <a:ext cx="2803491" cy="920176"/>
-          </a:xfrm>
-          <a:prstGeom prst="rect">
-            <a:avLst/>
-          </a:prstGeom>
-        </p:spPr>
-        <p:style>
-          <a:lnRef idx="2">
-            <a:schemeClr val="accent1">
-              <a:shade val="15000"/>
-            </a:schemeClr>
-          </a:lnRef>
-          <a:fillRef idx="1">
-            <a:schemeClr val="accent1"/>
-          </a:fillRef>
-          <a:effectRef idx="0">
-            <a:schemeClr val="accent1"/>
-          </a:effectRef>
-          <a:fontRef idx="minor">
-            <a:schemeClr val="lt1"/>
-          </a:fontRef>
-        </p:style>
-        <p:txBody>
-          <a:bodyPr rtlCol="0" anchor="ctr"/>
-          <a:lstStyle/>
-          <a:p>
-            <a:pPr algn="ctr"/>
-            <a:r>
-              <a:rPr lang="fr-FR" dirty="0"/>
-              <a:t>NB de jours PP/22</a:t>
-            </a:r>
-          </a:p>
-        </p:txBody>
-      </p:sp>
-      <p:sp>
-        <p:nvSpPr>
-          <p:cNvPr id="10" name="Rectangle 9">
-            <a:extLst>
-              <a:ext uri="{FF2B5EF4-FFF2-40B4-BE49-F238E27FC236}">
-                <a16:creationId xmlns:a16="http://schemas.microsoft.com/office/drawing/2014/main" id="{06AF5FCC-81CF-9BF9-D7C5-DF187F1BAA8C}"/>
-              </a:ext>
-            </a:extLst>
-          </p:cNvPr>
-          <p:cNvSpPr/>
-          <p:nvPr/>
-        </p:nvSpPr>
-        <p:spPr>
-          <a:xfrm>
-            <a:off x="157424" y="365124"/>
-            <a:ext cx="5938576" cy="3960228"/>
-          </a:xfrm>
-          <a:prstGeom prst="rect">
-            <a:avLst/>
-          </a:prstGeom>
-        </p:spPr>
-        <p:style>
-          <a:lnRef idx="2">
-            <a:schemeClr val="accent1">
-              <a:shade val="15000"/>
-            </a:schemeClr>
-          </a:lnRef>
-          <a:fillRef idx="1">
-            <a:schemeClr val="accent1"/>
-          </a:fillRef>
-          <a:effectRef idx="0">
-            <a:schemeClr val="accent1"/>
-          </a:effectRef>
-          <a:fontRef idx="minor">
-            <a:schemeClr val="lt1"/>
-          </a:fontRef>
-        </p:style>
-        <p:txBody>
-          <a:bodyPr rtlCol="0" anchor="ctr"/>
-          <a:lstStyle/>
-          <a:p>
-            <a:pPr algn="ctr"/>
-            <a:r>
-              <a:rPr lang="fr-FR" dirty="0"/>
-              <a:t>Courbe </a:t>
-            </a:r>
-            <a:r>
-              <a:rPr lang="fr-FR" dirty="0" err="1"/>
-              <a:t>spark</a:t>
-            </a:r>
-            <a:r>
-              <a:rPr lang="fr-FR" dirty="0"/>
-              <a:t> spread *3 rendements</a:t>
-            </a:r>
-          </a:p>
-          <a:p>
-            <a:pPr algn="ctr"/>
-            <a:r>
-              <a:rPr lang="fr-FR" dirty="0"/>
-              <a:t>1,8</a:t>
-            </a:r>
-          </a:p>
-          <a:p>
-            <a:pPr algn="ctr"/>
-            <a:r>
-              <a:rPr lang="fr-FR" dirty="0"/>
-              <a:t>2,2</a:t>
-            </a:r>
-          </a:p>
-          <a:p>
-            <a:pPr algn="ctr"/>
-            <a:r>
-              <a:rPr lang="fr-FR" dirty="0"/>
-              <a:t>3,2</a:t>
-            </a:r>
-          </a:p>
-        </p:txBody>
-      </p:sp>
-      <p:sp>
-        <p:nvSpPr>
-          <p:cNvPr id="12" name="Rectangle 11">
-            <a:extLst>
-              <a:ext uri="{FF2B5EF4-FFF2-40B4-BE49-F238E27FC236}">
-                <a16:creationId xmlns:a16="http://schemas.microsoft.com/office/drawing/2014/main" id="{8786F3C1-0787-E66A-848E-955B90C792F9}"/>
-              </a:ext>
-            </a:extLst>
-          </p:cNvPr>
-          <p:cNvSpPr/>
-          <p:nvPr/>
-        </p:nvSpPr>
-        <p:spPr>
-          <a:xfrm>
-            <a:off x="6297807" y="365124"/>
-            <a:ext cx="5938576" cy="3960228"/>
-          </a:xfrm>
-          <a:prstGeom prst="rect">
-            <a:avLst/>
-          </a:prstGeom>
-        </p:spPr>
-        <p:style>
-          <a:lnRef idx="2">
-            <a:schemeClr val="accent1">
-              <a:shade val="15000"/>
-            </a:schemeClr>
-          </a:lnRef>
-          <a:fillRef idx="1">
-            <a:schemeClr val="accent1"/>
-          </a:fillRef>
-          <a:effectRef idx="0">
-            <a:schemeClr val="accent1"/>
-          </a:effectRef>
-          <a:fontRef idx="minor">
-            <a:schemeClr val="lt1"/>
-          </a:fontRef>
-        </p:style>
-        <p:txBody>
-          <a:bodyPr rtlCol="0" anchor="ctr"/>
-          <a:lstStyle/>
-          <a:p>
-            <a:pPr algn="ctr"/>
-            <a:r>
-              <a:rPr lang="fr-FR" dirty="0"/>
-              <a:t>Courbe Clean </a:t>
-            </a:r>
-            <a:r>
-              <a:rPr lang="fr-FR" dirty="0" err="1"/>
-              <a:t>spark</a:t>
-            </a:r>
-            <a:r>
-              <a:rPr lang="fr-FR" dirty="0"/>
-              <a:t> spread *3 rendements</a:t>
-            </a:r>
-          </a:p>
-          <a:p>
-            <a:pPr algn="ctr"/>
-            <a:r>
-              <a:rPr lang="fr-FR" dirty="0"/>
-              <a:t>1,8</a:t>
-            </a:r>
-          </a:p>
-          <a:p>
-            <a:pPr algn="ctr"/>
-            <a:r>
-              <a:rPr lang="fr-FR" dirty="0"/>
-              <a:t>2,2</a:t>
-            </a:r>
-          </a:p>
-          <a:p>
-            <a:pPr algn="ctr"/>
-            <a:r>
-              <a:rPr lang="fr-FR" dirty="0"/>
-              <a:t>3,2</a:t>
-            </a:r>
-          </a:p>
-          <a:p>
-            <a:pPr algn="ctr"/>
-            <a:endParaRPr lang="fr-FR" dirty="0"/>
-          </a:p>
-          <a:p>
-            <a:pPr algn="ctr"/>
-            <a:r>
-              <a:rPr lang="fr-FR" dirty="0"/>
-              <a:t>+0,185*co2</a:t>
-            </a:r>
-          </a:p>
-        </p:txBody>
-      </p:sp>
-      <p:sp>
-        <p:nvSpPr>
-          <p:cNvPr id="14" name="Rectangle 13">
-            <a:extLst>
-              <a:ext uri="{FF2B5EF4-FFF2-40B4-BE49-F238E27FC236}">
-                <a16:creationId xmlns:a16="http://schemas.microsoft.com/office/drawing/2014/main" id="{816291A1-7B8E-9638-9B09-43AD346292A9}"/>
-              </a:ext>
-            </a:extLst>
-          </p:cNvPr>
-          <p:cNvSpPr/>
-          <p:nvPr/>
-        </p:nvSpPr>
-        <p:spPr>
-          <a:xfrm>
-            <a:off x="157424" y="5398921"/>
-            <a:ext cx="2803491" cy="920176"/>
-          </a:xfrm>
-          <a:prstGeom prst="rect">
-            <a:avLst/>
-          </a:prstGeom>
-          <a:solidFill>
-            <a:schemeClr val="accent2"/>
-          </a:solidFill>
-        </p:spPr>
-        <p:style>
-          <a:lnRef idx="2">
-            <a:schemeClr val="accent1">
-              <a:shade val="15000"/>
-            </a:schemeClr>
-          </a:lnRef>
-          <a:fillRef idx="1">
-            <a:schemeClr val="accent1"/>
-          </a:fillRef>
-          <a:effectRef idx="0">
-            <a:schemeClr val="accent1"/>
-          </a:effectRef>
-          <a:fontRef idx="minor">
-            <a:schemeClr val="lt1"/>
-          </a:fontRef>
-        </p:style>
-        <p:txBody>
-          <a:bodyPr rtlCol="0" anchor="ctr"/>
-          <a:lstStyle/>
-          <a:p>
-            <a:pPr algn="ctr"/>
-            <a:r>
-              <a:rPr lang="fr-FR" dirty="0"/>
-              <a:t>On est en PP</a:t>
-            </a:r>
-          </a:p>
-        </p:txBody>
-      </p:sp>
-      <p:sp>
-        <p:nvSpPr>
-          <p:cNvPr id="16" name="Espace réservé du contenu 15">
-            <a:extLst>
-              <a:ext uri="{FF2B5EF4-FFF2-40B4-BE49-F238E27FC236}">
-                <a16:creationId xmlns:a16="http://schemas.microsoft.com/office/drawing/2014/main" id="{A5CA299F-B19F-30AF-6A78-A1D1B6BFB50D}"/>
+          <p:cNvPr id="3" name="Espace réservé du contenu 2">
+            <a:extLst>
+              <a:ext uri="{FF2B5EF4-FFF2-40B4-BE49-F238E27FC236}">
+                <a16:creationId xmlns:a16="http://schemas.microsoft.com/office/drawing/2014/main" id="{C1174697-3B19-B6A5-D5F8-1081D2EE0CFB}"/>
               </a:ext>
             </a:extLst>
           </p:cNvPr>
@@ -6302,485 +5958,45 @@
             <p:ph idx="1"/>
           </p:nvPr>
         </p:nvSpPr>
-        <p:spPr>
-          <a:xfrm>
-            <a:off x="3228169" y="4496809"/>
-            <a:ext cx="3309791" cy="1822287"/>
-          </a:xfrm>
-          <a:prstGeom prst="rect">
-            <a:avLst/>
-          </a:prstGeom>
-        </p:spPr>
-        <p:style>
-          <a:lnRef idx="2">
-            <a:schemeClr val="accent1">
-              <a:shade val="15000"/>
-            </a:schemeClr>
-          </a:lnRef>
-          <a:fillRef idx="1">
-            <a:schemeClr val="accent1"/>
-          </a:fillRef>
-          <a:effectRef idx="0">
-            <a:schemeClr val="accent1"/>
-          </a:effectRef>
-          <a:fontRef idx="minor">
-            <a:schemeClr val="lt1"/>
-          </a:fontRef>
-        </p:style>
-        <p:txBody>
-          <a:bodyPr rtlCol="0" anchor="ctr">
-            <a:normAutofit/>
-          </a:bodyPr>
-          <a:lstStyle/>
-          <a:p>
-            <a:pPr algn="ctr"/>
-            <a:r>
-              <a:rPr lang="fr-FR" dirty="0"/>
-              <a:t>MFRR hausse +baisse</a:t>
-            </a:r>
-          </a:p>
-          <a:p>
-            <a:pPr marL="0" indent="0" algn="ctr">
-              <a:buNone/>
-            </a:pPr>
-            <a:r>
-              <a:rPr lang="fr-FR" dirty="0"/>
-              <a:t>(vs la saison précédente)</a:t>
-            </a:r>
-          </a:p>
-        </p:txBody>
-      </p:sp>
-      <p:sp>
-        <p:nvSpPr>
-          <p:cNvPr id="17" name="Rectangle 16">
-            <a:extLst>
-              <a:ext uri="{FF2B5EF4-FFF2-40B4-BE49-F238E27FC236}">
-                <a16:creationId xmlns:a16="http://schemas.microsoft.com/office/drawing/2014/main" id="{95649D35-BCF5-72FD-6D49-A3333C4ADF6F}"/>
-              </a:ext>
-            </a:extLst>
-          </p:cNvPr>
-          <p:cNvSpPr/>
-          <p:nvPr/>
-        </p:nvSpPr>
-        <p:spPr>
-          <a:xfrm>
-            <a:off x="6748172" y="4446030"/>
-            <a:ext cx="1981197" cy="631547"/>
-          </a:xfrm>
-          <a:prstGeom prst="rect">
-            <a:avLst/>
-          </a:prstGeom>
-        </p:spPr>
-        <p:style>
-          <a:lnRef idx="2">
-            <a:schemeClr val="accent1">
-              <a:shade val="15000"/>
-            </a:schemeClr>
-          </a:lnRef>
-          <a:fillRef idx="1">
-            <a:schemeClr val="accent1"/>
-          </a:fillRef>
-          <a:effectRef idx="0">
-            <a:schemeClr val="accent1"/>
-          </a:effectRef>
-          <a:fontRef idx="minor">
-            <a:schemeClr val="lt1"/>
-          </a:fontRef>
-        </p:style>
-        <p:txBody>
-          <a:bodyPr rtlCol="0" anchor="ctr"/>
-          <a:lstStyle/>
-          <a:p>
-            <a:pPr algn="ctr"/>
-            <a:r>
-              <a:rPr lang="fr-FR" dirty="0"/>
-              <a:t>Peg du jour</a:t>
-            </a:r>
-          </a:p>
-          <a:p>
-            <a:pPr algn="ctr"/>
-            <a:r>
-              <a:rPr lang="fr-FR" dirty="0"/>
-              <a:t>Vs 7dernires jours</a:t>
-            </a:r>
-          </a:p>
-        </p:txBody>
-      </p:sp>
-      <p:sp>
-        <p:nvSpPr>
-          <p:cNvPr id="19" name="Rectangle 18">
-            <a:extLst>
-              <a:ext uri="{FF2B5EF4-FFF2-40B4-BE49-F238E27FC236}">
-                <a16:creationId xmlns:a16="http://schemas.microsoft.com/office/drawing/2014/main" id="{F4C3C6F4-59AA-372C-6EE9-AF9BAFB53123}"/>
-              </a:ext>
-            </a:extLst>
-          </p:cNvPr>
-          <p:cNvSpPr/>
-          <p:nvPr/>
-        </p:nvSpPr>
-        <p:spPr>
-          <a:xfrm>
-            <a:off x="9550026" y="4446030"/>
-            <a:ext cx="2315459" cy="631547"/>
-          </a:xfrm>
-          <a:prstGeom prst="rect">
-            <a:avLst/>
-          </a:prstGeom>
-        </p:spPr>
-        <p:style>
-          <a:lnRef idx="2">
-            <a:schemeClr val="accent1">
-              <a:shade val="15000"/>
-            </a:schemeClr>
-          </a:lnRef>
-          <a:fillRef idx="1">
-            <a:schemeClr val="accent1"/>
-          </a:fillRef>
-          <a:effectRef idx="0">
-            <a:schemeClr val="accent1"/>
-          </a:effectRef>
-          <a:fontRef idx="minor">
-            <a:schemeClr val="lt1"/>
-          </a:fontRef>
-        </p:style>
-        <p:txBody>
-          <a:bodyPr rtlCol="0" anchor="ctr"/>
-          <a:lstStyle/>
-          <a:p>
-            <a:pPr algn="ctr"/>
-            <a:r>
-              <a:rPr lang="fr-FR" dirty="0"/>
-              <a:t>CO2</a:t>
-            </a:r>
-          </a:p>
-          <a:p>
-            <a:pPr algn="ctr"/>
-            <a:r>
-              <a:rPr lang="fr-FR" dirty="0"/>
-              <a:t>Vs 7 derniers jours</a:t>
-            </a:r>
-          </a:p>
-        </p:txBody>
-      </p:sp>
-      <p:sp>
-        <p:nvSpPr>
-          <p:cNvPr id="20" name="Rectangle 19">
-            <a:extLst>
-              <a:ext uri="{FF2B5EF4-FFF2-40B4-BE49-F238E27FC236}">
-                <a16:creationId xmlns:a16="http://schemas.microsoft.com/office/drawing/2014/main" id="{DCD43213-6E2E-3F18-F644-103974EB4502}"/>
-              </a:ext>
-            </a:extLst>
-          </p:cNvPr>
-          <p:cNvSpPr/>
-          <p:nvPr/>
-        </p:nvSpPr>
-        <p:spPr>
-          <a:xfrm>
-            <a:off x="5453323" y="658167"/>
-            <a:ext cx="1406769" cy="1321149"/>
-          </a:xfrm>
-          <a:prstGeom prst="rect">
-            <a:avLst/>
-          </a:prstGeom>
-        </p:spPr>
-        <p:style>
-          <a:lnRef idx="2">
-            <a:schemeClr val="accent1">
-              <a:shade val="15000"/>
-            </a:schemeClr>
-          </a:lnRef>
-          <a:fillRef idx="1">
-            <a:schemeClr val="accent1"/>
-          </a:fillRef>
-          <a:effectRef idx="0">
-            <a:schemeClr val="accent1"/>
-          </a:effectRef>
-          <a:fontRef idx="minor">
-            <a:schemeClr val="lt1"/>
-          </a:fontRef>
-        </p:style>
-        <p:txBody>
-          <a:bodyPr rtlCol="0" anchor="ctr"/>
-          <a:lstStyle/>
-          <a:p>
-            <a:pPr algn="ctr"/>
+        <p:spPr/>
+        <p:txBody>
+          <a:bodyPr/>
+          <a:lstStyle/>
+          <a:p>
             <a:r>
               <a:rPr lang="fr-FR" dirty="0" err="1"/>
-              <a:t>Cogé</a:t>
-            </a:r>
-            <a:r>
-              <a:rPr lang="fr-FR" dirty="0"/>
-              <a:t> serre</a:t>
-            </a:r>
-          </a:p>
-          <a:p>
-            <a:pPr algn="ctr"/>
-            <a:r>
-              <a:rPr lang="fr-FR" dirty="0"/>
-              <a:t>Base</a:t>
-            </a:r>
-          </a:p>
-          <a:p>
-            <a:pPr algn="ctr"/>
-            <a:r>
-              <a:rPr lang="fr-FR" dirty="0"/>
-              <a:t>Peak</a:t>
-            </a:r>
-          </a:p>
-          <a:p>
-            <a:pPr algn="ctr"/>
-            <a:r>
-              <a:rPr lang="fr-FR" dirty="0"/>
-              <a:t>1,8 </a:t>
-            </a:r>
-          </a:p>
-        </p:txBody>
-      </p:sp>
-      <p:sp>
-        <p:nvSpPr>
-          <p:cNvPr id="21" name="Rectangle 20">
-            <a:extLst>
-              <a:ext uri="{FF2B5EF4-FFF2-40B4-BE49-F238E27FC236}">
-                <a16:creationId xmlns:a16="http://schemas.microsoft.com/office/drawing/2014/main" id="{ED0F5393-ABA6-5D46-298B-C8EC403AD580}"/>
-              </a:ext>
-            </a:extLst>
-          </p:cNvPr>
-          <p:cNvSpPr/>
-          <p:nvPr/>
-        </p:nvSpPr>
-        <p:spPr>
-          <a:xfrm>
-            <a:off x="296425" y="222990"/>
-            <a:ext cx="2069960" cy="703385"/>
-          </a:xfrm>
-          <a:prstGeom prst="rect">
-            <a:avLst/>
-          </a:prstGeom>
-        </p:spPr>
-        <p:style>
-          <a:lnRef idx="2">
-            <a:schemeClr val="accent1">
-              <a:shade val="15000"/>
-            </a:schemeClr>
-          </a:lnRef>
-          <a:fillRef idx="1">
-            <a:schemeClr val="accent1"/>
-          </a:fillRef>
-          <a:effectRef idx="0">
-            <a:schemeClr val="accent1"/>
-          </a:effectRef>
-          <a:fontRef idx="minor">
-            <a:schemeClr val="lt1"/>
-          </a:fontRef>
-        </p:style>
-        <p:txBody>
-          <a:bodyPr rtlCol="0" anchor="ctr"/>
-          <a:lstStyle/>
-          <a:p>
-            <a:pPr algn="ctr"/>
-            <a:r>
-              <a:rPr lang="fr-FR" dirty="0"/>
-              <a:t>Choisir les rendements?</a:t>
-            </a:r>
-          </a:p>
-          <a:p>
-            <a:pPr algn="ctr"/>
+              <a:t>Carouselle</a:t>
+            </a:r>
+            <a:r>
+              <a:rPr lang="fr-FR" dirty="0"/>
+              <a:t> sur la </a:t>
+            </a:r>
+            <a:r>
+              <a:rPr lang="fr-FR" dirty="0" err="1"/>
+              <a:t>téle</a:t>
+            </a:r>
             <a:endParaRPr lang="fr-FR" dirty="0"/>
           </a:p>
-        </p:txBody>
-      </p:sp>
-      <p:sp>
-        <p:nvSpPr>
-          <p:cNvPr id="23" name="Rectangle 22">
-            <a:extLst>
-              <a:ext uri="{FF2B5EF4-FFF2-40B4-BE49-F238E27FC236}">
-                <a16:creationId xmlns:a16="http://schemas.microsoft.com/office/drawing/2014/main" id="{6AA87551-7BE9-EDDA-0CA3-09610BF807C9}"/>
-              </a:ext>
-            </a:extLst>
-          </p:cNvPr>
-          <p:cNvSpPr/>
-          <p:nvPr/>
-        </p:nvSpPr>
-        <p:spPr>
-          <a:xfrm>
-            <a:off x="5453323" y="2262359"/>
-            <a:ext cx="1406769" cy="1166641"/>
-          </a:xfrm>
-          <a:prstGeom prst="rect">
-            <a:avLst/>
-          </a:prstGeom>
-        </p:spPr>
-        <p:style>
-          <a:lnRef idx="2">
-            <a:schemeClr val="accent1">
-              <a:shade val="15000"/>
-            </a:schemeClr>
-          </a:lnRef>
-          <a:fillRef idx="1">
-            <a:schemeClr val="accent1"/>
-          </a:fillRef>
-          <a:effectRef idx="0">
-            <a:schemeClr val="accent1"/>
-          </a:effectRef>
-          <a:fontRef idx="minor">
-            <a:schemeClr val="lt1"/>
-          </a:fontRef>
-        </p:style>
-        <p:txBody>
-          <a:bodyPr rtlCol="0" anchor="ctr"/>
-          <a:lstStyle/>
-          <a:p>
-            <a:pPr algn="ctr"/>
+          <a:p>
+            <a:endParaRPr lang="fr-FR" dirty="0"/>
+          </a:p>
+          <a:p>
+            <a:r>
+              <a:rPr lang="fr-FR" dirty="0"/>
+              <a:t>Disponibilité du nucléaire et </a:t>
+            </a:r>
             <a:r>
               <a:rPr lang="fr-FR" dirty="0" err="1"/>
-              <a:t>Cogé</a:t>
-            </a:r>
-            <a:r>
-              <a:rPr lang="fr-FR" dirty="0"/>
-              <a:t> indus</a:t>
-            </a:r>
-          </a:p>
-          <a:p>
-            <a:pPr algn="ctr"/>
-            <a:r>
-              <a:rPr lang="fr-FR" dirty="0"/>
-              <a:t>Base</a:t>
-            </a:r>
-          </a:p>
-          <a:p>
-            <a:pPr algn="ctr"/>
-            <a:r>
-              <a:rPr lang="fr-FR" dirty="0"/>
-              <a:t>Peak </a:t>
-            </a:r>
-          </a:p>
-          <a:p>
-            <a:pPr algn="ctr"/>
-            <a:r>
-              <a:rPr lang="fr-FR" dirty="0"/>
-              <a:t>2,2</a:t>
-            </a:r>
-          </a:p>
-        </p:txBody>
-      </p:sp>
-      <p:sp>
-        <p:nvSpPr>
-          <p:cNvPr id="24" name="Rectangle 23">
-            <a:extLst>
-              <a:ext uri="{FF2B5EF4-FFF2-40B4-BE49-F238E27FC236}">
-                <a16:creationId xmlns:a16="http://schemas.microsoft.com/office/drawing/2014/main" id="{2AE4F717-A388-4800-26AD-405D6E5025B4}"/>
-              </a:ext>
-            </a:extLst>
-          </p:cNvPr>
-          <p:cNvSpPr/>
-          <p:nvPr/>
-        </p:nvSpPr>
-        <p:spPr>
-          <a:xfrm>
-            <a:off x="6748172" y="5198257"/>
-            <a:ext cx="5117313" cy="699624"/>
-          </a:xfrm>
-          <a:prstGeom prst="rect">
-            <a:avLst/>
-          </a:prstGeom>
-        </p:spPr>
-        <p:style>
-          <a:lnRef idx="2">
-            <a:schemeClr val="accent1">
-              <a:shade val="15000"/>
-            </a:schemeClr>
-          </a:lnRef>
-          <a:fillRef idx="1">
-            <a:schemeClr val="accent1"/>
-          </a:fillRef>
-          <a:effectRef idx="0">
-            <a:schemeClr val="accent1"/>
-          </a:effectRef>
-          <a:fontRef idx="minor">
-            <a:schemeClr val="lt1"/>
-          </a:fontRef>
-        </p:style>
-        <p:txBody>
-          <a:bodyPr rtlCol="0" anchor="ctr"/>
-          <a:lstStyle/>
-          <a:p>
-            <a:pPr algn="ctr"/>
-            <a:r>
-              <a:rPr lang="fr-FR" dirty="0"/>
-              <a:t>Base </a:t>
-            </a:r>
-            <a:r>
-              <a:rPr lang="fr-FR" dirty="0" err="1"/>
-              <a:t>peak</a:t>
-            </a:r>
-            <a:r>
-              <a:rPr lang="fr-FR" dirty="0"/>
-              <a:t> M+1 M+2 Q+1 serre</a:t>
-            </a:r>
-          </a:p>
-        </p:txBody>
-      </p:sp>
-      <p:sp>
-        <p:nvSpPr>
-          <p:cNvPr id="26" name="Rectangle 25">
-            <a:extLst>
-              <a:ext uri="{FF2B5EF4-FFF2-40B4-BE49-F238E27FC236}">
-                <a16:creationId xmlns:a16="http://schemas.microsoft.com/office/drawing/2014/main" id="{D9FEA2F4-9AF2-0D71-DD0A-AAECC0EF8922}"/>
-              </a:ext>
-            </a:extLst>
-          </p:cNvPr>
-          <p:cNvSpPr/>
-          <p:nvPr/>
-        </p:nvSpPr>
-        <p:spPr>
-          <a:xfrm>
-            <a:off x="6748172" y="5950483"/>
-            <a:ext cx="5117313" cy="699624"/>
-          </a:xfrm>
-          <a:prstGeom prst="rect">
-            <a:avLst/>
-          </a:prstGeom>
-        </p:spPr>
-        <p:style>
-          <a:lnRef idx="2">
-            <a:schemeClr val="accent1">
-              <a:shade val="15000"/>
-            </a:schemeClr>
-          </a:lnRef>
-          <a:fillRef idx="1">
-            <a:schemeClr val="accent1"/>
-          </a:fillRef>
-          <a:effectRef idx="0">
-            <a:schemeClr val="accent1"/>
-          </a:effectRef>
-          <a:fontRef idx="minor">
-            <a:schemeClr val="lt1"/>
-          </a:fontRef>
-        </p:style>
-        <p:txBody>
-          <a:bodyPr rtlCol="0" anchor="ctr"/>
-          <a:lstStyle/>
-          <a:p>
-            <a:pPr algn="ctr"/>
-            <a:r>
-              <a:rPr lang="fr-FR" dirty="0"/>
-              <a:t>Base </a:t>
-            </a:r>
-            <a:r>
-              <a:rPr lang="fr-FR" dirty="0" err="1"/>
-              <a:t>peak</a:t>
-            </a:r>
-            <a:r>
-              <a:rPr lang="fr-FR" dirty="0"/>
-              <a:t> M+1 M+2 Q+1 indus</a:t>
-            </a:r>
+              <a:t>ccg</a:t>
+            </a:r>
+            <a:endParaRPr lang="fr-FR" dirty="0"/>
           </a:p>
         </p:txBody>
       </p:sp>
     </p:spTree>
     <p:extLst>
       <p:ext uri="{BB962C8B-B14F-4D97-AF65-F5344CB8AC3E}">
-        <p14:creationId xmlns:p14="http://schemas.microsoft.com/office/powerpoint/2010/main" val="3235114641"/>
+        <p14:creationId xmlns:p14="http://schemas.microsoft.com/office/powerpoint/2010/main" val="2021926209"/>
       </p:ext>
     </p:extLst>
   </p:cSld>
@@ -6812,6 +6028,915 @@
           <p:cNvPr id="2" name="Titre 1">
             <a:extLst>
               <a:ext uri="{FF2B5EF4-FFF2-40B4-BE49-F238E27FC236}">
+                <a16:creationId xmlns:a16="http://schemas.microsoft.com/office/drawing/2014/main" id="{24167CB6-DF6E-AEAB-B0AD-6BDC6FB984BE}"/>
+              </a:ext>
+            </a:extLst>
+          </p:cNvPr>
+          <p:cNvSpPr>
+            <a:spLocks noGrp="1"/>
+          </p:cNvSpPr>
+          <p:nvPr>
+            <p:ph type="title"/>
+          </p:nvPr>
+        </p:nvSpPr>
+        <p:spPr/>
+        <p:txBody>
+          <a:bodyPr/>
+          <a:lstStyle/>
+          <a:p>
+            <a:endParaRPr lang="fr-FR" dirty="0"/>
+          </a:p>
+        </p:txBody>
+      </p:sp>
+      <p:sp>
+        <p:nvSpPr>
+          <p:cNvPr id="4" name="Rectangle 3">
+            <a:extLst>
+              <a:ext uri="{FF2B5EF4-FFF2-40B4-BE49-F238E27FC236}">
+                <a16:creationId xmlns:a16="http://schemas.microsoft.com/office/drawing/2014/main" id="{1B0C0160-F03D-7BB6-9B60-68BD48B0762C}"/>
+              </a:ext>
+            </a:extLst>
+          </p:cNvPr>
+          <p:cNvSpPr/>
+          <p:nvPr/>
+        </p:nvSpPr>
+        <p:spPr>
+          <a:xfrm>
+            <a:off x="8189406" y="365126"/>
+            <a:ext cx="2803491" cy="629662"/>
+          </a:xfrm>
+          <a:prstGeom prst="rect">
+            <a:avLst/>
+          </a:prstGeom>
+        </p:spPr>
+        <p:style>
+          <a:lnRef idx="2">
+            <a:schemeClr val="accent1">
+              <a:shade val="15000"/>
+            </a:schemeClr>
+          </a:lnRef>
+          <a:fillRef idx="1">
+            <a:schemeClr val="accent1"/>
+          </a:fillRef>
+          <a:effectRef idx="0">
+            <a:schemeClr val="accent1"/>
+          </a:effectRef>
+          <a:fontRef idx="minor">
+            <a:schemeClr val="lt1"/>
+          </a:fontRef>
+        </p:style>
+        <p:txBody>
+          <a:bodyPr rtlCol="0" anchor="ctr"/>
+          <a:lstStyle/>
+          <a:p>
+            <a:pPr algn="ctr"/>
+            <a:r>
+              <a:rPr lang="fr-FR" dirty="0"/>
+              <a:t>Spark-spread </a:t>
+            </a:r>
+          </a:p>
+        </p:txBody>
+      </p:sp>
+      <p:sp>
+        <p:nvSpPr>
+          <p:cNvPr id="6" name="Rectangle 5">
+            <a:extLst>
+              <a:ext uri="{FF2B5EF4-FFF2-40B4-BE49-F238E27FC236}">
+                <a16:creationId xmlns:a16="http://schemas.microsoft.com/office/drawing/2014/main" id="{6FDA8550-54D3-BCFE-061C-90769C5311AE}"/>
+              </a:ext>
+            </a:extLst>
+          </p:cNvPr>
+          <p:cNvSpPr/>
+          <p:nvPr/>
+        </p:nvSpPr>
+        <p:spPr>
+          <a:xfrm>
+            <a:off x="8189406" y="2173575"/>
+            <a:ext cx="2803491" cy="920175"/>
+          </a:xfrm>
+          <a:prstGeom prst="rect">
+            <a:avLst/>
+          </a:prstGeom>
+        </p:spPr>
+        <p:style>
+          <a:lnRef idx="2">
+            <a:schemeClr val="accent1">
+              <a:shade val="15000"/>
+            </a:schemeClr>
+          </a:lnRef>
+          <a:fillRef idx="1">
+            <a:schemeClr val="accent1"/>
+          </a:fillRef>
+          <a:effectRef idx="0">
+            <a:schemeClr val="accent1"/>
+          </a:effectRef>
+          <a:fontRef idx="minor">
+            <a:schemeClr val="lt1"/>
+          </a:fontRef>
+        </p:style>
+        <p:txBody>
+          <a:bodyPr rtlCol="0" anchor="ctr"/>
+          <a:lstStyle/>
+          <a:p>
+            <a:pPr algn="ctr"/>
+            <a:endParaRPr lang="fr-FR" dirty="0"/>
+          </a:p>
+        </p:txBody>
+      </p:sp>
+      <p:sp>
+        <p:nvSpPr>
+          <p:cNvPr id="8" name="Rectangle 7">
+            <a:extLst>
+              <a:ext uri="{FF2B5EF4-FFF2-40B4-BE49-F238E27FC236}">
+                <a16:creationId xmlns:a16="http://schemas.microsoft.com/office/drawing/2014/main" id="{C5D7E445-750A-A988-EADB-36671FDD7FA5}"/>
+              </a:ext>
+            </a:extLst>
+          </p:cNvPr>
+          <p:cNvSpPr/>
+          <p:nvPr/>
+        </p:nvSpPr>
+        <p:spPr>
+          <a:xfrm>
+            <a:off x="157425" y="4467486"/>
+            <a:ext cx="2803491" cy="920176"/>
+          </a:xfrm>
+          <a:prstGeom prst="rect">
+            <a:avLst/>
+          </a:prstGeom>
+        </p:spPr>
+        <p:style>
+          <a:lnRef idx="2">
+            <a:schemeClr val="accent1">
+              <a:shade val="15000"/>
+            </a:schemeClr>
+          </a:lnRef>
+          <a:fillRef idx="1">
+            <a:schemeClr val="accent1"/>
+          </a:fillRef>
+          <a:effectRef idx="0">
+            <a:schemeClr val="accent1"/>
+          </a:effectRef>
+          <a:fontRef idx="minor">
+            <a:schemeClr val="lt1"/>
+          </a:fontRef>
+        </p:style>
+        <p:txBody>
+          <a:bodyPr rtlCol="0" anchor="ctr"/>
+          <a:lstStyle/>
+          <a:p>
+            <a:pPr algn="ctr"/>
+            <a:r>
+              <a:rPr lang="fr-FR" dirty="0"/>
+              <a:t>NB de jours PP/22</a:t>
+            </a:r>
+          </a:p>
+        </p:txBody>
+      </p:sp>
+      <p:sp>
+        <p:nvSpPr>
+          <p:cNvPr id="10" name="Rectangle 9">
+            <a:extLst>
+              <a:ext uri="{FF2B5EF4-FFF2-40B4-BE49-F238E27FC236}">
+                <a16:creationId xmlns:a16="http://schemas.microsoft.com/office/drawing/2014/main" id="{06AF5FCC-81CF-9BF9-D7C5-DF187F1BAA8C}"/>
+              </a:ext>
+            </a:extLst>
+          </p:cNvPr>
+          <p:cNvSpPr/>
+          <p:nvPr/>
+        </p:nvSpPr>
+        <p:spPr>
+          <a:xfrm>
+            <a:off x="157424" y="365124"/>
+            <a:ext cx="5938576" cy="3960228"/>
+          </a:xfrm>
+          <a:prstGeom prst="rect">
+            <a:avLst/>
+          </a:prstGeom>
+        </p:spPr>
+        <p:style>
+          <a:lnRef idx="2">
+            <a:schemeClr val="accent1">
+              <a:shade val="15000"/>
+            </a:schemeClr>
+          </a:lnRef>
+          <a:fillRef idx="1">
+            <a:schemeClr val="accent1"/>
+          </a:fillRef>
+          <a:effectRef idx="0">
+            <a:schemeClr val="accent1"/>
+          </a:effectRef>
+          <a:fontRef idx="minor">
+            <a:schemeClr val="lt1"/>
+          </a:fontRef>
+        </p:style>
+        <p:txBody>
+          <a:bodyPr rtlCol="0" anchor="ctr"/>
+          <a:lstStyle/>
+          <a:p>
+            <a:pPr algn="ctr"/>
+            <a:r>
+              <a:rPr lang="fr-FR" dirty="0"/>
+              <a:t>Courbe </a:t>
+            </a:r>
+            <a:r>
+              <a:rPr lang="fr-FR" dirty="0" err="1"/>
+              <a:t>spark</a:t>
+            </a:r>
+            <a:r>
+              <a:rPr lang="fr-FR" dirty="0"/>
+              <a:t> spread *3 rendements</a:t>
+            </a:r>
+          </a:p>
+          <a:p>
+            <a:pPr algn="ctr"/>
+            <a:r>
+              <a:rPr lang="fr-FR" dirty="0"/>
+              <a:t>1,8</a:t>
+            </a:r>
+          </a:p>
+          <a:p>
+            <a:pPr algn="ctr"/>
+            <a:r>
+              <a:rPr lang="fr-FR" dirty="0"/>
+              <a:t>2,2</a:t>
+            </a:r>
+          </a:p>
+          <a:p>
+            <a:pPr algn="ctr"/>
+            <a:r>
+              <a:rPr lang="fr-FR" dirty="0"/>
+              <a:t>3,2</a:t>
+            </a:r>
+          </a:p>
+        </p:txBody>
+      </p:sp>
+      <p:sp>
+        <p:nvSpPr>
+          <p:cNvPr id="12" name="Rectangle 11">
+            <a:extLst>
+              <a:ext uri="{FF2B5EF4-FFF2-40B4-BE49-F238E27FC236}">
+                <a16:creationId xmlns:a16="http://schemas.microsoft.com/office/drawing/2014/main" id="{8786F3C1-0787-E66A-848E-955B90C792F9}"/>
+              </a:ext>
+            </a:extLst>
+          </p:cNvPr>
+          <p:cNvSpPr/>
+          <p:nvPr/>
+        </p:nvSpPr>
+        <p:spPr>
+          <a:xfrm>
+            <a:off x="6297807" y="365124"/>
+            <a:ext cx="5938576" cy="3960228"/>
+          </a:xfrm>
+          <a:prstGeom prst="rect">
+            <a:avLst/>
+          </a:prstGeom>
+        </p:spPr>
+        <p:style>
+          <a:lnRef idx="2">
+            <a:schemeClr val="accent1">
+              <a:shade val="15000"/>
+            </a:schemeClr>
+          </a:lnRef>
+          <a:fillRef idx="1">
+            <a:schemeClr val="accent1"/>
+          </a:fillRef>
+          <a:effectRef idx="0">
+            <a:schemeClr val="accent1"/>
+          </a:effectRef>
+          <a:fontRef idx="minor">
+            <a:schemeClr val="lt1"/>
+          </a:fontRef>
+        </p:style>
+        <p:txBody>
+          <a:bodyPr rtlCol="0" anchor="ctr"/>
+          <a:lstStyle/>
+          <a:p>
+            <a:pPr algn="ctr"/>
+            <a:r>
+              <a:rPr lang="fr-FR" dirty="0"/>
+              <a:t>Courbe Clean </a:t>
+            </a:r>
+            <a:r>
+              <a:rPr lang="fr-FR" dirty="0" err="1"/>
+              <a:t>spark</a:t>
+            </a:r>
+            <a:r>
+              <a:rPr lang="fr-FR" dirty="0"/>
+              <a:t> spread *3 rendements</a:t>
+            </a:r>
+          </a:p>
+          <a:p>
+            <a:pPr algn="ctr"/>
+            <a:r>
+              <a:rPr lang="fr-FR" dirty="0"/>
+              <a:t>1,8</a:t>
+            </a:r>
+          </a:p>
+          <a:p>
+            <a:pPr algn="ctr"/>
+            <a:r>
+              <a:rPr lang="fr-FR" dirty="0"/>
+              <a:t>2,2</a:t>
+            </a:r>
+          </a:p>
+          <a:p>
+            <a:pPr algn="ctr"/>
+            <a:r>
+              <a:rPr lang="fr-FR" dirty="0"/>
+              <a:t>3,2</a:t>
+            </a:r>
+          </a:p>
+          <a:p>
+            <a:pPr algn="ctr"/>
+            <a:endParaRPr lang="fr-FR" dirty="0"/>
+          </a:p>
+          <a:p>
+            <a:pPr algn="ctr"/>
+            <a:r>
+              <a:rPr lang="fr-FR" dirty="0"/>
+              <a:t>+0,185*co2</a:t>
+            </a:r>
+          </a:p>
+        </p:txBody>
+      </p:sp>
+      <p:sp>
+        <p:nvSpPr>
+          <p:cNvPr id="14" name="Rectangle 13">
+            <a:extLst>
+              <a:ext uri="{FF2B5EF4-FFF2-40B4-BE49-F238E27FC236}">
+                <a16:creationId xmlns:a16="http://schemas.microsoft.com/office/drawing/2014/main" id="{816291A1-7B8E-9638-9B09-43AD346292A9}"/>
+              </a:ext>
+            </a:extLst>
+          </p:cNvPr>
+          <p:cNvSpPr/>
+          <p:nvPr/>
+        </p:nvSpPr>
+        <p:spPr>
+          <a:xfrm>
+            <a:off x="157424" y="5398921"/>
+            <a:ext cx="2803491" cy="920176"/>
+          </a:xfrm>
+          <a:prstGeom prst="rect">
+            <a:avLst/>
+          </a:prstGeom>
+          <a:solidFill>
+            <a:schemeClr val="accent2"/>
+          </a:solidFill>
+        </p:spPr>
+        <p:style>
+          <a:lnRef idx="2">
+            <a:schemeClr val="accent1">
+              <a:shade val="15000"/>
+            </a:schemeClr>
+          </a:lnRef>
+          <a:fillRef idx="1">
+            <a:schemeClr val="accent1"/>
+          </a:fillRef>
+          <a:effectRef idx="0">
+            <a:schemeClr val="accent1"/>
+          </a:effectRef>
+          <a:fontRef idx="minor">
+            <a:schemeClr val="lt1"/>
+          </a:fontRef>
+        </p:style>
+        <p:txBody>
+          <a:bodyPr rtlCol="0" anchor="ctr"/>
+          <a:lstStyle/>
+          <a:p>
+            <a:pPr algn="ctr"/>
+            <a:r>
+              <a:rPr lang="fr-FR" dirty="0"/>
+              <a:t>On est en PP</a:t>
+            </a:r>
+          </a:p>
+        </p:txBody>
+      </p:sp>
+      <p:sp>
+        <p:nvSpPr>
+          <p:cNvPr id="16" name="Espace réservé du contenu 15">
+            <a:extLst>
+              <a:ext uri="{FF2B5EF4-FFF2-40B4-BE49-F238E27FC236}">
+                <a16:creationId xmlns:a16="http://schemas.microsoft.com/office/drawing/2014/main" id="{A5CA299F-B19F-30AF-6A78-A1D1B6BFB50D}"/>
+              </a:ext>
+            </a:extLst>
+          </p:cNvPr>
+          <p:cNvSpPr>
+            <a:spLocks noGrp="1"/>
+          </p:cNvSpPr>
+          <p:nvPr>
+            <p:ph idx="1"/>
+          </p:nvPr>
+        </p:nvSpPr>
+        <p:spPr>
+          <a:xfrm>
+            <a:off x="3228169" y="4496809"/>
+            <a:ext cx="3309791" cy="1822287"/>
+          </a:xfrm>
+          <a:prstGeom prst="rect">
+            <a:avLst/>
+          </a:prstGeom>
+        </p:spPr>
+        <p:style>
+          <a:lnRef idx="2">
+            <a:schemeClr val="accent1">
+              <a:shade val="15000"/>
+            </a:schemeClr>
+          </a:lnRef>
+          <a:fillRef idx="1">
+            <a:schemeClr val="accent1"/>
+          </a:fillRef>
+          <a:effectRef idx="0">
+            <a:schemeClr val="accent1"/>
+          </a:effectRef>
+          <a:fontRef idx="minor">
+            <a:schemeClr val="lt1"/>
+          </a:fontRef>
+        </p:style>
+        <p:txBody>
+          <a:bodyPr rtlCol="0" anchor="ctr">
+            <a:normAutofit/>
+          </a:bodyPr>
+          <a:lstStyle/>
+          <a:p>
+            <a:pPr algn="ctr"/>
+            <a:r>
+              <a:rPr lang="fr-FR" dirty="0"/>
+              <a:t>MFRR hausse +baisse</a:t>
+            </a:r>
+          </a:p>
+          <a:p>
+            <a:pPr marL="0" indent="0" algn="ctr">
+              <a:buNone/>
+            </a:pPr>
+            <a:r>
+              <a:rPr lang="fr-FR" dirty="0"/>
+              <a:t>(vs la saison précédente)</a:t>
+            </a:r>
+          </a:p>
+        </p:txBody>
+      </p:sp>
+      <p:sp>
+        <p:nvSpPr>
+          <p:cNvPr id="17" name="Rectangle 16">
+            <a:extLst>
+              <a:ext uri="{FF2B5EF4-FFF2-40B4-BE49-F238E27FC236}">
+                <a16:creationId xmlns:a16="http://schemas.microsoft.com/office/drawing/2014/main" id="{95649D35-BCF5-72FD-6D49-A3333C4ADF6F}"/>
+              </a:ext>
+            </a:extLst>
+          </p:cNvPr>
+          <p:cNvSpPr/>
+          <p:nvPr/>
+        </p:nvSpPr>
+        <p:spPr>
+          <a:xfrm>
+            <a:off x="6748172" y="4446030"/>
+            <a:ext cx="1981197" cy="631547"/>
+          </a:xfrm>
+          <a:prstGeom prst="rect">
+            <a:avLst/>
+          </a:prstGeom>
+        </p:spPr>
+        <p:style>
+          <a:lnRef idx="2">
+            <a:schemeClr val="accent1">
+              <a:shade val="15000"/>
+            </a:schemeClr>
+          </a:lnRef>
+          <a:fillRef idx="1">
+            <a:schemeClr val="accent1"/>
+          </a:fillRef>
+          <a:effectRef idx="0">
+            <a:schemeClr val="accent1"/>
+          </a:effectRef>
+          <a:fontRef idx="minor">
+            <a:schemeClr val="lt1"/>
+          </a:fontRef>
+        </p:style>
+        <p:txBody>
+          <a:bodyPr rtlCol="0" anchor="ctr"/>
+          <a:lstStyle/>
+          <a:p>
+            <a:pPr algn="ctr"/>
+            <a:r>
+              <a:rPr lang="fr-FR" dirty="0"/>
+              <a:t>Peg du jour</a:t>
+            </a:r>
+          </a:p>
+          <a:p>
+            <a:pPr algn="ctr"/>
+            <a:r>
+              <a:rPr lang="fr-FR" dirty="0"/>
+              <a:t>Vs 7dernires jours</a:t>
+            </a:r>
+          </a:p>
+        </p:txBody>
+      </p:sp>
+      <p:sp>
+        <p:nvSpPr>
+          <p:cNvPr id="19" name="Rectangle 18">
+            <a:extLst>
+              <a:ext uri="{FF2B5EF4-FFF2-40B4-BE49-F238E27FC236}">
+                <a16:creationId xmlns:a16="http://schemas.microsoft.com/office/drawing/2014/main" id="{F4C3C6F4-59AA-372C-6EE9-AF9BAFB53123}"/>
+              </a:ext>
+            </a:extLst>
+          </p:cNvPr>
+          <p:cNvSpPr/>
+          <p:nvPr/>
+        </p:nvSpPr>
+        <p:spPr>
+          <a:xfrm>
+            <a:off x="9550026" y="4446030"/>
+            <a:ext cx="2315459" cy="631547"/>
+          </a:xfrm>
+          <a:prstGeom prst="rect">
+            <a:avLst/>
+          </a:prstGeom>
+        </p:spPr>
+        <p:style>
+          <a:lnRef idx="2">
+            <a:schemeClr val="accent1">
+              <a:shade val="15000"/>
+            </a:schemeClr>
+          </a:lnRef>
+          <a:fillRef idx="1">
+            <a:schemeClr val="accent1"/>
+          </a:fillRef>
+          <a:effectRef idx="0">
+            <a:schemeClr val="accent1"/>
+          </a:effectRef>
+          <a:fontRef idx="minor">
+            <a:schemeClr val="lt1"/>
+          </a:fontRef>
+        </p:style>
+        <p:txBody>
+          <a:bodyPr rtlCol="0" anchor="ctr"/>
+          <a:lstStyle/>
+          <a:p>
+            <a:pPr algn="ctr"/>
+            <a:r>
+              <a:rPr lang="fr-FR" dirty="0"/>
+              <a:t>CO2</a:t>
+            </a:r>
+          </a:p>
+          <a:p>
+            <a:pPr algn="ctr"/>
+            <a:r>
+              <a:rPr lang="fr-FR" dirty="0"/>
+              <a:t>Vs 7 derniers jours</a:t>
+            </a:r>
+          </a:p>
+        </p:txBody>
+      </p:sp>
+      <p:sp>
+        <p:nvSpPr>
+          <p:cNvPr id="20" name="Rectangle 19">
+            <a:extLst>
+              <a:ext uri="{FF2B5EF4-FFF2-40B4-BE49-F238E27FC236}">
+                <a16:creationId xmlns:a16="http://schemas.microsoft.com/office/drawing/2014/main" id="{DCD43213-6E2E-3F18-F644-103974EB4502}"/>
+              </a:ext>
+            </a:extLst>
+          </p:cNvPr>
+          <p:cNvSpPr/>
+          <p:nvPr/>
+        </p:nvSpPr>
+        <p:spPr>
+          <a:xfrm>
+            <a:off x="5453323" y="658167"/>
+            <a:ext cx="1406769" cy="1321149"/>
+          </a:xfrm>
+          <a:prstGeom prst="rect">
+            <a:avLst/>
+          </a:prstGeom>
+        </p:spPr>
+        <p:style>
+          <a:lnRef idx="2">
+            <a:schemeClr val="accent1">
+              <a:shade val="15000"/>
+            </a:schemeClr>
+          </a:lnRef>
+          <a:fillRef idx="1">
+            <a:schemeClr val="accent1"/>
+          </a:fillRef>
+          <a:effectRef idx="0">
+            <a:schemeClr val="accent1"/>
+          </a:effectRef>
+          <a:fontRef idx="minor">
+            <a:schemeClr val="lt1"/>
+          </a:fontRef>
+        </p:style>
+        <p:txBody>
+          <a:bodyPr rtlCol="0" anchor="ctr"/>
+          <a:lstStyle/>
+          <a:p>
+            <a:pPr algn="ctr"/>
+            <a:r>
+              <a:rPr lang="fr-FR" dirty="0" err="1"/>
+              <a:t>Cogé</a:t>
+            </a:r>
+            <a:r>
+              <a:rPr lang="fr-FR" dirty="0"/>
+              <a:t> serre</a:t>
+            </a:r>
+          </a:p>
+          <a:p>
+            <a:pPr algn="ctr"/>
+            <a:r>
+              <a:rPr lang="fr-FR" dirty="0"/>
+              <a:t>Base</a:t>
+            </a:r>
+          </a:p>
+          <a:p>
+            <a:pPr algn="ctr"/>
+            <a:r>
+              <a:rPr lang="fr-FR" dirty="0"/>
+              <a:t>Peak</a:t>
+            </a:r>
+          </a:p>
+          <a:p>
+            <a:pPr algn="ctr"/>
+            <a:r>
+              <a:rPr lang="fr-FR" dirty="0"/>
+              <a:t>1,8 </a:t>
+            </a:r>
+          </a:p>
+        </p:txBody>
+      </p:sp>
+      <p:sp>
+        <p:nvSpPr>
+          <p:cNvPr id="21" name="Rectangle 20">
+            <a:extLst>
+              <a:ext uri="{FF2B5EF4-FFF2-40B4-BE49-F238E27FC236}">
+                <a16:creationId xmlns:a16="http://schemas.microsoft.com/office/drawing/2014/main" id="{ED0F5393-ABA6-5D46-298B-C8EC403AD580}"/>
+              </a:ext>
+            </a:extLst>
+          </p:cNvPr>
+          <p:cNvSpPr/>
+          <p:nvPr/>
+        </p:nvSpPr>
+        <p:spPr>
+          <a:xfrm>
+            <a:off x="296425" y="222990"/>
+            <a:ext cx="2069960" cy="703385"/>
+          </a:xfrm>
+          <a:prstGeom prst="rect">
+            <a:avLst/>
+          </a:prstGeom>
+        </p:spPr>
+        <p:style>
+          <a:lnRef idx="2">
+            <a:schemeClr val="accent1">
+              <a:shade val="15000"/>
+            </a:schemeClr>
+          </a:lnRef>
+          <a:fillRef idx="1">
+            <a:schemeClr val="accent1"/>
+          </a:fillRef>
+          <a:effectRef idx="0">
+            <a:schemeClr val="accent1"/>
+          </a:effectRef>
+          <a:fontRef idx="minor">
+            <a:schemeClr val="lt1"/>
+          </a:fontRef>
+        </p:style>
+        <p:txBody>
+          <a:bodyPr rtlCol="0" anchor="ctr"/>
+          <a:lstStyle/>
+          <a:p>
+            <a:pPr algn="ctr"/>
+            <a:r>
+              <a:rPr lang="fr-FR" dirty="0"/>
+              <a:t>Choisir les rendements?</a:t>
+            </a:r>
+          </a:p>
+          <a:p>
+            <a:pPr algn="ctr"/>
+            <a:endParaRPr lang="fr-FR" dirty="0"/>
+          </a:p>
+        </p:txBody>
+      </p:sp>
+      <p:sp>
+        <p:nvSpPr>
+          <p:cNvPr id="23" name="Rectangle 22">
+            <a:extLst>
+              <a:ext uri="{FF2B5EF4-FFF2-40B4-BE49-F238E27FC236}">
+                <a16:creationId xmlns:a16="http://schemas.microsoft.com/office/drawing/2014/main" id="{6AA87551-7BE9-EDDA-0CA3-09610BF807C9}"/>
+              </a:ext>
+            </a:extLst>
+          </p:cNvPr>
+          <p:cNvSpPr/>
+          <p:nvPr/>
+        </p:nvSpPr>
+        <p:spPr>
+          <a:xfrm>
+            <a:off x="5453323" y="2262359"/>
+            <a:ext cx="1406769" cy="1166641"/>
+          </a:xfrm>
+          <a:prstGeom prst="rect">
+            <a:avLst/>
+          </a:prstGeom>
+        </p:spPr>
+        <p:style>
+          <a:lnRef idx="2">
+            <a:schemeClr val="accent1">
+              <a:shade val="15000"/>
+            </a:schemeClr>
+          </a:lnRef>
+          <a:fillRef idx="1">
+            <a:schemeClr val="accent1"/>
+          </a:fillRef>
+          <a:effectRef idx="0">
+            <a:schemeClr val="accent1"/>
+          </a:effectRef>
+          <a:fontRef idx="minor">
+            <a:schemeClr val="lt1"/>
+          </a:fontRef>
+        </p:style>
+        <p:txBody>
+          <a:bodyPr rtlCol="0" anchor="ctr"/>
+          <a:lstStyle/>
+          <a:p>
+            <a:pPr algn="ctr"/>
+            <a:r>
+              <a:rPr lang="fr-FR" dirty="0" err="1"/>
+              <a:t>Cogé</a:t>
+            </a:r>
+            <a:r>
+              <a:rPr lang="fr-FR" dirty="0"/>
+              <a:t> indus</a:t>
+            </a:r>
+          </a:p>
+          <a:p>
+            <a:pPr algn="ctr"/>
+            <a:r>
+              <a:rPr lang="fr-FR" dirty="0"/>
+              <a:t>Base</a:t>
+            </a:r>
+          </a:p>
+          <a:p>
+            <a:pPr algn="ctr"/>
+            <a:r>
+              <a:rPr lang="fr-FR" dirty="0"/>
+              <a:t>Peak </a:t>
+            </a:r>
+          </a:p>
+          <a:p>
+            <a:pPr algn="ctr"/>
+            <a:r>
+              <a:rPr lang="fr-FR" dirty="0"/>
+              <a:t>2,2</a:t>
+            </a:r>
+          </a:p>
+        </p:txBody>
+      </p:sp>
+      <p:sp>
+        <p:nvSpPr>
+          <p:cNvPr id="24" name="Rectangle 23">
+            <a:extLst>
+              <a:ext uri="{FF2B5EF4-FFF2-40B4-BE49-F238E27FC236}">
+                <a16:creationId xmlns:a16="http://schemas.microsoft.com/office/drawing/2014/main" id="{2AE4F717-A388-4800-26AD-405D6E5025B4}"/>
+              </a:ext>
+            </a:extLst>
+          </p:cNvPr>
+          <p:cNvSpPr/>
+          <p:nvPr/>
+        </p:nvSpPr>
+        <p:spPr>
+          <a:xfrm>
+            <a:off x="6748172" y="5198257"/>
+            <a:ext cx="5117313" cy="699624"/>
+          </a:xfrm>
+          <a:prstGeom prst="rect">
+            <a:avLst/>
+          </a:prstGeom>
+        </p:spPr>
+        <p:style>
+          <a:lnRef idx="2">
+            <a:schemeClr val="accent1">
+              <a:shade val="15000"/>
+            </a:schemeClr>
+          </a:lnRef>
+          <a:fillRef idx="1">
+            <a:schemeClr val="accent1"/>
+          </a:fillRef>
+          <a:effectRef idx="0">
+            <a:schemeClr val="accent1"/>
+          </a:effectRef>
+          <a:fontRef idx="minor">
+            <a:schemeClr val="lt1"/>
+          </a:fontRef>
+        </p:style>
+        <p:txBody>
+          <a:bodyPr rtlCol="0" anchor="ctr"/>
+          <a:lstStyle/>
+          <a:p>
+            <a:pPr algn="ctr"/>
+            <a:r>
+              <a:rPr lang="fr-FR" dirty="0"/>
+              <a:t>Base </a:t>
+            </a:r>
+            <a:r>
+              <a:rPr lang="fr-FR" dirty="0" err="1"/>
+              <a:t>peak</a:t>
+            </a:r>
+            <a:r>
+              <a:rPr lang="fr-FR" dirty="0"/>
+              <a:t> M+1 M+2 Q+1 serre</a:t>
+            </a:r>
+          </a:p>
+        </p:txBody>
+      </p:sp>
+      <p:sp>
+        <p:nvSpPr>
+          <p:cNvPr id="26" name="Rectangle 25">
+            <a:extLst>
+              <a:ext uri="{FF2B5EF4-FFF2-40B4-BE49-F238E27FC236}">
+                <a16:creationId xmlns:a16="http://schemas.microsoft.com/office/drawing/2014/main" id="{D9FEA2F4-9AF2-0D71-DD0A-AAECC0EF8922}"/>
+              </a:ext>
+            </a:extLst>
+          </p:cNvPr>
+          <p:cNvSpPr/>
+          <p:nvPr/>
+        </p:nvSpPr>
+        <p:spPr>
+          <a:xfrm>
+            <a:off x="6748172" y="5950483"/>
+            <a:ext cx="5117313" cy="699624"/>
+          </a:xfrm>
+          <a:prstGeom prst="rect">
+            <a:avLst/>
+          </a:prstGeom>
+        </p:spPr>
+        <p:style>
+          <a:lnRef idx="2">
+            <a:schemeClr val="accent1">
+              <a:shade val="15000"/>
+            </a:schemeClr>
+          </a:lnRef>
+          <a:fillRef idx="1">
+            <a:schemeClr val="accent1"/>
+          </a:fillRef>
+          <a:effectRef idx="0">
+            <a:schemeClr val="accent1"/>
+          </a:effectRef>
+          <a:fontRef idx="minor">
+            <a:schemeClr val="lt1"/>
+          </a:fontRef>
+        </p:style>
+        <p:txBody>
+          <a:bodyPr rtlCol="0" anchor="ctr"/>
+          <a:lstStyle/>
+          <a:p>
+            <a:pPr algn="ctr"/>
+            <a:r>
+              <a:rPr lang="fr-FR" dirty="0"/>
+              <a:t>Base </a:t>
+            </a:r>
+            <a:r>
+              <a:rPr lang="fr-FR" dirty="0" err="1"/>
+              <a:t>peak</a:t>
+            </a:r>
+            <a:r>
+              <a:rPr lang="fr-FR" dirty="0"/>
+              <a:t> M+1 M+2 Q+1 indus</a:t>
+            </a:r>
+          </a:p>
+        </p:txBody>
+      </p:sp>
+    </p:spTree>
+    <p:extLst>
+      <p:ext uri="{BB962C8B-B14F-4D97-AF65-F5344CB8AC3E}">
+        <p14:creationId xmlns:p14="http://schemas.microsoft.com/office/powerpoint/2010/main" val="3235114641"/>
+      </p:ext>
+    </p:extLst>
+  </p:cSld>
+  <p:clrMapOvr>
+    <a:masterClrMapping/>
+  </p:clrMapOvr>
+</p:sld>
+</file>
+
+<file path=ppt/slides/slide6.xml><?xml version="1.0" encoding="utf-8"?>
+<p:sld xmlns:a="http://schemas.openxmlformats.org/drawingml/2006/main" xmlns:r="http://schemas.openxmlformats.org/officeDocument/2006/relationships" xmlns:p="http://schemas.openxmlformats.org/presentationml/2006/main">
+  <p:cSld>
+    <p:spTree>
+      <p:nvGrpSpPr>
+        <p:cNvPr id="1" name=""/>
+        <p:cNvGrpSpPr/>
+        <p:nvPr/>
+      </p:nvGrpSpPr>
+      <p:grpSpPr>
+        <a:xfrm>
+          <a:off x="0" y="0"/>
+          <a:ext cx="0" cy="0"/>
+          <a:chOff x="0" y="0"/>
+          <a:chExt cx="0" cy="0"/>
+        </a:xfrm>
+      </p:grpSpPr>
+      <p:sp>
+        <p:nvSpPr>
+          <p:cNvPr id="2" name="Titre 1">
+            <a:extLst>
+              <a:ext uri="{FF2B5EF4-FFF2-40B4-BE49-F238E27FC236}">
                 <a16:creationId xmlns:a16="http://schemas.microsoft.com/office/drawing/2014/main" id="{4CEDA65A-F7D8-95D0-31F3-01098CB458E2}"/>
               </a:ext>
             </a:extLst>
@@ -7235,7 +7360,7 @@
 </p:sld>
 </file>
 
-<file path=ppt/slides/slide6.xml><?xml version="1.0" encoding="utf-8"?>
+<file path=ppt/slides/slide7.xml><?xml version="1.0" encoding="utf-8"?>
 <p:sld xmlns:a="http://schemas.openxmlformats.org/drawingml/2006/main" xmlns:r="http://schemas.openxmlformats.org/officeDocument/2006/relationships" xmlns:p="http://schemas.openxmlformats.org/presentationml/2006/main">
   <p:cSld>
     <p:spTree>
@@ -8363,7 +8488,7 @@
 </p:sld>
 </file>
 
-<file path=ppt/slides/slide7.xml><?xml version="1.0" encoding="utf-8"?>
+<file path=ppt/slides/slide8.xml><?xml version="1.0" encoding="utf-8"?>
 <p:sld xmlns:a="http://schemas.openxmlformats.org/drawingml/2006/main" xmlns:r="http://schemas.openxmlformats.org/officeDocument/2006/relationships" xmlns:p="http://schemas.openxmlformats.org/presentationml/2006/main">
   <p:cSld>
     <p:spTree>

</xml_diff>